<commit_message>
Refresh presentation with current models and research limits
</commit_message>
<xml_diff>
--- a/Deliverables/RoadScan-Presentation.pptx
+++ b/Deliverables/RoadScan-Presentation.pptx
@@ -2,23 +2,24 @@
 <file path=ppt/presentation.xml><?xml version="1.0" encoding="utf-8"?>
 <p:presentation xmlns:p="http://schemas.openxmlformats.org/presentationml/2006/main">
   <p:sldMasterIdLst>
-    <p:sldMasterId xmlns:r="http://schemas.openxmlformats.org/officeDocument/2006/relationships" id="2147483648" r:id="R3e829d087e6a4701"/>
+    <p:sldMasterId xmlns:r="http://schemas.openxmlformats.org/officeDocument/2006/relationships" id="2147483648" r:id="R32f43f6ee00349f9"/>
   </p:sldMasterIdLst>
   <p:notesMasterIdLst>
-    <p:notesMasterId xmlns:r="http://schemas.openxmlformats.org/officeDocument/2006/relationships" r:id="Raf88a234308545d0"/>
+    <p:notesMasterId xmlns:r="http://schemas.openxmlformats.org/officeDocument/2006/relationships" r:id="R47a977f033424d6e"/>
   </p:notesMasterIdLst>
   <p:sldIdLst>
-    <p:sldId xmlns:r="http://schemas.openxmlformats.org/officeDocument/2006/relationships" id="256" r:id="R6db52b3fcd424fa7"/>
-    <p:sldId xmlns:r="http://schemas.openxmlformats.org/officeDocument/2006/relationships" id="257" r:id="R5f41bb116d494a0d"/>
-    <p:sldId xmlns:r="http://schemas.openxmlformats.org/officeDocument/2006/relationships" id="258" r:id="R8935709f9f634f36"/>
-    <p:sldId xmlns:r="http://schemas.openxmlformats.org/officeDocument/2006/relationships" id="259" r:id="R6ffe680bf42648ef"/>
-    <p:sldId xmlns:r="http://schemas.openxmlformats.org/officeDocument/2006/relationships" id="260" r:id="R2e4953c4e8e544c4"/>
-    <p:sldId xmlns:r="http://schemas.openxmlformats.org/officeDocument/2006/relationships" id="261" r:id="R812adc630cf34dd5"/>
-    <p:sldId xmlns:r="http://schemas.openxmlformats.org/officeDocument/2006/relationships" id="262" r:id="Rd3a328ce4e7a454b"/>
-    <p:sldId xmlns:r="http://schemas.openxmlformats.org/officeDocument/2006/relationships" id="263" r:id="Rce7690538d7e4af3"/>
-    <p:sldId xmlns:r="http://schemas.openxmlformats.org/officeDocument/2006/relationships" id="264" r:id="R0a62cf1264254a1d"/>
-    <p:sldId xmlns:r="http://schemas.openxmlformats.org/officeDocument/2006/relationships" id="265" r:id="R15617c8fb74a4d1c"/>
-    <p:sldId xmlns:r="http://schemas.openxmlformats.org/officeDocument/2006/relationships" id="266" r:id="R5c0dcf9f3cd14aea"/>
+    <p:sldId xmlns:r="http://schemas.openxmlformats.org/officeDocument/2006/relationships" id="256" r:id="R820c97ee408247df"/>
+    <p:sldId xmlns:r="http://schemas.openxmlformats.org/officeDocument/2006/relationships" id="257" r:id="R5fa5047ade144ebb"/>
+    <p:sldId xmlns:r="http://schemas.openxmlformats.org/officeDocument/2006/relationships" id="258" r:id="R2561982fd45049a9"/>
+    <p:sldId xmlns:r="http://schemas.openxmlformats.org/officeDocument/2006/relationships" id="259" r:id="R7d2764d3dbdc4232"/>
+    <p:sldId xmlns:r="http://schemas.openxmlformats.org/officeDocument/2006/relationships" id="260" r:id="R20db0bf9c53c4f95"/>
+    <p:sldId xmlns:r="http://schemas.openxmlformats.org/officeDocument/2006/relationships" id="261" r:id="Rbfd1d32fec874f21"/>
+    <p:sldId xmlns:r="http://schemas.openxmlformats.org/officeDocument/2006/relationships" id="262" r:id="R65ee069c06554418"/>
+    <p:sldId xmlns:r="http://schemas.openxmlformats.org/officeDocument/2006/relationships" id="263" r:id="R54e7c429fa824a91"/>
+    <p:sldId xmlns:r="http://schemas.openxmlformats.org/officeDocument/2006/relationships" id="264" r:id="R3f8562d8b3c44826"/>
+    <p:sldId xmlns:r="http://schemas.openxmlformats.org/officeDocument/2006/relationships" id="265" r:id="R3327c8cc1d894130"/>
+    <p:sldId xmlns:r="http://schemas.openxmlformats.org/officeDocument/2006/relationships" id="266" r:id="R338991c758e14b03"/>
+    <p:sldId xmlns:r="http://schemas.openxmlformats.org/officeDocument/2006/relationships" id="267" r:id="R12762d8933024f5c"/>
   </p:sldIdLst>
   <p:sldSz cx="12192000" cy="6858000"/>
   <p:notesSz cx="6858000" cy="9144000"/>
@@ -552,7 +553,7 @@
           </a:p>
           <a:p xmlns:a="http://schemas.openxmlformats.org/drawingml/2006/main">
             <a:r>
-              <a:t>The repository README contains the setup commands. Keep the local token private and retain the Docker data volume to preserve reports. Import trusted model files through Settings, then verify the Active label before testing. A road detector is required for road-damage boxes. The public baseline checkpoint and its license/source packet are on the model-resources release. Physical drone integration and Mac/ARM setup have not been verified.</a:t>
+              <a:t>The repository README contains the setup commands. Keep the local token private and retain the Docker data volume to preserve reports. Import trusted model files through Settings, then verify the Active label before testing. A road detector is required for road-damage boxes. The baseline, seven RunPod detectors and three experimental road fine-tunes have downloadable weights and source companions on the model-resources release. Rename fine-tune files to their documented distinct labels before fresh imports. Full fresh-machine download-to-inference acceptance remains unverified. Physical drone integration and Mac/ARM setup have not been verified.</a:t>
             </a:r>
           </a:p>
           <a:p xmlns:a="http://schemas.openxmlformats.org/drawingml/2006/main">
@@ -653,6 +654,96 @@
           <a:p xmlns:a="http://schemas.openxmlformats.org/drawingml/2006/main">
             <a:r>
               <a:t>Sources: Deliverables/For-Examiners.md; Model-Report.md; Validation-Status.md; cleared screenshot assets. No claimed drone flight or measured Saudi-road performance.</a:t>
+            </a:r>
+          </a:p>
+        </p:txBody>
+      </p:sp>
+      <p:sp>
+        <p:nvSpPr>
+          <p:cNvPr id="4" name="Slide Number Placeholder 3"/>
+          <p:cNvSpPr>
+            <a:spLocks xmlns:a="http://schemas.openxmlformats.org/drawingml/2006/main" noGrp="1"/>
+          </p:cNvSpPr>
+          <p:nvPr>
+            <p:ph type="sldNum" idx="5"/>
+          </p:nvPr>
+        </p:nvSpPr>
+        <p:spPr/>
+        <p:txBody>
+          <a:bodyPr xmlns:a="http://schemas.openxmlformats.org/drawingml/2006/main"/>
+          <a:lstStyle xmlns:a="http://schemas.openxmlformats.org/drawingml/2006/main"/>
+          <a:p xmlns:a="http://schemas.openxmlformats.org/drawingml/2006/main"/>
+        </p:txBody>
+      </p:sp>
+    </p:spTree>
+  </p:cSld>
+  <p:clrMapOvr>
+    <a:masterClrMapping xmlns:a="http://schemas.openxmlformats.org/drawingml/2006/main"/>
+  </p:clrMapOvr>
+</p:notes>
+</file>
+
+<file path=ppt/notesSlides/notesSlide12.xml><?xml version="1.0" encoding="utf-8"?>
+<p:notes xmlns:p="http://schemas.openxmlformats.org/presentationml/2006/main">
+  <p:cSld>
+    <p:spTree>
+      <p:nvGrpSpPr>
+        <p:cNvPr id="1" name=""/>
+        <p:cNvGrpSpPr/>
+        <p:nvPr/>
+      </p:nvGrpSpPr>
+      <p:grpSpPr>
+        <a:xfrm xmlns:a="http://schemas.openxmlformats.org/drawingml/2006/main"/>
+      </p:grpSpPr>
+      <p:sp>
+        <p:nvSpPr>
+          <p:cNvPr id="2" name="Slide Image Placeholder 1"/>
+          <p:cNvSpPr>
+            <a:spLocks xmlns:a="http://schemas.openxmlformats.org/drawingml/2006/main" noGrp="1"/>
+          </p:cNvSpPr>
+          <p:nvPr>
+            <p:ph type="sldImg" idx="0"/>
+          </p:nvPr>
+        </p:nvSpPr>
+        <p:spPr/>
+      </p:sp>
+      <p:sp>
+        <p:nvSpPr>
+          <p:cNvPr id="3" name="Notes Placeholder 2"/>
+          <p:cNvSpPr>
+            <a:spLocks xmlns:a="http://schemas.openxmlformats.org/drawingml/2006/main" noGrp="1"/>
+          </p:cNvSpPr>
+          <p:nvPr>
+            <p:ph type="body" idx="1"/>
+          </p:nvPr>
+        </p:nvSpPr>
+        <p:spPr/>
+        <p:txBody>
+          <a:bodyPr xmlns:a="http://schemas.openxmlformats.org/drawingml/2006/main"/>
+          <a:lstStyle xmlns:a="http://schemas.openxmlformats.org/drawingml/2006/main"/>
+          <a:p xmlns:a="http://schemas.openxmlformats.org/drawingml/2006/main">
+            <a:r>
+              <a:t>Appendix, outside the five-minute talk.</a:t>
+            </a:r>
+          </a:p>
+          <a:p xmlns:a="http://schemas.openxmlformats.org/drawingml/2006/main">
+            <a:r>
+              <a:t/>
+            </a:r>
+          </a:p>
+          <a:p xmlns:a="http://schemas.openxmlformats.org/drawingml/2006/main">
+            <a:r>
+              <a:t>This appendix maps the supplied experiments to the project brief. E1 compares image classification with detection, which requires different metrics. E2 studies detector size and resolution. E3 includes augmentation ablations. E4 studies country shift and later road adaptation, but reported near-duplicate leakage and shared-video selection prevent independent field-accuracy claims. E5 compares duplicate representations in simulations. The replacement DINOv2 and FAISS matcher exists, but real same-damage and different-damage pairs still need calibration and evaluation. Collect forty to eighty labeled local test photos without adding them to training. Suggested speaking handoff: Feras presents slides one and two, Ahmed Salamah three and four, and Ahmed Alhejaili five through seven. This is a suggested presentation rotation, not an attribution of individual implementation work.</a:t>
+            </a:r>
+          </a:p>
+          <a:p xmlns:a="http://schemas.openxmlformats.org/drawingml/2006/main">
+            <a:r>
+              <a:t/>
+            </a:r>
+          </a:p>
+          <a:p xmlns:a="http://schemas.openxmlformats.org/drawingml/2006/main">
+            <a:r>
+              <a:t>Sources: Deliverables/Submission-Audit-2026-10-30.md; RoadScan-Project-Report.pdf sections E1 through E5; Model-Release-Matrix-2026-10-30.md; OLO AIEP Track A brief. Trainer evidence clarifies the ResNet18 initializer as IMAGENET1K_V1; publication terms and original run reproduction remain separate unresolved issues.</a:t>
             </a:r>
           </a:p>
         </p:txBody>
@@ -1182,7 +1273,7 @@
           </a:p>
           <a:p xmlns:a="http://schemas.openxmlformats.org/drawingml/2006/main">
             <a:r>
-              <a:t>The recorded release checks passed two hundred twenty-one backend tests, twenty-four frontend tests and sixty-seven browser checks. One optional backend test was skipped. These establish software behavior, not detection accuracy. Our delivery includes source code, reports, guides and a published baseline checkpoint with its scoped source license. The remaining research work is concrete: collect labeled Saudi road images and real repeated-damage pairs, repair data leakage, compare models on the same test and measure camera latency on representative hardware. RoadScan provides a working, inspectable foundation for that work, with human review central to the workflow.</a:t>
+              <a:t>The recorded release checks passed two hundred twenty-one backend tests, twenty-four frontend tests and sixty-seven browser checks. One optional backend test was skipped. These establish software behavior, not detection accuracy. Our delivery includes source code, reports, guides and eleven published road detectors, DINOv2 and their source or license companions. The remaining research work is concrete: collect labeled Saudi road images and real repeated-damage pairs, repair data leakage, compare models on the same test and measure camera latency on representative hardware. RoadScan provides a working, inspectable foundation for that work, with human review central to the workflow.</a:t>
             </a:r>
           </a:p>
           <a:p xmlns:a="http://schemas.openxmlformats.org/drawingml/2006/main">
@@ -1272,7 +1363,7 @@
           </a:p>
           <a:p xmlns:a="http://schemas.openxmlformats.org/drawingml/2006/main">
             <a:r>
-              <a:t>All nineteen unique weight files are indexed by SHA-256 in the model report. Sixteen are road detectors. The ResNet18 classifier predicts image-level labels, the stock COCO checkpoint is an initializer, and DINOv2 supports optional visual similarity. These roles have different evaluation metrics. The released baseline is road-trained. DINOv2 availability does not replace a detector.</a:t>
+              <a:t>The current matrix records twenty-two unique local weight files, including nineteen road detectors. Eleven road detectors and DINOv2 are downloadable from our release. The stock COCO initializer links upstream. Eight older detectors and the ResNet18 classifier remain on individual publication holds. Road v1, Road A and Road v2b are experimental. Their shared-video selection evidence is not an independent test, and the Main model remains the default. Two additional filenames named by the trainer have not been located and are excluded from this inventory. Published downloads passed anonymous full-SHA256 and size verification. These integrity checks do not establish model accuracy.</a:t>
             </a:r>
           </a:p>
           <a:p xmlns:a="http://schemas.openxmlformats.org/drawingml/2006/main">
@@ -1282,7 +1373,7 @@
           </a:p>
           <a:p xmlns:a="http://schemas.openxmlformats.org/drawingml/2006/main">
             <a:r>
-              <a:t>Sources: Deliverables/Model-Inventory.json; Model-Report.md; Baseline-Publication-Verification.json and Model-Release-Verification.json.</a:t>
+              <a:t>Sources: Deliverables/Model-Release-Matrix-2026-10-30.md, updated 31 October; Trainer-Provenance-2026-10-31.md; Trainer-Byte-Reconciliation-2026-10-31.json; model-resources-2026-10-28 release. Inventory and publication status as of 31 October 2026.</a:t>
             </a:r>
           </a:p>
         </p:txBody>
@@ -1419,7 +1510,7 @@
           <p:cNvPr id="3" name="Title">
             <a:extLst xmlns:a="http://schemas.openxmlformats.org/drawingml/2006/main">
               <a:ext uri="{FF2B5EF4-FFF2-40B4-BE49-F238E27FC236}">
-                <a16:creationId xmlns:a16="http://schemas.microsoft.com/office/drawing/2014/main" id="{7A3E5E2C-4303-4C58-B2D0-5F015CE82C0E}"/>
+                <a16:creationId xmlns:a16="http://schemas.microsoft.com/office/drawing/2014/main" id="{F752914C-0A9C-4F4B-A195-C8548CE1811C}"/>
               </a:ext>
             </a:extLst>
           </p:cNvPr>
@@ -1648,7 +1739,7 @@
           <p:cNvPr id="2" name="Subtitle">
             <a:extLst xmlns:a="http://schemas.openxmlformats.org/drawingml/2006/main">
               <a:ext uri="{FF2B5EF4-FFF2-40B4-BE49-F238E27FC236}">
-                <a16:creationId xmlns:a16="http://schemas.microsoft.com/office/drawing/2014/main" id="{D8942F1D-D2B8-460A-85C5-A00C4C62704A}"/>
+                <a16:creationId xmlns:a16="http://schemas.microsoft.com/office/drawing/2014/main" id="{8C9AF849-252A-44EF-9B83-EA53399220F7}"/>
               </a:ext>
             </a:extLst>
           </p:cNvPr>
@@ -1894,7 +1985,7 @@
           <p:cNvPr id="2" name="Section title">
             <a:extLst xmlns:a="http://schemas.openxmlformats.org/drawingml/2006/main">
               <a:ext uri="{FF2B5EF4-FFF2-40B4-BE49-F238E27FC236}">
-                <a16:creationId xmlns:a16="http://schemas.microsoft.com/office/drawing/2014/main" id="{5839F1B3-A22D-44D2-B4CC-3CB79CCAB3A7}"/>
+                <a16:creationId xmlns:a16="http://schemas.microsoft.com/office/drawing/2014/main" id="{82D5E25B-1607-4EEB-8AA6-3A91B22394BC}"/>
               </a:ext>
             </a:extLst>
           </p:cNvPr>
@@ -2140,7 +2231,7 @@
           <p:cNvPr id="3" name="Title">
             <a:extLst xmlns:a="http://schemas.openxmlformats.org/drawingml/2006/main">
               <a:ext uri="{FF2B5EF4-FFF2-40B4-BE49-F238E27FC236}">
-                <a16:creationId xmlns:a16="http://schemas.microsoft.com/office/drawing/2014/main" id="{837132FF-C11B-4D56-9081-E67BB7CF52DE}"/>
+                <a16:creationId xmlns:a16="http://schemas.microsoft.com/office/drawing/2014/main" id="{01FBB941-98A5-416C-88E8-707F52F43BA1}"/>
               </a:ext>
             </a:extLst>
           </p:cNvPr>
@@ -2369,7 +2460,7 @@
           <p:cNvPr id="2" name="Body">
             <a:extLst xmlns:a="http://schemas.openxmlformats.org/drawingml/2006/main">
               <a:ext uri="{FF2B5EF4-FFF2-40B4-BE49-F238E27FC236}">
-                <a16:creationId xmlns:a16="http://schemas.microsoft.com/office/drawing/2014/main" id="{DAAB11F2-51AC-44C4-AA6A-7C2B7CF88673}"/>
+                <a16:creationId xmlns:a16="http://schemas.microsoft.com/office/drawing/2014/main" id="{2EC918AE-3DF0-4451-A74E-320604C60445}"/>
               </a:ext>
             </a:extLst>
           </p:cNvPr>
@@ -2615,7 +2706,7 @@
           <p:cNvPr id="4" name="Title">
             <a:extLst xmlns:a="http://schemas.openxmlformats.org/drawingml/2006/main">
               <a:ext uri="{FF2B5EF4-FFF2-40B4-BE49-F238E27FC236}">
-                <a16:creationId xmlns:a16="http://schemas.microsoft.com/office/drawing/2014/main" id="{7545139B-2CB5-42AC-9BF1-A32520FB512C}"/>
+                <a16:creationId xmlns:a16="http://schemas.microsoft.com/office/drawing/2014/main" id="{7D448903-04D9-4F5B-ABDF-48EBBD25C7FB}"/>
               </a:ext>
             </a:extLst>
           </p:cNvPr>
@@ -2844,7 +2935,7 @@
           <p:cNvPr id="2" name="Left column">
             <a:extLst xmlns:a="http://schemas.openxmlformats.org/drawingml/2006/main">
               <a:ext uri="{FF2B5EF4-FFF2-40B4-BE49-F238E27FC236}">
-                <a16:creationId xmlns:a16="http://schemas.microsoft.com/office/drawing/2014/main" id="{19E12C0A-B59C-457D-A088-91B2F312FA8E}"/>
+                <a16:creationId xmlns:a16="http://schemas.microsoft.com/office/drawing/2014/main" id="{274958DA-1749-4D7E-A8F2-9AC906F00FF5}"/>
               </a:ext>
             </a:extLst>
           </p:cNvPr>
@@ -3073,7 +3164,7 @@
           <p:cNvPr id="3" name="Right column">
             <a:extLst xmlns:a="http://schemas.openxmlformats.org/drawingml/2006/main">
               <a:ext uri="{FF2B5EF4-FFF2-40B4-BE49-F238E27FC236}">
-                <a16:creationId xmlns:a16="http://schemas.microsoft.com/office/drawing/2014/main" id="{3E6D6550-4BE5-4B40-B731-7AA703D3FC2D}"/>
+                <a16:creationId xmlns:a16="http://schemas.microsoft.com/office/drawing/2014/main" id="{5486064F-B803-4DDA-ACD0-5B83A827EF64}"/>
               </a:ext>
             </a:extLst>
           </p:cNvPr>
@@ -3319,7 +3410,7 @@
           <p:cNvPr id="3" name="Title">
             <a:extLst xmlns:a="http://schemas.openxmlformats.org/drawingml/2006/main">
               <a:ext uri="{FF2B5EF4-FFF2-40B4-BE49-F238E27FC236}">
-                <a16:creationId xmlns:a16="http://schemas.microsoft.com/office/drawing/2014/main" id="{EC8FAA8A-97AE-4D54-BDEE-636017CAA7D8}"/>
+                <a16:creationId xmlns:a16="http://schemas.microsoft.com/office/drawing/2014/main" id="{AD52CAE7-8256-47B5-894C-AC99C51456E8}"/>
               </a:ext>
             </a:extLst>
           </p:cNvPr>
@@ -3548,7 +3639,7 @@
           <p:cNvPr id="2" name="Left column">
             <a:extLst xmlns:a="http://schemas.openxmlformats.org/drawingml/2006/main">
               <a:ext uri="{FF2B5EF4-FFF2-40B4-BE49-F238E27FC236}">
-                <a16:creationId xmlns:a16="http://schemas.microsoft.com/office/drawing/2014/main" id="{B1A55A39-1796-453F-A037-29B75736B6AE}"/>
+                <a16:creationId xmlns:a16="http://schemas.microsoft.com/office/drawing/2014/main" id="{46ECEA9D-022D-4471-A5A3-21D9B2502CD8}"/>
               </a:ext>
             </a:extLst>
           </p:cNvPr>
@@ -3815,12 +3906,12 @@
   </p:cSld>
   <p:clrMap bg1="lt1" tx1="dk1" bg2="lt2" tx2="dk2" accent1="accent1" accent2="accent2" accent3="accent3" accent4="accent4" accent5="accent5" accent6="accent6" hlink="hlink" folHlink="folHlink"/>
   <p:sldLayoutIdLst>
-    <p:sldLayoutId xmlns:r="http://schemas.openxmlformats.org/officeDocument/2006/relationships" id="2147483649" r:id="Rbb1fadf73b884eef"/>
-    <p:sldLayoutId xmlns:r="http://schemas.openxmlformats.org/officeDocument/2006/relationships" id="2147483650" r:id="R99351937b941486f"/>
-    <p:sldLayoutId xmlns:r="http://schemas.openxmlformats.org/officeDocument/2006/relationships" id="2147483651" r:id="R3b130c87219f4201"/>
-    <p:sldLayoutId xmlns:r="http://schemas.openxmlformats.org/officeDocument/2006/relationships" id="2147483652" r:id="R3156dbb8ab7940b1"/>
-    <p:sldLayoutId xmlns:r="http://schemas.openxmlformats.org/officeDocument/2006/relationships" id="2147483653" r:id="R05c7bd29dbc64d77"/>
-    <p:sldLayoutId xmlns:r="http://schemas.openxmlformats.org/officeDocument/2006/relationships" id="2147483654" r:id="R69a6d5c510ed4865"/>
+    <p:sldLayoutId xmlns:r="http://schemas.openxmlformats.org/officeDocument/2006/relationships" id="2147483649" r:id="R08a971db90794dfe"/>
+    <p:sldLayoutId xmlns:r="http://schemas.openxmlformats.org/officeDocument/2006/relationships" id="2147483650" r:id="R403fc5c5bf8048fc"/>
+    <p:sldLayoutId xmlns:r="http://schemas.openxmlformats.org/officeDocument/2006/relationships" id="2147483651" r:id="Rd6c5d3264a1f451f"/>
+    <p:sldLayoutId xmlns:r="http://schemas.openxmlformats.org/officeDocument/2006/relationships" id="2147483652" r:id="Re92f0aefdb564229"/>
+    <p:sldLayoutId xmlns:r="http://schemas.openxmlformats.org/officeDocument/2006/relationships" id="2147483653" r:id="Rdbbb5289f6d34da2"/>
+    <p:sldLayoutId xmlns:r="http://schemas.openxmlformats.org/officeDocument/2006/relationships" id="2147483654" r:id="Rddc1637dc88b4987"/>
   </p:sldLayoutIdLst>
   <p:txStyles>
     <p:titleStyle>
@@ -4371,7 +4462,7 @@
           <p:cNvPr id="10" name="ROAD DAMAGE INSPECTION">
             <a:extLst xmlns:a="http://schemas.openxmlformats.org/drawingml/2006/main">
               <a:ext uri="{FF2B5EF4-FFF2-40B4-BE49-F238E27FC236}">
-                <a16:creationId xmlns:a16="http://schemas.microsoft.com/office/drawing/2014/main" id="{F8FF31F7-5614-46DB-8D58-CD7E2EEC63CA}"/>
+                <a16:creationId xmlns:a16="http://schemas.microsoft.com/office/drawing/2014/main" id="{2D2222A0-19E3-4E79-B800-CFB77291AEA2}"/>
               </a:ext>
             </a:extLst>
           </p:cNvPr>
@@ -4527,7 +4618,7 @@
           <p:cNvPr id="2" name="RoadScan">
             <a:extLst xmlns:a="http://schemas.openxmlformats.org/drawingml/2006/main">
               <a:ext uri="{FF2B5EF4-FFF2-40B4-BE49-F238E27FC236}">
-                <a16:creationId xmlns:a16="http://schemas.microsoft.com/office/drawing/2014/main" id="{9BE8D1E4-F7A0-469F-B776-5E8190140509}"/>
+                <a16:creationId xmlns:a16="http://schemas.microsoft.com/office/drawing/2014/main" id="{037F9458-9B87-448B-BBED-52965B341212}"/>
               </a:ext>
             </a:extLst>
           </p:cNvPr>
@@ -4683,7 +4774,7 @@
           <p:cNvPr id="3" name="RoadScan / AIEP capstone">
             <a:extLst xmlns:a="http://schemas.openxmlformats.org/drawingml/2006/main">
               <a:ext uri="{FF2B5EF4-FFF2-40B4-BE49-F238E27FC236}">
-                <a16:creationId xmlns:a16="http://schemas.microsoft.com/office/drawing/2014/main" id="{E62428C8-5B3C-49A6-B6FC-233A2D132276}"/>
+                <a16:creationId xmlns:a16="http://schemas.microsoft.com/office/drawing/2014/main" id="{8EFDEB3F-23B2-49F0-9BE0-B2BE00CED196}"/>
               </a:ext>
             </a:extLst>
           </p:cNvPr>
@@ -4839,7 +4930,7 @@
           <p:cNvPr id="4" name="01">
             <a:extLst xmlns:a="http://schemas.openxmlformats.org/drawingml/2006/main">
               <a:ext uri="{FF2B5EF4-FFF2-40B4-BE49-F238E27FC236}">
-                <a16:creationId xmlns:a16="http://schemas.microsoft.com/office/drawing/2014/main" id="{6CE1596A-D05A-4AF7-9B60-EDEC40E1F3BA}"/>
+                <a16:creationId xmlns:a16="http://schemas.microsoft.com/office/drawing/2014/main" id="{855040E6-6A93-426F-BEC8-D554518150E8}"/>
               </a:ext>
             </a:extLst>
           </p:cNvPr>
@@ -4995,7 +5086,7 @@
           <p:cNvPr id="5" name="Human-reviewed&#10;road intelligence">
             <a:extLst xmlns:a="http://schemas.openxmlformats.org/drawingml/2006/main">
               <a:ext uri="{FF2B5EF4-FFF2-40B4-BE49-F238E27FC236}">
-                <a16:creationId xmlns:a16="http://schemas.microsoft.com/office/drawing/2014/main" id="{4933F618-57D6-4036-B667-6C173ED9202C}"/>
+                <a16:creationId xmlns:a16="http://schemas.microsoft.com/office/drawing/2014/main" id="{34B01E07-951B-4C47-B370-1B52DDD1304F}"/>
               </a:ext>
             </a:extLst>
           </p:cNvPr>
@@ -5174,7 +5265,7 @@
           <p:cNvPr id="6" name="A local workflow for detecting damage,&#10;reviewing e">
             <a:extLst xmlns:a="http://schemas.openxmlformats.org/drawingml/2006/main">
               <a:ext uri="{FF2B5EF4-FFF2-40B4-BE49-F238E27FC236}">
-                <a16:creationId xmlns:a16="http://schemas.microsoft.com/office/drawing/2014/main" id="{45E81DCB-7794-4F2D-AFE0-2C01CD31580B}"/>
+                <a16:creationId xmlns:a16="http://schemas.microsoft.com/office/drawing/2014/main" id="{FD6CCE1B-6665-49F5-AA0B-DA8293884F7A}"/>
               </a:ext>
             </a:extLst>
           </p:cNvPr>
@@ -5376,7 +5467,7 @@
           <p:cNvPr id="7" name="">
             <a:extLst xmlns:a="http://schemas.openxmlformats.org/drawingml/2006/main">
               <a:ext uri="{FF2B5EF4-FFF2-40B4-BE49-F238E27FC236}">
-                <a16:creationId xmlns:a16="http://schemas.microsoft.com/office/drawing/2014/main" id="{945BB620-0B9C-441C-9470-B192C1AF4138}"/>
+                <a16:creationId xmlns:a16="http://schemas.microsoft.com/office/drawing/2014/main" id="{A9078FB2-DA75-4CCB-A45D-0BAA13FFFF56}"/>
               </a:ext>
             </a:extLst>
           </p:cNvPr>
@@ -5386,7 +5477,7 @@
           <p:nvPr/>
         </p:nvPicPr>
         <p:blipFill>
-          <a:blip xmlns:r="http://schemas.openxmlformats.org/officeDocument/2006/relationships" xmlns:a="http://schemas.openxmlformats.org/drawingml/2006/main" r:embed="Rc889ed2f72d3474b"/>
+          <a:blip xmlns:r="http://schemas.openxmlformats.org/officeDocument/2006/relationships" xmlns:a="http://schemas.openxmlformats.org/drawingml/2006/main" r:embed="R45c89f2bd9cb402b"/>
           <a:srcRect xmlns:a="http://schemas.openxmlformats.org/drawingml/2006/main" l="57500" t="24500" r="1200" b="25700"/>
           <a:stretch xmlns:a="http://schemas.openxmlformats.org/drawingml/2006/main"/>
         </p:blipFill>
@@ -5405,7 +5496,7 @@
           <p:cNvPr id="8" name="Original app illustration, not a model prediction">
             <a:extLst xmlns:a="http://schemas.openxmlformats.org/drawingml/2006/main">
               <a:ext uri="{FF2B5EF4-FFF2-40B4-BE49-F238E27FC236}">
-                <a16:creationId xmlns:a16="http://schemas.microsoft.com/office/drawing/2014/main" id="{AA7CB3B9-D087-419F-B704-0AE88775B9AE}"/>
+                <a16:creationId xmlns:a16="http://schemas.microsoft.com/office/drawing/2014/main" id="{142BB98C-8278-488A-AE67-976B25AB0441}"/>
               </a:ext>
             </a:extLst>
           </p:cNvPr>
@@ -5561,7 +5652,7 @@
           <p:cNvPr id="9" name="Feras Alyamani   /   Ahmed Salamah   /   Ahmed Alh">
             <a:extLst xmlns:a="http://schemas.openxmlformats.org/drawingml/2006/main">
               <a:ext uri="{FF2B5EF4-FFF2-40B4-BE49-F238E27FC236}">
-                <a16:creationId xmlns:a16="http://schemas.microsoft.com/office/drawing/2014/main" id="{EEAF807F-6982-4312-9797-FD3586C6AC30}"/>
+                <a16:creationId xmlns:a16="http://schemas.microsoft.com/office/drawing/2014/main" id="{EE328472-A64B-4E92-8149-FB9DC039FB67}"/>
               </a:ext>
             </a:extLst>
           </p:cNvPr>
@@ -5715,7 +5806,7 @@
     </p:spTree>
     <p:extLst>
       <p:ext uri="{BB962C8B-B14F-4D97-AF65-F5344CB8AC3E}">
-        <p14:creationId xmlns:p14="http://schemas.microsoft.com/office/powerpoint/2010/main" val="764198785"/>
+        <p14:creationId xmlns:p14="http://schemas.microsoft.com/office/powerpoint/2010/main" val="153653307"/>
       </p:ext>
     </p:extLst>
   </p:cSld>
@@ -5746,7 +5837,7 @@
           <p:cNvPr id="18" name="APPENDIX C / DEPLOYMENT">
             <a:extLst xmlns:a="http://schemas.openxmlformats.org/drawingml/2006/main">
               <a:ext uri="{FF2B5EF4-FFF2-40B4-BE49-F238E27FC236}">
-                <a16:creationId xmlns:a16="http://schemas.microsoft.com/office/drawing/2014/main" id="{1D6E6282-8727-4211-8F6E-E27D4ED5EE36}"/>
+                <a16:creationId xmlns:a16="http://schemas.microsoft.com/office/drawing/2014/main" id="{1BB60BBF-77F1-480B-B536-C40617AB49BC}"/>
               </a:ext>
             </a:extLst>
           </p:cNvPr>
@@ -5902,7 +5993,7 @@
           <p:cNvPr id="2" name="Running RoadScan on another laptop">
             <a:extLst xmlns:a="http://schemas.openxmlformats.org/drawingml/2006/main">
               <a:ext uri="{FF2B5EF4-FFF2-40B4-BE49-F238E27FC236}">
-                <a16:creationId xmlns:a16="http://schemas.microsoft.com/office/drawing/2014/main" id="{47B109AF-0962-45CA-87F0-9C50BF121968}"/>
+                <a16:creationId xmlns:a16="http://schemas.microsoft.com/office/drawing/2014/main" id="{37B518C4-014A-47C3-A65E-74B3C8271B8E}"/>
               </a:ext>
             </a:extLst>
           </p:cNvPr>
@@ -6058,7 +6149,7 @@
           <p:cNvPr id="3" name="RoadScan / AIEP capstone">
             <a:extLst xmlns:a="http://schemas.openxmlformats.org/drawingml/2006/main">
               <a:ext uri="{FF2B5EF4-FFF2-40B4-BE49-F238E27FC236}">
-                <a16:creationId xmlns:a16="http://schemas.microsoft.com/office/drawing/2014/main" id="{296CF3D7-86A4-4FAA-9E0A-1DC9FF7BEB3C}"/>
+                <a16:creationId xmlns:a16="http://schemas.microsoft.com/office/drawing/2014/main" id="{0303B519-F932-47BD-BBA1-64355A3F1F41}"/>
               </a:ext>
             </a:extLst>
           </p:cNvPr>
@@ -6214,7 +6305,7 @@
           <p:cNvPr id="4" name="10">
             <a:extLst xmlns:a="http://schemas.openxmlformats.org/drawingml/2006/main">
               <a:ext uri="{FF2B5EF4-FFF2-40B4-BE49-F238E27FC236}">
-                <a16:creationId xmlns:a16="http://schemas.microsoft.com/office/drawing/2014/main" id="{5B2B3E95-F6EF-4ED9-ACA5-0BAFF02F1778}"/>
+                <a16:creationId xmlns:a16="http://schemas.microsoft.com/office/drawing/2014/main" id="{F0278442-2EFF-4435-9DA2-C077A7841096}"/>
               </a:ext>
             </a:extLst>
           </p:cNvPr>
@@ -6370,7 +6461,7 @@
           <p:cNvPr id="5" name="1">
             <a:extLst xmlns:a="http://schemas.openxmlformats.org/drawingml/2006/main">
               <a:ext uri="{FF2B5EF4-FFF2-40B4-BE49-F238E27FC236}">
-                <a16:creationId xmlns:a16="http://schemas.microsoft.com/office/drawing/2014/main" id="{4B82E750-3FA2-4ED3-B5EC-37AB632D88DE}"/>
+                <a16:creationId xmlns:a16="http://schemas.microsoft.com/office/drawing/2014/main" id="{8FB7B1D0-8AB9-44F2-B8E9-80C119F9D3F8}"/>
               </a:ext>
             </a:extLst>
           </p:cNvPr>
@@ -6526,7 +6617,7 @@
           <p:cNvPr id="6" name="Docker Desktop">
             <a:extLst xmlns:a="http://schemas.openxmlformats.org/drawingml/2006/main">
               <a:ext uri="{FF2B5EF4-FFF2-40B4-BE49-F238E27FC236}">
-                <a16:creationId xmlns:a16="http://schemas.microsoft.com/office/drawing/2014/main" id="{985343CA-5B27-4BE6-A274-0486C336896B}"/>
+                <a16:creationId xmlns:a16="http://schemas.microsoft.com/office/drawing/2014/main" id="{FC45531A-0F77-4494-ABC5-4AC08FAF649F}"/>
               </a:ext>
             </a:extLst>
           </p:cNvPr>
@@ -6682,7 +6773,7 @@
           <p:cNvPr id="7" name="Use Linux containers and the repository setup guid">
             <a:extLst xmlns:a="http://schemas.openxmlformats.org/drawingml/2006/main">
               <a:ext uri="{FF2B5EF4-FFF2-40B4-BE49-F238E27FC236}">
-                <a16:creationId xmlns:a16="http://schemas.microsoft.com/office/drawing/2014/main" id="{EE6FE8C6-C766-46A7-829B-083EF6AE2E08}"/>
+                <a16:creationId xmlns:a16="http://schemas.microsoft.com/office/drawing/2014/main" id="{0F140D01-5FBB-4BA3-82D5-2725A26E3052}"/>
               </a:ext>
             </a:extLst>
           </p:cNvPr>
@@ -6838,7 +6929,7 @@
           <p:cNvPr id="8" name="2">
             <a:extLst xmlns:a="http://schemas.openxmlformats.org/drawingml/2006/main">
               <a:ext uri="{FF2B5EF4-FFF2-40B4-BE49-F238E27FC236}">
-                <a16:creationId xmlns:a16="http://schemas.microsoft.com/office/drawing/2014/main" id="{D8B7669F-0D09-4905-9298-10B7143E9392}"/>
+                <a16:creationId xmlns:a16="http://schemas.microsoft.com/office/drawing/2014/main" id="{CDC0D6FA-4959-40C6-92A5-8E0F1D570FFE}"/>
               </a:ext>
             </a:extLst>
           </p:cNvPr>
@@ -6994,7 +7085,7 @@
           <p:cNvPr id="9" name="Local settings">
             <a:extLst xmlns:a="http://schemas.openxmlformats.org/drawingml/2006/main">
               <a:ext uri="{FF2B5EF4-FFF2-40B4-BE49-F238E27FC236}">
-                <a16:creationId xmlns:a16="http://schemas.microsoft.com/office/drawing/2014/main" id="{1F3184BA-1391-4D85-9376-26E77DF07795}"/>
+                <a16:creationId xmlns:a16="http://schemas.microsoft.com/office/drawing/2014/main" id="{F376CA59-19C8-4D6D-8CED-16A80CD4A039}"/>
               </a:ext>
             </a:extLst>
           </p:cNvPr>
@@ -7150,7 +7241,7 @@
           <p:cNvPr id="10" name="Generate the local token and keep the data volume.">
             <a:extLst xmlns:a="http://schemas.openxmlformats.org/drawingml/2006/main">
               <a:ext uri="{FF2B5EF4-FFF2-40B4-BE49-F238E27FC236}">
-                <a16:creationId xmlns:a16="http://schemas.microsoft.com/office/drawing/2014/main" id="{B43695A0-20C8-4C00-A9F7-D8AF881187C3}"/>
+                <a16:creationId xmlns:a16="http://schemas.microsoft.com/office/drawing/2014/main" id="{EA43E2A5-2CD2-4A5D-889A-C6CAF25EEAFB}"/>
               </a:ext>
             </a:extLst>
           </p:cNvPr>
@@ -7306,7 +7397,7 @@
           <p:cNvPr id="11" name="3">
             <a:extLst xmlns:a="http://schemas.openxmlformats.org/drawingml/2006/main">
               <a:ext uri="{FF2B5EF4-FFF2-40B4-BE49-F238E27FC236}">
-                <a16:creationId xmlns:a16="http://schemas.microsoft.com/office/drawing/2014/main" id="{E66D8537-91D1-4DB9-B33E-0BCE60D55409}"/>
+                <a16:creationId xmlns:a16="http://schemas.microsoft.com/office/drawing/2014/main" id="{4D6AB26C-A84E-49DF-9E7D-7324BD328003}"/>
               </a:ext>
             </a:extLst>
           </p:cNvPr>
@@ -7462,7 +7553,7 @@
           <p:cNvPr id="12" name="Trusted checkpoint">
             <a:extLst xmlns:a="http://schemas.openxmlformats.org/drawingml/2006/main">
               <a:ext uri="{FF2B5EF4-FFF2-40B4-BE49-F238E27FC236}">
-                <a16:creationId xmlns:a16="http://schemas.microsoft.com/office/drawing/2014/main" id="{35FA2EA4-A900-4EBB-A150-B1F0007F25B6}"/>
+                <a16:creationId xmlns:a16="http://schemas.microsoft.com/office/drawing/2014/main" id="{93AAD8B6-AF84-4595-B077-FEE9CCDD3A69}"/>
               </a:ext>
             </a:extLst>
           </p:cNvPr>
@@ -7618,7 +7709,7 @@
           <p:cNvPr id="13" name="Import a compatible road model and confirm Active.">
             <a:extLst xmlns:a="http://schemas.openxmlformats.org/drawingml/2006/main">
               <a:ext uri="{FF2B5EF4-FFF2-40B4-BE49-F238E27FC236}">
-                <a16:creationId xmlns:a16="http://schemas.microsoft.com/office/drawing/2014/main" id="{F0F4F130-6E68-431F-8B8D-45564D6D87FE}"/>
+                <a16:creationId xmlns:a16="http://schemas.microsoft.com/office/drawing/2014/main" id="{858965A7-D278-4A4C-B8F7-1D29225F5CE3}"/>
               </a:ext>
             </a:extLst>
           </p:cNvPr>
@@ -7774,7 +7865,7 @@
           <p:cNvPr id="14" name="4">
             <a:extLst xmlns:a="http://schemas.openxmlformats.org/drawingml/2006/main">
               <a:ext uri="{FF2B5EF4-FFF2-40B4-BE49-F238E27FC236}">
-                <a16:creationId xmlns:a16="http://schemas.microsoft.com/office/drawing/2014/main" id="{AB50C7F8-4538-4510-8F92-6AAE3803F8A2}"/>
+                <a16:creationId xmlns:a16="http://schemas.microsoft.com/office/drawing/2014/main" id="{722CB8CA-F6C2-4AD7-9C22-AD36BD592060}"/>
               </a:ext>
             </a:extLst>
           </p:cNvPr>
@@ -7930,7 +8021,7 @@
           <p:cNvPr id="15" name="First report">
             <a:extLst xmlns:a="http://schemas.openxmlformats.org/drawingml/2006/main">
               <a:ext uri="{FF2B5EF4-FFF2-40B4-BE49-F238E27FC236}">
-                <a16:creationId xmlns:a16="http://schemas.microsoft.com/office/drawing/2014/main" id="{A26631B1-BB4D-4AA3-933B-AC4E5E55A5DB}"/>
+                <a16:creationId xmlns:a16="http://schemas.microsoft.com/office/drawing/2014/main" id="{8F5DEC78-376B-4CEC-8187-4FDEDC971DA7}"/>
               </a:ext>
             </a:extLst>
           </p:cNvPr>
@@ -8086,7 +8177,7 @@
           <p:cNvPr id="16" name="Analyze a photo, inspect the boxes, then save a re">
             <a:extLst xmlns:a="http://schemas.openxmlformats.org/drawingml/2006/main">
               <a:ext uri="{FF2B5EF4-FFF2-40B4-BE49-F238E27FC236}">
-                <a16:creationId xmlns:a16="http://schemas.microsoft.com/office/drawing/2014/main" id="{9DD2E87C-2E41-44A3-933E-7CE7B4D42823}"/>
+                <a16:creationId xmlns:a16="http://schemas.microsoft.com/office/drawing/2014/main" id="{93EF1445-F82B-4ABD-A905-5575C3CA5EA8}"/>
               </a:ext>
             </a:extLst>
           </p:cNvPr>
@@ -8239,10 +8330,10 @@
       </p:sp>
       <p:sp>
         <p:nvSpPr>
-          <p:cNvPr id="17" name="Windows CPU workflow documented. Mac/ARM and drone">
+          <p:cNvPr id="17" name="Fresh-machine acceptance, Mac/ARM and physical dro">
             <a:extLst xmlns:a="http://schemas.openxmlformats.org/drawingml/2006/main">
               <a:ext uri="{FF2B5EF4-FFF2-40B4-BE49-F238E27FC236}">
-                <a16:creationId xmlns:a16="http://schemas.microsoft.com/office/drawing/2014/main" id="{A92353FC-1E76-4538-B4D8-9F1B71343890}"/>
+                <a16:creationId xmlns:a16="http://schemas.microsoft.com/office/drawing/2014/main" id="{0DB35ECC-1714-4340-97F6-C6CC40BF0E9C}"/>
               </a:ext>
             </a:extLst>
           </p:cNvPr>
@@ -8388,7 +8479,7 @@
                 <a:ea typeface="Arial"/>
                 <a:cs typeface="Arial"/>
               </a:rPr>
-              <a:t>Windows CPU workflow documented. Mac/ARM and drone hardware remain unverified.</a:t>
+              <a:t>Fresh-machine acceptance, Mac/ARM and physical drone integration remain unverified.</a:t>
             </a:r>
           </a:p>
         </p:txBody>
@@ -8396,7 +8487,7 @@
     </p:spTree>
     <p:extLst>
       <p:ext uri="{BB962C8B-B14F-4D97-AF65-F5344CB8AC3E}">
-        <p14:creationId xmlns:p14="http://schemas.microsoft.com/office/powerpoint/2010/main" val="1405126803"/>
+        <p14:creationId xmlns:p14="http://schemas.microsoft.com/office/powerpoint/2010/main" val="808542499"/>
       </p:ext>
     </p:extLst>
   </p:cSld>
@@ -8427,7 +8518,7 @@
           <p:cNvPr id="10" name="APPENDIX D / DEMO AND QUESTIONS">
             <a:extLst xmlns:a="http://schemas.openxmlformats.org/drawingml/2006/main">
               <a:ext uri="{FF2B5EF4-FFF2-40B4-BE49-F238E27FC236}">
-                <a16:creationId xmlns:a16="http://schemas.microsoft.com/office/drawing/2014/main" id="{3DF0F3C4-9C6A-4D3B-9D28-2426163B4687}"/>
+                <a16:creationId xmlns:a16="http://schemas.microsoft.com/office/drawing/2014/main" id="{652E783E-C5C6-41EE-A665-487FF5E62A77}"/>
               </a:ext>
             </a:extLst>
           </p:cNvPr>
@@ -8583,7 +8674,7 @@
           <p:cNvPr id="2" name="A short demonstration with evidence">
             <a:extLst xmlns:a="http://schemas.openxmlformats.org/drawingml/2006/main">
               <a:ext uri="{FF2B5EF4-FFF2-40B4-BE49-F238E27FC236}">
-                <a16:creationId xmlns:a16="http://schemas.microsoft.com/office/drawing/2014/main" id="{9BD413C4-46B6-4028-9F21-67ACDA50DCDE}"/>
+                <a16:creationId xmlns:a16="http://schemas.microsoft.com/office/drawing/2014/main" id="{1329A13B-BB03-4F8E-973A-7CC50A754D59}"/>
               </a:ext>
             </a:extLst>
           </p:cNvPr>
@@ -8739,7 +8830,7 @@
           <p:cNvPr id="3" name="RoadScan / AIEP capstone">
             <a:extLst xmlns:a="http://schemas.openxmlformats.org/drawingml/2006/main">
               <a:ext uri="{FF2B5EF4-FFF2-40B4-BE49-F238E27FC236}">
-                <a16:creationId xmlns:a16="http://schemas.microsoft.com/office/drawing/2014/main" id="{EBE62C1C-E24D-4610-A680-7AD168B7F114}"/>
+                <a16:creationId xmlns:a16="http://schemas.microsoft.com/office/drawing/2014/main" id="{54D515BA-EEFF-49D1-AC24-B0EDE03C1CB1}"/>
               </a:ext>
             </a:extLst>
           </p:cNvPr>
@@ -8895,7 +8986,7 @@
           <p:cNvPr id="4" name="11">
             <a:extLst xmlns:a="http://schemas.openxmlformats.org/drawingml/2006/main">
               <a:ext uri="{FF2B5EF4-FFF2-40B4-BE49-F238E27FC236}">
-                <a16:creationId xmlns:a16="http://schemas.microsoft.com/office/drawing/2014/main" id="{76AA1BD9-1549-4BD1-B220-B6EC2EEE0D8D}"/>
+                <a16:creationId xmlns:a16="http://schemas.microsoft.com/office/drawing/2014/main" id="{80797D99-DD84-40EA-A5D7-6BE843346870}"/>
               </a:ext>
             </a:extLst>
           </p:cNvPr>
@@ -9051,7 +9142,7 @@
           <p:cNvPr id="5" name="Show">
             <a:extLst xmlns:a="http://schemas.openxmlformats.org/drawingml/2006/main">
               <a:ext uri="{FF2B5EF4-FFF2-40B4-BE49-F238E27FC236}">
-                <a16:creationId xmlns:a16="http://schemas.microsoft.com/office/drawing/2014/main" id="{3914F2F6-0099-4F58-B65C-57295C919401}"/>
+                <a16:creationId xmlns:a16="http://schemas.microsoft.com/office/drawing/2014/main" id="{E228A792-7A38-4C5A-ADEA-CB6D5A4BBB4C}"/>
               </a:ext>
             </a:extLst>
           </p:cNvPr>
@@ -9207,7 +9298,7 @@
           <p:cNvPr id="6" name="A road image and its prediction.&#10;A corrected repor">
             <a:extLst xmlns:a="http://schemas.openxmlformats.org/drawingml/2006/main">
               <a:ext uri="{FF2B5EF4-FFF2-40B4-BE49-F238E27FC236}">
-                <a16:creationId xmlns:a16="http://schemas.microsoft.com/office/drawing/2014/main" id="{BA3E2A53-BF22-4749-AF78-BAFE9180EB10}"/>
+                <a16:creationId xmlns:a16="http://schemas.microsoft.com/office/drawing/2014/main" id="{7828DB7B-1E5C-463A-A699-BE2B8FCBDAC7}"/>
               </a:ext>
             </a:extLst>
           </p:cNvPr>
@@ -9432,7 +9523,7 @@
           <p:cNvPr id="7" name="Explain">
             <a:extLst xmlns:a="http://schemas.openxmlformats.org/drawingml/2006/main">
               <a:ext uri="{FF2B5EF4-FFF2-40B4-BE49-F238E27FC236}">
-                <a16:creationId xmlns:a16="http://schemas.microsoft.com/office/drawing/2014/main" id="{D79E9F3D-32F2-42DD-A6E5-0B88C1B70C4F}"/>
+                <a16:creationId xmlns:a16="http://schemas.microsoft.com/office/drawing/2014/main" id="{4F9CE830-0B3D-4B58-A2B0-02BEFE87804B}"/>
               </a:ext>
             </a:extLst>
           </p:cNvPr>
@@ -9588,7 +9679,7 @@
           <p:cNvPr id="8" name="Confidence is not accuracy.&#10;Priority is an estimat">
             <a:extLst xmlns:a="http://schemas.openxmlformats.org/drawingml/2006/main">
               <a:ext uri="{FF2B5EF4-FFF2-40B4-BE49-F238E27FC236}">
-                <a16:creationId xmlns:a16="http://schemas.microsoft.com/office/drawing/2014/main" id="{99268D6F-C273-45EF-B4C9-C70D4464E699}"/>
+                <a16:creationId xmlns:a16="http://schemas.microsoft.com/office/drawing/2014/main" id="{6EBCEBF7-0D93-442F-BACB-EF91B2D63667}"/>
               </a:ext>
             </a:extLst>
           </p:cNvPr>
@@ -9836,7 +9927,7 @@
           <p:cNvPr id="9" name="If hardware is unavailable, use the cleared interf">
             <a:extLst xmlns:a="http://schemas.openxmlformats.org/drawingml/2006/main">
               <a:ext uri="{FF2B5EF4-FFF2-40B4-BE49-F238E27FC236}">
-                <a16:creationId xmlns:a16="http://schemas.microsoft.com/office/drawing/2014/main" id="{CEFC7676-3ED1-4BC8-B0F4-76271D5BD99E}"/>
+                <a16:creationId xmlns:a16="http://schemas.microsoft.com/office/drawing/2014/main" id="{9AF0C610-3875-4B62-B50E-A554CA86FC72}"/>
               </a:ext>
             </a:extLst>
           </p:cNvPr>
@@ -9990,7 +10081,2220 @@
     </p:spTree>
     <p:extLst>
       <p:ext uri="{BB962C8B-B14F-4D97-AF65-F5344CB8AC3E}">
-        <p14:creationId xmlns:p14="http://schemas.microsoft.com/office/powerpoint/2010/main" val="1548765180"/>
+        <p14:creationId xmlns:p14="http://schemas.microsoft.com/office/powerpoint/2010/main" val="476823856"/>
+      </p:ext>
+    </p:extLst>
+  </p:cSld>
+</p:sld>
+</file>
+
+<file path=ppt/slides/slide12.xml><?xml version="1.0" encoding="utf-8"?>
+<p:sld xmlns:p="http://schemas.openxmlformats.org/presentationml/2006/main">
+  <p:cSld>
+    <p:bg>
+      <p:bgPr>
+        <a:solidFill xmlns:a="http://schemas.openxmlformats.org/drawingml/2006/main">
+          <a:srgbClr val="0C1820"/>
+        </a:solidFill>
+      </p:bgPr>
+    </p:bg>
+    <p:spTree>
+      <p:nvGrpSpPr>
+        <p:cNvPr id="1" name=""/>
+        <p:cNvGrpSpPr/>
+        <p:nvPr/>
+      </p:nvGrpSpPr>
+      <p:grpSpPr>
+        <a:xfrm xmlns:a="http://schemas.openxmlformats.org/drawingml/2006/main"/>
+      </p:grpSpPr>
+      <p:sp>
+        <p:nvSpPr>
+          <p:cNvPr id="15" name="APPENDIX E / RESEARCH SCOPE">
+            <a:extLst xmlns:a="http://schemas.openxmlformats.org/drawingml/2006/main">
+              <a:ext uri="{FF2B5EF4-FFF2-40B4-BE49-F238E27FC236}">
+                <a16:creationId xmlns:a16="http://schemas.microsoft.com/office/drawing/2014/main" id="{3B01BBE0-B6FD-4E4F-A53A-0B72A26B7E17}"/>
+              </a:ext>
+            </a:extLst>
+          </p:cNvPr>
+          <p:cNvSpPr>
+            <a:spLocks xmlns:a="http://schemas.openxmlformats.org/drawingml/2006/main" noGrp="1"/>
+          </p:cNvSpPr>
+          <p:nvPr/>
+        </p:nvSpPr>
+        <p:spPr>
+          <a:xfrm xmlns:a="http://schemas.openxmlformats.org/drawingml/2006/main">
+            <a:off x="552450" y="304800"/>
+            <a:ext cx="10001250" cy="228600"/>
+          </a:xfrm>
+          <a:prstGeom xmlns:a="http://schemas.openxmlformats.org/drawingml/2006/main" prst="rect">
+            <a:avLst/>
+          </a:prstGeom>
+          <a:noFill xmlns:a="http://schemas.openxmlformats.org/drawingml/2006/main"/>
+          <a:ln xmlns:a="http://schemas.openxmlformats.org/drawingml/2006/main" w="0">
+            <a:noFill/>
+          </a:ln>
+        </p:spPr>
+        <p:txBody>
+          <a:bodyPr xmlns:a="http://schemas.openxmlformats.org/drawingml/2006/main" lIns="0" tIns="0" rIns="0" bIns="0"/>
+          <a:lstStyle xmlns:a="http://schemas.openxmlformats.org/drawingml/2006/main">
+            <a:defPPr>
+              <a:defRPr sz="1125" b="1">
+                <a:solidFill>
+                  <a:srgbClr val="77D6DD"/>
+                </a:solidFill>
+                <a:latin typeface="Arial"/>
+                <a:ea typeface="Arial"/>
+                <a:cs typeface="Arial"/>
+              </a:defRPr>
+            </a:defPPr>
+            <a:lvl1pPr>
+              <a:defRPr sz="1125" b="1">
+                <a:solidFill>
+                  <a:srgbClr val="77D6DD"/>
+                </a:solidFill>
+                <a:latin typeface="Arial"/>
+                <a:ea typeface="Arial"/>
+                <a:cs typeface="Arial"/>
+              </a:defRPr>
+            </a:lvl1pPr>
+            <a:lvl2pPr>
+              <a:defRPr sz="1125" b="1">
+                <a:solidFill>
+                  <a:srgbClr val="77D6DD"/>
+                </a:solidFill>
+                <a:latin typeface="Arial"/>
+                <a:ea typeface="Arial"/>
+                <a:cs typeface="Arial"/>
+              </a:defRPr>
+            </a:lvl2pPr>
+            <a:lvl3pPr>
+              <a:defRPr sz="1125" b="1">
+                <a:solidFill>
+                  <a:srgbClr val="77D6DD"/>
+                </a:solidFill>
+                <a:latin typeface="Arial"/>
+                <a:ea typeface="Arial"/>
+                <a:cs typeface="Arial"/>
+              </a:defRPr>
+            </a:lvl3pPr>
+            <a:lvl4pPr>
+              <a:defRPr sz="1125" b="1">
+                <a:solidFill>
+                  <a:srgbClr val="77D6DD"/>
+                </a:solidFill>
+                <a:latin typeface="Arial"/>
+                <a:ea typeface="Arial"/>
+                <a:cs typeface="Arial"/>
+              </a:defRPr>
+            </a:lvl4pPr>
+            <a:lvl5pPr>
+              <a:defRPr sz="1125" b="1">
+                <a:solidFill>
+                  <a:srgbClr val="77D6DD"/>
+                </a:solidFill>
+                <a:latin typeface="Arial"/>
+                <a:ea typeface="Arial"/>
+                <a:cs typeface="Arial"/>
+              </a:defRPr>
+            </a:lvl5pPr>
+            <a:lvl6pPr>
+              <a:defRPr sz="1125" b="1">
+                <a:solidFill>
+                  <a:srgbClr val="77D6DD"/>
+                </a:solidFill>
+                <a:latin typeface="Arial"/>
+                <a:ea typeface="Arial"/>
+                <a:cs typeface="Arial"/>
+              </a:defRPr>
+            </a:lvl6pPr>
+            <a:lvl7pPr>
+              <a:defRPr sz="1125" b="1">
+                <a:solidFill>
+                  <a:srgbClr val="77D6DD"/>
+                </a:solidFill>
+                <a:latin typeface="Arial"/>
+                <a:ea typeface="Arial"/>
+                <a:cs typeface="Arial"/>
+              </a:defRPr>
+            </a:lvl7pPr>
+            <a:lvl8pPr>
+              <a:defRPr sz="1125" b="1">
+                <a:solidFill>
+                  <a:srgbClr val="77D6DD"/>
+                </a:solidFill>
+                <a:latin typeface="Arial"/>
+                <a:ea typeface="Arial"/>
+                <a:cs typeface="Arial"/>
+              </a:defRPr>
+            </a:lvl8pPr>
+            <a:lvl9pPr>
+              <a:defRPr sz="1125" b="1">
+                <a:solidFill>
+                  <a:srgbClr val="77D6DD"/>
+                </a:solidFill>
+                <a:latin typeface="Arial"/>
+                <a:ea typeface="Arial"/>
+                <a:cs typeface="Arial"/>
+              </a:defRPr>
+            </a:lvl9pPr>
+          </a:lstStyle>
+          <a:p xmlns:a="http://schemas.openxmlformats.org/drawingml/2006/main">
+            <a:pPr>
+              <a:defRPr sz="1125" b="1">
+                <a:solidFill>
+                  <a:srgbClr val="77D6DD"/>
+                </a:solidFill>
+                <a:latin typeface="Arial"/>
+                <a:ea typeface="Arial"/>
+                <a:cs typeface="Arial"/>
+              </a:defRPr>
+            </a:pPr>
+            <a:r>
+              <a:rPr sz="1125" b="1">
+                <a:solidFill>
+                  <a:srgbClr val="77D6DD"/>
+                </a:solidFill>
+                <a:latin typeface="Arial"/>
+                <a:ea typeface="Arial"/>
+                <a:cs typeface="Arial"/>
+              </a:rPr>
+              <a:t>APPENDIX E / RESEARCH SCOPE</a:t>
+            </a:r>
+          </a:p>
+        </p:txBody>
+      </p:sp>
+      <p:sp>
+        <p:nvSpPr>
+          <p:cNvPr id="2" name="Experiments and remaining evidence">
+            <a:extLst xmlns:a="http://schemas.openxmlformats.org/drawingml/2006/main">
+              <a:ext uri="{FF2B5EF4-FFF2-40B4-BE49-F238E27FC236}">
+                <a16:creationId xmlns:a16="http://schemas.microsoft.com/office/drawing/2014/main" id="{AB3C1F4D-F92A-4DFC-9E76-6FB816B809C7}"/>
+              </a:ext>
+            </a:extLst>
+          </p:cNvPr>
+          <p:cNvSpPr>
+            <a:spLocks xmlns:a="http://schemas.openxmlformats.org/drawingml/2006/main" noGrp="1"/>
+          </p:cNvSpPr>
+          <p:nvPr/>
+        </p:nvSpPr>
+        <p:spPr>
+          <a:xfrm xmlns:a="http://schemas.openxmlformats.org/drawingml/2006/main">
+            <a:off x="552450" y="742950"/>
+            <a:ext cx="11087100" cy="1066800"/>
+          </a:xfrm>
+          <a:prstGeom xmlns:a="http://schemas.openxmlformats.org/drawingml/2006/main" prst="rect">
+            <a:avLst/>
+          </a:prstGeom>
+          <a:noFill xmlns:a="http://schemas.openxmlformats.org/drawingml/2006/main"/>
+          <a:ln xmlns:a="http://schemas.openxmlformats.org/drawingml/2006/main" w="0">
+            <a:noFill/>
+          </a:ln>
+        </p:spPr>
+        <p:txBody>
+          <a:bodyPr xmlns:a="http://schemas.openxmlformats.org/drawingml/2006/main" lIns="0" tIns="0" rIns="0" bIns="0"/>
+          <a:lstStyle xmlns:a="http://schemas.openxmlformats.org/drawingml/2006/main">
+            <a:defPPr>
+              <a:defRPr sz="3675" b="1">
+                <a:solidFill>
+                  <a:srgbClr val="F0F5F6"/>
+                </a:solidFill>
+                <a:latin typeface="Arial"/>
+                <a:ea typeface="Arial"/>
+                <a:cs typeface="Arial"/>
+              </a:defRPr>
+            </a:defPPr>
+            <a:lvl1pPr>
+              <a:defRPr sz="3675" b="1">
+                <a:solidFill>
+                  <a:srgbClr val="F0F5F6"/>
+                </a:solidFill>
+                <a:latin typeface="Arial"/>
+                <a:ea typeface="Arial"/>
+                <a:cs typeface="Arial"/>
+              </a:defRPr>
+            </a:lvl1pPr>
+            <a:lvl2pPr>
+              <a:defRPr sz="3675" b="1">
+                <a:solidFill>
+                  <a:srgbClr val="F0F5F6"/>
+                </a:solidFill>
+                <a:latin typeface="Arial"/>
+                <a:ea typeface="Arial"/>
+                <a:cs typeface="Arial"/>
+              </a:defRPr>
+            </a:lvl2pPr>
+            <a:lvl3pPr>
+              <a:defRPr sz="3675" b="1">
+                <a:solidFill>
+                  <a:srgbClr val="F0F5F6"/>
+                </a:solidFill>
+                <a:latin typeface="Arial"/>
+                <a:ea typeface="Arial"/>
+                <a:cs typeface="Arial"/>
+              </a:defRPr>
+            </a:lvl3pPr>
+            <a:lvl4pPr>
+              <a:defRPr sz="3675" b="1">
+                <a:solidFill>
+                  <a:srgbClr val="F0F5F6"/>
+                </a:solidFill>
+                <a:latin typeface="Arial"/>
+                <a:ea typeface="Arial"/>
+                <a:cs typeface="Arial"/>
+              </a:defRPr>
+            </a:lvl4pPr>
+            <a:lvl5pPr>
+              <a:defRPr sz="3675" b="1">
+                <a:solidFill>
+                  <a:srgbClr val="F0F5F6"/>
+                </a:solidFill>
+                <a:latin typeface="Arial"/>
+                <a:ea typeface="Arial"/>
+                <a:cs typeface="Arial"/>
+              </a:defRPr>
+            </a:lvl5pPr>
+            <a:lvl6pPr>
+              <a:defRPr sz="3675" b="1">
+                <a:solidFill>
+                  <a:srgbClr val="F0F5F6"/>
+                </a:solidFill>
+                <a:latin typeface="Arial"/>
+                <a:ea typeface="Arial"/>
+                <a:cs typeface="Arial"/>
+              </a:defRPr>
+            </a:lvl6pPr>
+            <a:lvl7pPr>
+              <a:defRPr sz="3675" b="1">
+                <a:solidFill>
+                  <a:srgbClr val="F0F5F6"/>
+                </a:solidFill>
+                <a:latin typeface="Arial"/>
+                <a:ea typeface="Arial"/>
+                <a:cs typeface="Arial"/>
+              </a:defRPr>
+            </a:lvl7pPr>
+            <a:lvl8pPr>
+              <a:defRPr sz="3675" b="1">
+                <a:solidFill>
+                  <a:srgbClr val="F0F5F6"/>
+                </a:solidFill>
+                <a:latin typeface="Arial"/>
+                <a:ea typeface="Arial"/>
+                <a:cs typeface="Arial"/>
+              </a:defRPr>
+            </a:lvl8pPr>
+            <a:lvl9pPr>
+              <a:defRPr sz="3675" b="1">
+                <a:solidFill>
+                  <a:srgbClr val="F0F5F6"/>
+                </a:solidFill>
+                <a:latin typeface="Arial"/>
+                <a:ea typeface="Arial"/>
+                <a:cs typeface="Arial"/>
+              </a:defRPr>
+            </a:lvl9pPr>
+          </a:lstStyle>
+          <a:p xmlns:a="http://schemas.openxmlformats.org/drawingml/2006/main">
+            <a:pPr>
+              <a:defRPr sz="3675" b="1">
+                <a:solidFill>
+                  <a:srgbClr val="F0F5F6"/>
+                </a:solidFill>
+                <a:latin typeface="Arial"/>
+                <a:ea typeface="Arial"/>
+                <a:cs typeface="Arial"/>
+              </a:defRPr>
+            </a:pPr>
+            <a:r>
+              <a:rPr sz="3675" b="1">
+                <a:solidFill>
+                  <a:srgbClr val="F0F5F6"/>
+                </a:solidFill>
+                <a:latin typeface="Arial"/>
+                <a:ea typeface="Arial"/>
+                <a:cs typeface="Arial"/>
+              </a:rPr>
+              <a:t>Experiments and remaining evidence</a:t>
+            </a:r>
+          </a:p>
+        </p:txBody>
+      </p:sp>
+      <p:sp>
+        <p:nvSpPr>
+          <p:cNvPr id="3" name="RoadScan / AIEP capstone">
+            <a:extLst xmlns:a="http://schemas.openxmlformats.org/drawingml/2006/main">
+              <a:ext uri="{FF2B5EF4-FFF2-40B4-BE49-F238E27FC236}">
+                <a16:creationId xmlns:a16="http://schemas.microsoft.com/office/drawing/2014/main" id="{F5582677-D8EC-4E2C-B5F9-A44A4A75D799}"/>
+              </a:ext>
+            </a:extLst>
+          </p:cNvPr>
+          <p:cNvSpPr>
+            <a:spLocks xmlns:a="http://schemas.openxmlformats.org/drawingml/2006/main" noGrp="1"/>
+          </p:cNvSpPr>
+          <p:nvPr/>
+        </p:nvSpPr>
+        <p:spPr>
+          <a:xfrm xmlns:a="http://schemas.openxmlformats.org/drawingml/2006/main">
+            <a:off x="552450" y="6438900"/>
+            <a:ext cx="8572500" cy="190500"/>
+          </a:xfrm>
+          <a:prstGeom xmlns:a="http://schemas.openxmlformats.org/drawingml/2006/main" prst="rect">
+            <a:avLst/>
+          </a:prstGeom>
+          <a:noFill xmlns:a="http://schemas.openxmlformats.org/drawingml/2006/main"/>
+          <a:ln xmlns:a="http://schemas.openxmlformats.org/drawingml/2006/main" w="0">
+            <a:noFill/>
+          </a:ln>
+        </p:spPr>
+        <p:txBody>
+          <a:bodyPr xmlns:a="http://schemas.openxmlformats.org/drawingml/2006/main" lIns="0" tIns="0" rIns="0" bIns="0"/>
+          <a:lstStyle xmlns:a="http://schemas.openxmlformats.org/drawingml/2006/main">
+            <a:defPPr>
+              <a:defRPr sz="1125" b="0">
+                <a:solidFill>
+                  <a:srgbClr val="A5BDC6"/>
+                </a:solidFill>
+                <a:latin typeface="Arial"/>
+                <a:ea typeface="Arial"/>
+                <a:cs typeface="Arial"/>
+              </a:defRPr>
+            </a:defPPr>
+            <a:lvl1pPr>
+              <a:defRPr sz="1125" b="0">
+                <a:solidFill>
+                  <a:srgbClr val="A5BDC6"/>
+                </a:solidFill>
+                <a:latin typeface="Arial"/>
+                <a:ea typeface="Arial"/>
+                <a:cs typeface="Arial"/>
+              </a:defRPr>
+            </a:lvl1pPr>
+            <a:lvl2pPr>
+              <a:defRPr sz="1125" b="0">
+                <a:solidFill>
+                  <a:srgbClr val="A5BDC6"/>
+                </a:solidFill>
+                <a:latin typeface="Arial"/>
+                <a:ea typeface="Arial"/>
+                <a:cs typeface="Arial"/>
+              </a:defRPr>
+            </a:lvl2pPr>
+            <a:lvl3pPr>
+              <a:defRPr sz="1125" b="0">
+                <a:solidFill>
+                  <a:srgbClr val="A5BDC6"/>
+                </a:solidFill>
+                <a:latin typeface="Arial"/>
+                <a:ea typeface="Arial"/>
+                <a:cs typeface="Arial"/>
+              </a:defRPr>
+            </a:lvl3pPr>
+            <a:lvl4pPr>
+              <a:defRPr sz="1125" b="0">
+                <a:solidFill>
+                  <a:srgbClr val="A5BDC6"/>
+                </a:solidFill>
+                <a:latin typeface="Arial"/>
+                <a:ea typeface="Arial"/>
+                <a:cs typeface="Arial"/>
+              </a:defRPr>
+            </a:lvl4pPr>
+            <a:lvl5pPr>
+              <a:defRPr sz="1125" b="0">
+                <a:solidFill>
+                  <a:srgbClr val="A5BDC6"/>
+                </a:solidFill>
+                <a:latin typeface="Arial"/>
+                <a:ea typeface="Arial"/>
+                <a:cs typeface="Arial"/>
+              </a:defRPr>
+            </a:lvl5pPr>
+            <a:lvl6pPr>
+              <a:defRPr sz="1125" b="0">
+                <a:solidFill>
+                  <a:srgbClr val="A5BDC6"/>
+                </a:solidFill>
+                <a:latin typeface="Arial"/>
+                <a:ea typeface="Arial"/>
+                <a:cs typeface="Arial"/>
+              </a:defRPr>
+            </a:lvl6pPr>
+            <a:lvl7pPr>
+              <a:defRPr sz="1125" b="0">
+                <a:solidFill>
+                  <a:srgbClr val="A5BDC6"/>
+                </a:solidFill>
+                <a:latin typeface="Arial"/>
+                <a:ea typeface="Arial"/>
+                <a:cs typeface="Arial"/>
+              </a:defRPr>
+            </a:lvl7pPr>
+            <a:lvl8pPr>
+              <a:defRPr sz="1125" b="0">
+                <a:solidFill>
+                  <a:srgbClr val="A5BDC6"/>
+                </a:solidFill>
+                <a:latin typeface="Arial"/>
+                <a:ea typeface="Arial"/>
+                <a:cs typeface="Arial"/>
+              </a:defRPr>
+            </a:lvl8pPr>
+            <a:lvl9pPr>
+              <a:defRPr sz="1125" b="0">
+                <a:solidFill>
+                  <a:srgbClr val="A5BDC6"/>
+                </a:solidFill>
+                <a:latin typeface="Arial"/>
+                <a:ea typeface="Arial"/>
+                <a:cs typeface="Arial"/>
+              </a:defRPr>
+            </a:lvl9pPr>
+          </a:lstStyle>
+          <a:p xmlns:a="http://schemas.openxmlformats.org/drawingml/2006/main">
+            <a:pPr>
+              <a:defRPr sz="1125" b="0">
+                <a:solidFill>
+                  <a:srgbClr val="A5BDC6"/>
+                </a:solidFill>
+                <a:latin typeface="Arial"/>
+                <a:ea typeface="Arial"/>
+                <a:cs typeface="Arial"/>
+              </a:defRPr>
+            </a:pPr>
+            <a:r>
+              <a:rPr sz="1125" b="0">
+                <a:solidFill>
+                  <a:srgbClr val="A5BDC6"/>
+                </a:solidFill>
+                <a:latin typeface="Arial"/>
+                <a:ea typeface="Arial"/>
+                <a:cs typeface="Arial"/>
+              </a:rPr>
+              <a:t>RoadScan / AIEP capstone</a:t>
+            </a:r>
+          </a:p>
+        </p:txBody>
+      </p:sp>
+      <p:sp>
+        <p:nvSpPr>
+          <p:cNvPr id="4" name="12">
+            <a:extLst xmlns:a="http://schemas.openxmlformats.org/drawingml/2006/main">
+              <a:ext uri="{FF2B5EF4-FFF2-40B4-BE49-F238E27FC236}">
+                <a16:creationId xmlns:a16="http://schemas.microsoft.com/office/drawing/2014/main" id="{0DE2A4E0-BAD6-4B9C-B098-6C29D1E82796}"/>
+              </a:ext>
+            </a:extLst>
+          </p:cNvPr>
+          <p:cNvSpPr>
+            <a:spLocks xmlns:a="http://schemas.openxmlformats.org/drawingml/2006/main" noGrp="1"/>
+          </p:cNvSpPr>
+          <p:nvPr/>
+        </p:nvSpPr>
+        <p:spPr>
+          <a:xfrm xmlns:a="http://schemas.openxmlformats.org/drawingml/2006/main">
+            <a:off x="11144250" y="6400800"/>
+            <a:ext cx="552450" cy="247650"/>
+          </a:xfrm>
+          <a:prstGeom xmlns:a="http://schemas.openxmlformats.org/drawingml/2006/main" prst="rect">
+            <a:avLst/>
+          </a:prstGeom>
+          <a:noFill xmlns:a="http://schemas.openxmlformats.org/drawingml/2006/main"/>
+          <a:ln xmlns:a="http://schemas.openxmlformats.org/drawingml/2006/main" w="0">
+            <a:noFill/>
+          </a:ln>
+        </p:spPr>
+        <p:txBody>
+          <a:bodyPr xmlns:a="http://schemas.openxmlformats.org/drawingml/2006/main" lIns="0" tIns="0" rIns="0" bIns="0"/>
+          <a:lstStyle xmlns:a="http://schemas.openxmlformats.org/drawingml/2006/main">
+            <a:defPPr>
+              <a:defRPr sz="1500" b="1">
+                <a:solidFill>
+                  <a:srgbClr val="DCFA6B"/>
+                </a:solidFill>
+                <a:latin typeface="Arial"/>
+                <a:ea typeface="Arial"/>
+                <a:cs typeface="Arial"/>
+              </a:defRPr>
+            </a:defPPr>
+            <a:lvl1pPr>
+              <a:defRPr sz="1500" b="1">
+                <a:solidFill>
+                  <a:srgbClr val="DCFA6B"/>
+                </a:solidFill>
+                <a:latin typeface="Arial"/>
+                <a:ea typeface="Arial"/>
+                <a:cs typeface="Arial"/>
+              </a:defRPr>
+            </a:lvl1pPr>
+            <a:lvl2pPr>
+              <a:defRPr sz="1500" b="1">
+                <a:solidFill>
+                  <a:srgbClr val="DCFA6B"/>
+                </a:solidFill>
+                <a:latin typeface="Arial"/>
+                <a:ea typeface="Arial"/>
+                <a:cs typeface="Arial"/>
+              </a:defRPr>
+            </a:lvl2pPr>
+            <a:lvl3pPr>
+              <a:defRPr sz="1500" b="1">
+                <a:solidFill>
+                  <a:srgbClr val="DCFA6B"/>
+                </a:solidFill>
+                <a:latin typeface="Arial"/>
+                <a:ea typeface="Arial"/>
+                <a:cs typeface="Arial"/>
+              </a:defRPr>
+            </a:lvl3pPr>
+            <a:lvl4pPr>
+              <a:defRPr sz="1500" b="1">
+                <a:solidFill>
+                  <a:srgbClr val="DCFA6B"/>
+                </a:solidFill>
+                <a:latin typeface="Arial"/>
+                <a:ea typeface="Arial"/>
+                <a:cs typeface="Arial"/>
+              </a:defRPr>
+            </a:lvl4pPr>
+            <a:lvl5pPr>
+              <a:defRPr sz="1500" b="1">
+                <a:solidFill>
+                  <a:srgbClr val="DCFA6B"/>
+                </a:solidFill>
+                <a:latin typeface="Arial"/>
+                <a:ea typeface="Arial"/>
+                <a:cs typeface="Arial"/>
+              </a:defRPr>
+            </a:lvl5pPr>
+            <a:lvl6pPr>
+              <a:defRPr sz="1500" b="1">
+                <a:solidFill>
+                  <a:srgbClr val="DCFA6B"/>
+                </a:solidFill>
+                <a:latin typeface="Arial"/>
+                <a:ea typeface="Arial"/>
+                <a:cs typeface="Arial"/>
+              </a:defRPr>
+            </a:lvl6pPr>
+            <a:lvl7pPr>
+              <a:defRPr sz="1500" b="1">
+                <a:solidFill>
+                  <a:srgbClr val="DCFA6B"/>
+                </a:solidFill>
+                <a:latin typeface="Arial"/>
+                <a:ea typeface="Arial"/>
+                <a:cs typeface="Arial"/>
+              </a:defRPr>
+            </a:lvl7pPr>
+            <a:lvl8pPr>
+              <a:defRPr sz="1500" b="1">
+                <a:solidFill>
+                  <a:srgbClr val="DCFA6B"/>
+                </a:solidFill>
+                <a:latin typeface="Arial"/>
+                <a:ea typeface="Arial"/>
+                <a:cs typeface="Arial"/>
+              </a:defRPr>
+            </a:lvl8pPr>
+            <a:lvl9pPr>
+              <a:defRPr sz="1500" b="1">
+                <a:solidFill>
+                  <a:srgbClr val="DCFA6B"/>
+                </a:solidFill>
+                <a:latin typeface="Arial"/>
+                <a:ea typeface="Arial"/>
+                <a:cs typeface="Arial"/>
+              </a:defRPr>
+            </a:lvl9pPr>
+          </a:lstStyle>
+          <a:p xmlns:a="http://schemas.openxmlformats.org/drawingml/2006/main">
+            <a:pPr>
+              <a:defRPr sz="1500" b="1">
+                <a:solidFill>
+                  <a:srgbClr val="DCFA6B"/>
+                </a:solidFill>
+                <a:latin typeface="Arial"/>
+                <a:ea typeface="Arial"/>
+                <a:cs typeface="Arial"/>
+              </a:defRPr>
+            </a:pPr>
+            <a:r>
+              <a:rPr sz="1500" b="1">
+                <a:solidFill>
+                  <a:srgbClr val="DCFA6B"/>
+                </a:solidFill>
+                <a:latin typeface="Arial"/>
+                <a:ea typeface="Arial"/>
+                <a:cs typeface="Arial"/>
+              </a:rPr>
+              <a:t>12</a:t>
+            </a:r>
+          </a:p>
+        </p:txBody>
+      </p:sp>
+      <p:sp>
+        <p:nvSpPr>
+          <p:cNvPr id="5" name="E1  Classifier and detector">
+            <a:extLst xmlns:a="http://schemas.openxmlformats.org/drawingml/2006/main">
+              <a:ext uri="{FF2B5EF4-FFF2-40B4-BE49-F238E27FC236}">
+                <a16:creationId xmlns:a16="http://schemas.microsoft.com/office/drawing/2014/main" id="{0DA41B83-6D2E-4C01-ACE8-83168E2952A5}"/>
+              </a:ext>
+            </a:extLst>
+          </p:cNvPr>
+          <p:cNvSpPr>
+            <a:spLocks xmlns:a="http://schemas.openxmlformats.org/drawingml/2006/main" noGrp="1"/>
+          </p:cNvSpPr>
+          <p:nvPr/>
+        </p:nvSpPr>
+        <p:spPr>
+          <a:xfrm xmlns:a="http://schemas.openxmlformats.org/drawingml/2006/main">
+            <a:off x="552450" y="1933575"/>
+            <a:ext cx="11087100" cy="323850"/>
+          </a:xfrm>
+          <a:prstGeom xmlns:a="http://schemas.openxmlformats.org/drawingml/2006/main" prst="rect">
+            <a:avLst/>
+          </a:prstGeom>
+          <a:noFill xmlns:a="http://schemas.openxmlformats.org/drawingml/2006/main"/>
+          <a:ln xmlns:a="http://schemas.openxmlformats.org/drawingml/2006/main" w="0">
+            <a:noFill/>
+          </a:ln>
+        </p:spPr>
+        <p:txBody>
+          <a:bodyPr xmlns:a="http://schemas.openxmlformats.org/drawingml/2006/main" lIns="0" tIns="0" rIns="0" bIns="0"/>
+          <a:lstStyle xmlns:a="http://schemas.openxmlformats.org/drawingml/2006/main">
+            <a:defPPr>
+              <a:defRPr sz="2025" b="1">
+                <a:solidFill>
+                  <a:srgbClr val="DCFA6B"/>
+                </a:solidFill>
+                <a:latin typeface="Arial"/>
+                <a:ea typeface="Arial"/>
+                <a:cs typeface="Arial"/>
+              </a:defRPr>
+            </a:defPPr>
+            <a:lvl1pPr>
+              <a:defRPr sz="2025" b="1">
+                <a:solidFill>
+                  <a:srgbClr val="DCFA6B"/>
+                </a:solidFill>
+                <a:latin typeface="Arial"/>
+                <a:ea typeface="Arial"/>
+                <a:cs typeface="Arial"/>
+              </a:defRPr>
+            </a:lvl1pPr>
+            <a:lvl2pPr>
+              <a:defRPr sz="2025" b="1">
+                <a:solidFill>
+                  <a:srgbClr val="DCFA6B"/>
+                </a:solidFill>
+                <a:latin typeface="Arial"/>
+                <a:ea typeface="Arial"/>
+                <a:cs typeface="Arial"/>
+              </a:defRPr>
+            </a:lvl2pPr>
+            <a:lvl3pPr>
+              <a:defRPr sz="2025" b="1">
+                <a:solidFill>
+                  <a:srgbClr val="DCFA6B"/>
+                </a:solidFill>
+                <a:latin typeface="Arial"/>
+                <a:ea typeface="Arial"/>
+                <a:cs typeface="Arial"/>
+              </a:defRPr>
+            </a:lvl3pPr>
+            <a:lvl4pPr>
+              <a:defRPr sz="2025" b="1">
+                <a:solidFill>
+                  <a:srgbClr val="DCFA6B"/>
+                </a:solidFill>
+                <a:latin typeface="Arial"/>
+                <a:ea typeface="Arial"/>
+                <a:cs typeface="Arial"/>
+              </a:defRPr>
+            </a:lvl4pPr>
+            <a:lvl5pPr>
+              <a:defRPr sz="2025" b="1">
+                <a:solidFill>
+                  <a:srgbClr val="DCFA6B"/>
+                </a:solidFill>
+                <a:latin typeface="Arial"/>
+                <a:ea typeface="Arial"/>
+                <a:cs typeface="Arial"/>
+              </a:defRPr>
+            </a:lvl5pPr>
+            <a:lvl6pPr>
+              <a:defRPr sz="2025" b="1">
+                <a:solidFill>
+                  <a:srgbClr val="DCFA6B"/>
+                </a:solidFill>
+                <a:latin typeface="Arial"/>
+                <a:ea typeface="Arial"/>
+                <a:cs typeface="Arial"/>
+              </a:defRPr>
+            </a:lvl6pPr>
+            <a:lvl7pPr>
+              <a:defRPr sz="2025" b="1">
+                <a:solidFill>
+                  <a:srgbClr val="DCFA6B"/>
+                </a:solidFill>
+                <a:latin typeface="Arial"/>
+                <a:ea typeface="Arial"/>
+                <a:cs typeface="Arial"/>
+              </a:defRPr>
+            </a:lvl7pPr>
+            <a:lvl8pPr>
+              <a:defRPr sz="2025" b="1">
+                <a:solidFill>
+                  <a:srgbClr val="DCFA6B"/>
+                </a:solidFill>
+                <a:latin typeface="Arial"/>
+                <a:ea typeface="Arial"/>
+                <a:cs typeface="Arial"/>
+              </a:defRPr>
+            </a:lvl8pPr>
+            <a:lvl9pPr>
+              <a:defRPr sz="2025" b="1">
+                <a:solidFill>
+                  <a:srgbClr val="DCFA6B"/>
+                </a:solidFill>
+                <a:latin typeface="Arial"/>
+                <a:ea typeface="Arial"/>
+                <a:cs typeface="Arial"/>
+              </a:defRPr>
+            </a:lvl9pPr>
+          </a:lstStyle>
+          <a:p xmlns:a="http://schemas.openxmlformats.org/drawingml/2006/main">
+            <a:pPr>
+              <a:defRPr sz="2025" b="1">
+                <a:solidFill>
+                  <a:srgbClr val="DCFA6B"/>
+                </a:solidFill>
+                <a:latin typeface="Arial"/>
+                <a:ea typeface="Arial"/>
+                <a:cs typeface="Arial"/>
+              </a:defRPr>
+            </a:pPr>
+            <a:r>
+              <a:rPr sz="2025" b="1">
+                <a:solidFill>
+                  <a:srgbClr val="DCFA6B"/>
+                </a:solidFill>
+                <a:latin typeface="Arial"/>
+                <a:ea typeface="Arial"/>
+                <a:cs typeface="Arial"/>
+              </a:rPr>
+              <a:t>E1  Classifier and detector</a:t>
+            </a:r>
+          </a:p>
+        </p:txBody>
+      </p:sp>
+      <p:sp>
+        <p:nvSpPr>
+          <p:cNvPr id="6" name="Different tasks and metrics. Original run reproduc">
+            <a:extLst xmlns:a="http://schemas.openxmlformats.org/drawingml/2006/main">
+              <a:ext uri="{FF2B5EF4-FFF2-40B4-BE49-F238E27FC236}">
+                <a16:creationId xmlns:a16="http://schemas.microsoft.com/office/drawing/2014/main" id="{9B56E476-7B6D-498B-A294-ED9165026F03}"/>
+              </a:ext>
+            </a:extLst>
+          </p:cNvPr>
+          <p:cNvSpPr>
+            <a:spLocks xmlns:a="http://schemas.openxmlformats.org/drawingml/2006/main" noGrp="1"/>
+          </p:cNvSpPr>
+          <p:nvPr/>
+        </p:nvSpPr>
+        <p:spPr>
+          <a:xfrm xmlns:a="http://schemas.openxmlformats.org/drawingml/2006/main">
+            <a:off x="552450" y="2305050"/>
+            <a:ext cx="11087100" cy="323850"/>
+          </a:xfrm>
+          <a:prstGeom xmlns:a="http://schemas.openxmlformats.org/drawingml/2006/main" prst="rect">
+            <a:avLst/>
+          </a:prstGeom>
+          <a:noFill xmlns:a="http://schemas.openxmlformats.org/drawingml/2006/main"/>
+          <a:ln xmlns:a="http://schemas.openxmlformats.org/drawingml/2006/main" w="0">
+            <a:noFill/>
+          </a:ln>
+        </p:spPr>
+        <p:txBody>
+          <a:bodyPr xmlns:a="http://schemas.openxmlformats.org/drawingml/2006/main" lIns="0" tIns="0" rIns="0" bIns="0"/>
+          <a:lstStyle xmlns:a="http://schemas.openxmlformats.org/drawingml/2006/main">
+            <a:defPPr>
+              <a:defRPr sz="1725" b="0">
+                <a:solidFill>
+                  <a:srgbClr val="A5BDC6"/>
+                </a:solidFill>
+                <a:latin typeface="Arial"/>
+                <a:ea typeface="Arial"/>
+                <a:cs typeface="Arial"/>
+              </a:defRPr>
+            </a:defPPr>
+            <a:lvl1pPr>
+              <a:defRPr sz="1725" b="0">
+                <a:solidFill>
+                  <a:srgbClr val="A5BDC6"/>
+                </a:solidFill>
+                <a:latin typeface="Arial"/>
+                <a:ea typeface="Arial"/>
+                <a:cs typeface="Arial"/>
+              </a:defRPr>
+            </a:lvl1pPr>
+            <a:lvl2pPr>
+              <a:defRPr sz="1725" b="0">
+                <a:solidFill>
+                  <a:srgbClr val="A5BDC6"/>
+                </a:solidFill>
+                <a:latin typeface="Arial"/>
+                <a:ea typeface="Arial"/>
+                <a:cs typeface="Arial"/>
+              </a:defRPr>
+            </a:lvl2pPr>
+            <a:lvl3pPr>
+              <a:defRPr sz="1725" b="0">
+                <a:solidFill>
+                  <a:srgbClr val="A5BDC6"/>
+                </a:solidFill>
+                <a:latin typeface="Arial"/>
+                <a:ea typeface="Arial"/>
+                <a:cs typeface="Arial"/>
+              </a:defRPr>
+            </a:lvl3pPr>
+            <a:lvl4pPr>
+              <a:defRPr sz="1725" b="0">
+                <a:solidFill>
+                  <a:srgbClr val="A5BDC6"/>
+                </a:solidFill>
+                <a:latin typeface="Arial"/>
+                <a:ea typeface="Arial"/>
+                <a:cs typeface="Arial"/>
+              </a:defRPr>
+            </a:lvl4pPr>
+            <a:lvl5pPr>
+              <a:defRPr sz="1725" b="0">
+                <a:solidFill>
+                  <a:srgbClr val="A5BDC6"/>
+                </a:solidFill>
+                <a:latin typeface="Arial"/>
+                <a:ea typeface="Arial"/>
+                <a:cs typeface="Arial"/>
+              </a:defRPr>
+            </a:lvl5pPr>
+            <a:lvl6pPr>
+              <a:defRPr sz="1725" b="0">
+                <a:solidFill>
+                  <a:srgbClr val="A5BDC6"/>
+                </a:solidFill>
+                <a:latin typeface="Arial"/>
+                <a:ea typeface="Arial"/>
+                <a:cs typeface="Arial"/>
+              </a:defRPr>
+            </a:lvl6pPr>
+            <a:lvl7pPr>
+              <a:defRPr sz="1725" b="0">
+                <a:solidFill>
+                  <a:srgbClr val="A5BDC6"/>
+                </a:solidFill>
+                <a:latin typeface="Arial"/>
+                <a:ea typeface="Arial"/>
+                <a:cs typeface="Arial"/>
+              </a:defRPr>
+            </a:lvl7pPr>
+            <a:lvl8pPr>
+              <a:defRPr sz="1725" b="0">
+                <a:solidFill>
+                  <a:srgbClr val="A5BDC6"/>
+                </a:solidFill>
+                <a:latin typeface="Arial"/>
+                <a:ea typeface="Arial"/>
+                <a:cs typeface="Arial"/>
+              </a:defRPr>
+            </a:lvl8pPr>
+            <a:lvl9pPr>
+              <a:defRPr sz="1725" b="0">
+                <a:solidFill>
+                  <a:srgbClr val="A5BDC6"/>
+                </a:solidFill>
+                <a:latin typeface="Arial"/>
+                <a:ea typeface="Arial"/>
+                <a:cs typeface="Arial"/>
+              </a:defRPr>
+            </a:lvl9pPr>
+          </a:lstStyle>
+          <a:p xmlns:a="http://schemas.openxmlformats.org/drawingml/2006/main">
+            <a:pPr>
+              <a:defRPr sz="1725" b="0">
+                <a:solidFill>
+                  <a:srgbClr val="A5BDC6"/>
+                </a:solidFill>
+                <a:latin typeface="Arial"/>
+                <a:ea typeface="Arial"/>
+                <a:cs typeface="Arial"/>
+              </a:defRPr>
+            </a:pPr>
+            <a:r>
+              <a:rPr sz="1725" b="0">
+                <a:solidFill>
+                  <a:srgbClr val="A5BDC6"/>
+                </a:solidFill>
+                <a:latin typeface="Arial"/>
+                <a:ea typeface="Arial"/>
+                <a:cs typeface="Arial"/>
+              </a:rPr>
+              <a:t>Different tasks and metrics. Original run reproducibility is incomplete.</a:t>
+            </a:r>
+          </a:p>
+        </p:txBody>
+      </p:sp>
+      <p:sp>
+        <p:nvSpPr>
+          <p:cNvPr id="7" name="E2  Size and resolution">
+            <a:extLst xmlns:a="http://schemas.openxmlformats.org/drawingml/2006/main">
+              <a:ext uri="{FF2B5EF4-FFF2-40B4-BE49-F238E27FC236}">
+                <a16:creationId xmlns:a16="http://schemas.microsoft.com/office/drawing/2014/main" id="{98C12284-76E4-4D57-BE1C-62A4EFDAA8F3}"/>
+              </a:ext>
+            </a:extLst>
+          </p:cNvPr>
+          <p:cNvSpPr>
+            <a:spLocks xmlns:a="http://schemas.openxmlformats.org/drawingml/2006/main" noGrp="1"/>
+          </p:cNvSpPr>
+          <p:nvPr/>
+        </p:nvSpPr>
+        <p:spPr>
+          <a:xfrm xmlns:a="http://schemas.openxmlformats.org/drawingml/2006/main">
+            <a:off x="552450" y="2714625"/>
+            <a:ext cx="11087100" cy="323850"/>
+          </a:xfrm>
+          <a:prstGeom xmlns:a="http://schemas.openxmlformats.org/drawingml/2006/main" prst="rect">
+            <a:avLst/>
+          </a:prstGeom>
+          <a:noFill xmlns:a="http://schemas.openxmlformats.org/drawingml/2006/main"/>
+          <a:ln xmlns:a="http://schemas.openxmlformats.org/drawingml/2006/main" w="0">
+            <a:noFill/>
+          </a:ln>
+        </p:spPr>
+        <p:txBody>
+          <a:bodyPr xmlns:a="http://schemas.openxmlformats.org/drawingml/2006/main" lIns="0" tIns="0" rIns="0" bIns="0"/>
+          <a:lstStyle xmlns:a="http://schemas.openxmlformats.org/drawingml/2006/main">
+            <a:defPPr>
+              <a:defRPr sz="2025" b="1">
+                <a:solidFill>
+                  <a:srgbClr val="DCFA6B"/>
+                </a:solidFill>
+                <a:latin typeface="Arial"/>
+                <a:ea typeface="Arial"/>
+                <a:cs typeface="Arial"/>
+              </a:defRPr>
+            </a:defPPr>
+            <a:lvl1pPr>
+              <a:defRPr sz="2025" b="1">
+                <a:solidFill>
+                  <a:srgbClr val="DCFA6B"/>
+                </a:solidFill>
+                <a:latin typeface="Arial"/>
+                <a:ea typeface="Arial"/>
+                <a:cs typeface="Arial"/>
+              </a:defRPr>
+            </a:lvl1pPr>
+            <a:lvl2pPr>
+              <a:defRPr sz="2025" b="1">
+                <a:solidFill>
+                  <a:srgbClr val="DCFA6B"/>
+                </a:solidFill>
+                <a:latin typeface="Arial"/>
+                <a:ea typeface="Arial"/>
+                <a:cs typeface="Arial"/>
+              </a:defRPr>
+            </a:lvl2pPr>
+            <a:lvl3pPr>
+              <a:defRPr sz="2025" b="1">
+                <a:solidFill>
+                  <a:srgbClr val="DCFA6B"/>
+                </a:solidFill>
+                <a:latin typeface="Arial"/>
+                <a:ea typeface="Arial"/>
+                <a:cs typeface="Arial"/>
+              </a:defRPr>
+            </a:lvl3pPr>
+            <a:lvl4pPr>
+              <a:defRPr sz="2025" b="1">
+                <a:solidFill>
+                  <a:srgbClr val="DCFA6B"/>
+                </a:solidFill>
+                <a:latin typeface="Arial"/>
+                <a:ea typeface="Arial"/>
+                <a:cs typeface="Arial"/>
+              </a:defRPr>
+            </a:lvl4pPr>
+            <a:lvl5pPr>
+              <a:defRPr sz="2025" b="1">
+                <a:solidFill>
+                  <a:srgbClr val="DCFA6B"/>
+                </a:solidFill>
+                <a:latin typeface="Arial"/>
+                <a:ea typeface="Arial"/>
+                <a:cs typeface="Arial"/>
+              </a:defRPr>
+            </a:lvl5pPr>
+            <a:lvl6pPr>
+              <a:defRPr sz="2025" b="1">
+                <a:solidFill>
+                  <a:srgbClr val="DCFA6B"/>
+                </a:solidFill>
+                <a:latin typeface="Arial"/>
+                <a:ea typeface="Arial"/>
+                <a:cs typeface="Arial"/>
+              </a:defRPr>
+            </a:lvl6pPr>
+            <a:lvl7pPr>
+              <a:defRPr sz="2025" b="1">
+                <a:solidFill>
+                  <a:srgbClr val="DCFA6B"/>
+                </a:solidFill>
+                <a:latin typeface="Arial"/>
+                <a:ea typeface="Arial"/>
+                <a:cs typeface="Arial"/>
+              </a:defRPr>
+            </a:lvl7pPr>
+            <a:lvl8pPr>
+              <a:defRPr sz="2025" b="1">
+                <a:solidFill>
+                  <a:srgbClr val="DCFA6B"/>
+                </a:solidFill>
+                <a:latin typeface="Arial"/>
+                <a:ea typeface="Arial"/>
+                <a:cs typeface="Arial"/>
+              </a:defRPr>
+            </a:lvl8pPr>
+            <a:lvl9pPr>
+              <a:defRPr sz="2025" b="1">
+                <a:solidFill>
+                  <a:srgbClr val="DCFA6B"/>
+                </a:solidFill>
+                <a:latin typeface="Arial"/>
+                <a:ea typeface="Arial"/>
+                <a:cs typeface="Arial"/>
+              </a:defRPr>
+            </a:lvl9pPr>
+          </a:lstStyle>
+          <a:p xmlns:a="http://schemas.openxmlformats.org/drawingml/2006/main">
+            <a:pPr>
+              <a:defRPr sz="2025" b="1">
+                <a:solidFill>
+                  <a:srgbClr val="DCFA6B"/>
+                </a:solidFill>
+                <a:latin typeface="Arial"/>
+                <a:ea typeface="Arial"/>
+                <a:cs typeface="Arial"/>
+              </a:defRPr>
+            </a:pPr>
+            <a:r>
+              <a:rPr sz="2025" b="1">
+                <a:solidFill>
+                  <a:srgbClr val="DCFA6B"/>
+                </a:solidFill>
+                <a:latin typeface="Arial"/>
+                <a:ea typeface="Arial"/>
+                <a:cs typeface="Arial"/>
+              </a:rPr>
+              <a:t>E2  Size and resolution</a:t>
+            </a:r>
+          </a:p>
+        </p:txBody>
+      </p:sp>
+      <p:sp>
+        <p:nvSpPr>
+          <p:cNvPr id="8" name="Reported accuracy trade-offs. Comparable CPU laten">
+            <a:extLst xmlns:a="http://schemas.openxmlformats.org/drawingml/2006/main">
+              <a:ext uri="{FF2B5EF4-FFF2-40B4-BE49-F238E27FC236}">
+                <a16:creationId xmlns:a16="http://schemas.microsoft.com/office/drawing/2014/main" id="{E91FD08F-9FB8-4E01-B272-786EA4B3CA7B}"/>
+              </a:ext>
+            </a:extLst>
+          </p:cNvPr>
+          <p:cNvSpPr>
+            <a:spLocks xmlns:a="http://schemas.openxmlformats.org/drawingml/2006/main" noGrp="1"/>
+          </p:cNvSpPr>
+          <p:nvPr/>
+        </p:nvSpPr>
+        <p:spPr>
+          <a:xfrm xmlns:a="http://schemas.openxmlformats.org/drawingml/2006/main">
+            <a:off x="552450" y="3086100"/>
+            <a:ext cx="11087100" cy="323850"/>
+          </a:xfrm>
+          <a:prstGeom xmlns:a="http://schemas.openxmlformats.org/drawingml/2006/main" prst="rect">
+            <a:avLst/>
+          </a:prstGeom>
+          <a:noFill xmlns:a="http://schemas.openxmlformats.org/drawingml/2006/main"/>
+          <a:ln xmlns:a="http://schemas.openxmlformats.org/drawingml/2006/main" w="0">
+            <a:noFill/>
+          </a:ln>
+        </p:spPr>
+        <p:txBody>
+          <a:bodyPr xmlns:a="http://schemas.openxmlformats.org/drawingml/2006/main" lIns="0" tIns="0" rIns="0" bIns="0"/>
+          <a:lstStyle xmlns:a="http://schemas.openxmlformats.org/drawingml/2006/main">
+            <a:defPPr>
+              <a:defRPr sz="1725" b="0">
+                <a:solidFill>
+                  <a:srgbClr val="A5BDC6"/>
+                </a:solidFill>
+                <a:latin typeface="Arial"/>
+                <a:ea typeface="Arial"/>
+                <a:cs typeface="Arial"/>
+              </a:defRPr>
+            </a:defPPr>
+            <a:lvl1pPr>
+              <a:defRPr sz="1725" b="0">
+                <a:solidFill>
+                  <a:srgbClr val="A5BDC6"/>
+                </a:solidFill>
+                <a:latin typeface="Arial"/>
+                <a:ea typeface="Arial"/>
+                <a:cs typeface="Arial"/>
+              </a:defRPr>
+            </a:lvl1pPr>
+            <a:lvl2pPr>
+              <a:defRPr sz="1725" b="0">
+                <a:solidFill>
+                  <a:srgbClr val="A5BDC6"/>
+                </a:solidFill>
+                <a:latin typeface="Arial"/>
+                <a:ea typeface="Arial"/>
+                <a:cs typeface="Arial"/>
+              </a:defRPr>
+            </a:lvl2pPr>
+            <a:lvl3pPr>
+              <a:defRPr sz="1725" b="0">
+                <a:solidFill>
+                  <a:srgbClr val="A5BDC6"/>
+                </a:solidFill>
+                <a:latin typeface="Arial"/>
+                <a:ea typeface="Arial"/>
+                <a:cs typeface="Arial"/>
+              </a:defRPr>
+            </a:lvl3pPr>
+            <a:lvl4pPr>
+              <a:defRPr sz="1725" b="0">
+                <a:solidFill>
+                  <a:srgbClr val="A5BDC6"/>
+                </a:solidFill>
+                <a:latin typeface="Arial"/>
+                <a:ea typeface="Arial"/>
+                <a:cs typeface="Arial"/>
+              </a:defRPr>
+            </a:lvl4pPr>
+            <a:lvl5pPr>
+              <a:defRPr sz="1725" b="0">
+                <a:solidFill>
+                  <a:srgbClr val="A5BDC6"/>
+                </a:solidFill>
+                <a:latin typeface="Arial"/>
+                <a:ea typeface="Arial"/>
+                <a:cs typeface="Arial"/>
+              </a:defRPr>
+            </a:lvl5pPr>
+            <a:lvl6pPr>
+              <a:defRPr sz="1725" b="0">
+                <a:solidFill>
+                  <a:srgbClr val="A5BDC6"/>
+                </a:solidFill>
+                <a:latin typeface="Arial"/>
+                <a:ea typeface="Arial"/>
+                <a:cs typeface="Arial"/>
+              </a:defRPr>
+            </a:lvl6pPr>
+            <a:lvl7pPr>
+              <a:defRPr sz="1725" b="0">
+                <a:solidFill>
+                  <a:srgbClr val="A5BDC6"/>
+                </a:solidFill>
+                <a:latin typeface="Arial"/>
+                <a:ea typeface="Arial"/>
+                <a:cs typeface="Arial"/>
+              </a:defRPr>
+            </a:lvl7pPr>
+            <a:lvl8pPr>
+              <a:defRPr sz="1725" b="0">
+                <a:solidFill>
+                  <a:srgbClr val="A5BDC6"/>
+                </a:solidFill>
+                <a:latin typeface="Arial"/>
+                <a:ea typeface="Arial"/>
+                <a:cs typeface="Arial"/>
+              </a:defRPr>
+            </a:lvl8pPr>
+            <a:lvl9pPr>
+              <a:defRPr sz="1725" b="0">
+                <a:solidFill>
+                  <a:srgbClr val="A5BDC6"/>
+                </a:solidFill>
+                <a:latin typeface="Arial"/>
+                <a:ea typeface="Arial"/>
+                <a:cs typeface="Arial"/>
+              </a:defRPr>
+            </a:lvl9pPr>
+          </a:lstStyle>
+          <a:p xmlns:a="http://schemas.openxmlformats.org/drawingml/2006/main">
+            <a:pPr>
+              <a:defRPr sz="1725" b="0">
+                <a:solidFill>
+                  <a:srgbClr val="A5BDC6"/>
+                </a:solidFill>
+                <a:latin typeface="Arial"/>
+                <a:ea typeface="Arial"/>
+                <a:cs typeface="Arial"/>
+              </a:defRPr>
+            </a:pPr>
+            <a:r>
+              <a:rPr sz="1725" b="0">
+                <a:solidFill>
+                  <a:srgbClr val="A5BDC6"/>
+                </a:solidFill>
+                <a:latin typeface="Arial"/>
+                <a:ea typeface="Arial"/>
+                <a:cs typeface="Arial"/>
+              </a:rPr>
+              <a:t>Reported accuracy trade-offs. Comparable CPU latency is still needed.</a:t>
+            </a:r>
+          </a:p>
+        </p:txBody>
+      </p:sp>
+      <p:sp>
+        <p:nvSpPr>
+          <p:cNvPr id="9" name="E3  Augmentation">
+            <a:extLst xmlns:a="http://schemas.openxmlformats.org/drawingml/2006/main">
+              <a:ext uri="{FF2B5EF4-FFF2-40B4-BE49-F238E27FC236}">
+                <a16:creationId xmlns:a16="http://schemas.microsoft.com/office/drawing/2014/main" id="{E35DA318-299C-4104-A323-FDE0040B80C6}"/>
+              </a:ext>
+            </a:extLst>
+          </p:cNvPr>
+          <p:cNvSpPr>
+            <a:spLocks xmlns:a="http://schemas.openxmlformats.org/drawingml/2006/main" noGrp="1"/>
+          </p:cNvSpPr>
+          <p:nvPr/>
+        </p:nvSpPr>
+        <p:spPr>
+          <a:xfrm xmlns:a="http://schemas.openxmlformats.org/drawingml/2006/main">
+            <a:off x="552450" y="3495675"/>
+            <a:ext cx="11087100" cy="323850"/>
+          </a:xfrm>
+          <a:prstGeom xmlns:a="http://schemas.openxmlformats.org/drawingml/2006/main" prst="rect">
+            <a:avLst/>
+          </a:prstGeom>
+          <a:noFill xmlns:a="http://schemas.openxmlformats.org/drawingml/2006/main"/>
+          <a:ln xmlns:a="http://schemas.openxmlformats.org/drawingml/2006/main" w="0">
+            <a:noFill/>
+          </a:ln>
+        </p:spPr>
+        <p:txBody>
+          <a:bodyPr xmlns:a="http://schemas.openxmlformats.org/drawingml/2006/main" lIns="0" tIns="0" rIns="0" bIns="0"/>
+          <a:lstStyle xmlns:a="http://schemas.openxmlformats.org/drawingml/2006/main">
+            <a:defPPr>
+              <a:defRPr sz="2025" b="1">
+                <a:solidFill>
+                  <a:srgbClr val="DCFA6B"/>
+                </a:solidFill>
+                <a:latin typeface="Arial"/>
+                <a:ea typeface="Arial"/>
+                <a:cs typeface="Arial"/>
+              </a:defRPr>
+            </a:defPPr>
+            <a:lvl1pPr>
+              <a:defRPr sz="2025" b="1">
+                <a:solidFill>
+                  <a:srgbClr val="DCFA6B"/>
+                </a:solidFill>
+                <a:latin typeface="Arial"/>
+                <a:ea typeface="Arial"/>
+                <a:cs typeface="Arial"/>
+              </a:defRPr>
+            </a:lvl1pPr>
+            <a:lvl2pPr>
+              <a:defRPr sz="2025" b="1">
+                <a:solidFill>
+                  <a:srgbClr val="DCFA6B"/>
+                </a:solidFill>
+                <a:latin typeface="Arial"/>
+                <a:ea typeface="Arial"/>
+                <a:cs typeface="Arial"/>
+              </a:defRPr>
+            </a:lvl2pPr>
+            <a:lvl3pPr>
+              <a:defRPr sz="2025" b="1">
+                <a:solidFill>
+                  <a:srgbClr val="DCFA6B"/>
+                </a:solidFill>
+                <a:latin typeface="Arial"/>
+                <a:ea typeface="Arial"/>
+                <a:cs typeface="Arial"/>
+              </a:defRPr>
+            </a:lvl3pPr>
+            <a:lvl4pPr>
+              <a:defRPr sz="2025" b="1">
+                <a:solidFill>
+                  <a:srgbClr val="DCFA6B"/>
+                </a:solidFill>
+                <a:latin typeface="Arial"/>
+                <a:ea typeface="Arial"/>
+                <a:cs typeface="Arial"/>
+              </a:defRPr>
+            </a:lvl4pPr>
+            <a:lvl5pPr>
+              <a:defRPr sz="2025" b="1">
+                <a:solidFill>
+                  <a:srgbClr val="DCFA6B"/>
+                </a:solidFill>
+                <a:latin typeface="Arial"/>
+                <a:ea typeface="Arial"/>
+                <a:cs typeface="Arial"/>
+              </a:defRPr>
+            </a:lvl5pPr>
+            <a:lvl6pPr>
+              <a:defRPr sz="2025" b="1">
+                <a:solidFill>
+                  <a:srgbClr val="DCFA6B"/>
+                </a:solidFill>
+                <a:latin typeface="Arial"/>
+                <a:ea typeface="Arial"/>
+                <a:cs typeface="Arial"/>
+              </a:defRPr>
+            </a:lvl6pPr>
+            <a:lvl7pPr>
+              <a:defRPr sz="2025" b="1">
+                <a:solidFill>
+                  <a:srgbClr val="DCFA6B"/>
+                </a:solidFill>
+                <a:latin typeface="Arial"/>
+                <a:ea typeface="Arial"/>
+                <a:cs typeface="Arial"/>
+              </a:defRPr>
+            </a:lvl7pPr>
+            <a:lvl8pPr>
+              <a:defRPr sz="2025" b="1">
+                <a:solidFill>
+                  <a:srgbClr val="DCFA6B"/>
+                </a:solidFill>
+                <a:latin typeface="Arial"/>
+                <a:ea typeface="Arial"/>
+                <a:cs typeface="Arial"/>
+              </a:defRPr>
+            </a:lvl8pPr>
+            <a:lvl9pPr>
+              <a:defRPr sz="2025" b="1">
+                <a:solidFill>
+                  <a:srgbClr val="DCFA6B"/>
+                </a:solidFill>
+                <a:latin typeface="Arial"/>
+                <a:ea typeface="Arial"/>
+                <a:cs typeface="Arial"/>
+              </a:defRPr>
+            </a:lvl9pPr>
+          </a:lstStyle>
+          <a:p xmlns:a="http://schemas.openxmlformats.org/drawingml/2006/main">
+            <a:pPr>
+              <a:defRPr sz="2025" b="1">
+                <a:solidFill>
+                  <a:srgbClr val="DCFA6B"/>
+                </a:solidFill>
+                <a:latin typeface="Arial"/>
+                <a:ea typeface="Arial"/>
+                <a:cs typeface="Arial"/>
+              </a:defRPr>
+            </a:pPr>
+            <a:r>
+              <a:rPr sz="2025" b="1">
+                <a:solidFill>
+                  <a:srgbClr val="DCFA6B"/>
+                </a:solidFill>
+                <a:latin typeface="Arial"/>
+                <a:ea typeface="Arial"/>
+                <a:cs typeface="Arial"/>
+              </a:rPr>
+              <a:t>E3  Augmentation</a:t>
+            </a:r>
+          </a:p>
+        </p:txBody>
+      </p:sp>
+      <p:sp>
+        <p:nvSpPr>
+          <p:cNvPr id="10" name="Saved ablations include no augmentation and vertic">
+            <a:extLst xmlns:a="http://schemas.openxmlformats.org/drawingml/2006/main">
+              <a:ext uri="{FF2B5EF4-FFF2-40B4-BE49-F238E27FC236}">
+                <a16:creationId xmlns:a16="http://schemas.microsoft.com/office/drawing/2014/main" id="{F45A4200-00D4-4E41-AD71-F63411F26F06}"/>
+              </a:ext>
+            </a:extLst>
+          </p:cNvPr>
+          <p:cNvSpPr>
+            <a:spLocks xmlns:a="http://schemas.openxmlformats.org/drawingml/2006/main" noGrp="1"/>
+          </p:cNvSpPr>
+          <p:nvPr/>
+        </p:nvSpPr>
+        <p:spPr>
+          <a:xfrm xmlns:a="http://schemas.openxmlformats.org/drawingml/2006/main">
+            <a:off x="552450" y="3867150"/>
+            <a:ext cx="11087100" cy="323850"/>
+          </a:xfrm>
+          <a:prstGeom xmlns:a="http://schemas.openxmlformats.org/drawingml/2006/main" prst="rect">
+            <a:avLst/>
+          </a:prstGeom>
+          <a:noFill xmlns:a="http://schemas.openxmlformats.org/drawingml/2006/main"/>
+          <a:ln xmlns:a="http://schemas.openxmlformats.org/drawingml/2006/main" w="0">
+            <a:noFill/>
+          </a:ln>
+        </p:spPr>
+        <p:txBody>
+          <a:bodyPr xmlns:a="http://schemas.openxmlformats.org/drawingml/2006/main" lIns="0" tIns="0" rIns="0" bIns="0"/>
+          <a:lstStyle xmlns:a="http://schemas.openxmlformats.org/drawingml/2006/main">
+            <a:defPPr>
+              <a:defRPr sz="1725" b="0">
+                <a:solidFill>
+                  <a:srgbClr val="A5BDC6"/>
+                </a:solidFill>
+                <a:latin typeface="Arial"/>
+                <a:ea typeface="Arial"/>
+                <a:cs typeface="Arial"/>
+              </a:defRPr>
+            </a:defPPr>
+            <a:lvl1pPr>
+              <a:defRPr sz="1725" b="0">
+                <a:solidFill>
+                  <a:srgbClr val="A5BDC6"/>
+                </a:solidFill>
+                <a:latin typeface="Arial"/>
+                <a:ea typeface="Arial"/>
+                <a:cs typeface="Arial"/>
+              </a:defRPr>
+            </a:lvl1pPr>
+            <a:lvl2pPr>
+              <a:defRPr sz="1725" b="0">
+                <a:solidFill>
+                  <a:srgbClr val="A5BDC6"/>
+                </a:solidFill>
+                <a:latin typeface="Arial"/>
+                <a:ea typeface="Arial"/>
+                <a:cs typeface="Arial"/>
+              </a:defRPr>
+            </a:lvl2pPr>
+            <a:lvl3pPr>
+              <a:defRPr sz="1725" b="0">
+                <a:solidFill>
+                  <a:srgbClr val="A5BDC6"/>
+                </a:solidFill>
+                <a:latin typeface="Arial"/>
+                <a:ea typeface="Arial"/>
+                <a:cs typeface="Arial"/>
+              </a:defRPr>
+            </a:lvl3pPr>
+            <a:lvl4pPr>
+              <a:defRPr sz="1725" b="0">
+                <a:solidFill>
+                  <a:srgbClr val="A5BDC6"/>
+                </a:solidFill>
+                <a:latin typeface="Arial"/>
+                <a:ea typeface="Arial"/>
+                <a:cs typeface="Arial"/>
+              </a:defRPr>
+            </a:lvl4pPr>
+            <a:lvl5pPr>
+              <a:defRPr sz="1725" b="0">
+                <a:solidFill>
+                  <a:srgbClr val="A5BDC6"/>
+                </a:solidFill>
+                <a:latin typeface="Arial"/>
+                <a:ea typeface="Arial"/>
+                <a:cs typeface="Arial"/>
+              </a:defRPr>
+            </a:lvl5pPr>
+            <a:lvl6pPr>
+              <a:defRPr sz="1725" b="0">
+                <a:solidFill>
+                  <a:srgbClr val="A5BDC6"/>
+                </a:solidFill>
+                <a:latin typeface="Arial"/>
+                <a:ea typeface="Arial"/>
+                <a:cs typeface="Arial"/>
+              </a:defRPr>
+            </a:lvl6pPr>
+            <a:lvl7pPr>
+              <a:defRPr sz="1725" b="0">
+                <a:solidFill>
+                  <a:srgbClr val="A5BDC6"/>
+                </a:solidFill>
+                <a:latin typeface="Arial"/>
+                <a:ea typeface="Arial"/>
+                <a:cs typeface="Arial"/>
+              </a:defRPr>
+            </a:lvl7pPr>
+            <a:lvl8pPr>
+              <a:defRPr sz="1725" b="0">
+                <a:solidFill>
+                  <a:srgbClr val="A5BDC6"/>
+                </a:solidFill>
+                <a:latin typeface="Arial"/>
+                <a:ea typeface="Arial"/>
+                <a:cs typeface="Arial"/>
+              </a:defRPr>
+            </a:lvl8pPr>
+            <a:lvl9pPr>
+              <a:defRPr sz="1725" b="0">
+                <a:solidFill>
+                  <a:srgbClr val="A5BDC6"/>
+                </a:solidFill>
+                <a:latin typeface="Arial"/>
+                <a:ea typeface="Arial"/>
+                <a:cs typeface="Arial"/>
+              </a:defRPr>
+            </a:lvl9pPr>
+          </a:lstStyle>
+          <a:p xmlns:a="http://schemas.openxmlformats.org/drawingml/2006/main">
+            <a:pPr>
+              <a:defRPr sz="1725" b="0">
+                <a:solidFill>
+                  <a:srgbClr val="A5BDC6"/>
+                </a:solidFill>
+                <a:latin typeface="Arial"/>
+                <a:ea typeface="Arial"/>
+                <a:cs typeface="Arial"/>
+              </a:defRPr>
+            </a:pPr>
+            <a:r>
+              <a:rPr sz="1725" b="0">
+                <a:solidFill>
+                  <a:srgbClr val="A5BDC6"/>
+                </a:solidFill>
+                <a:latin typeface="Arial"/>
+                <a:ea typeface="Arial"/>
+                <a:cs typeface="Arial"/>
+              </a:rPr>
+              <a:t>Saved ablations include no augmentation and vertical flips.</a:t>
+            </a:r>
+          </a:p>
+        </p:txBody>
+      </p:sp>
+      <p:sp>
+        <p:nvSpPr>
+          <p:cNvPr id="11" name="E4  Country and road adaptation">
+            <a:extLst xmlns:a="http://schemas.openxmlformats.org/drawingml/2006/main">
+              <a:ext uri="{FF2B5EF4-FFF2-40B4-BE49-F238E27FC236}">
+                <a16:creationId xmlns:a16="http://schemas.microsoft.com/office/drawing/2014/main" id="{BF0AA104-B561-4760-9472-2DE6271C1F21}"/>
+              </a:ext>
+            </a:extLst>
+          </p:cNvPr>
+          <p:cNvSpPr>
+            <a:spLocks xmlns:a="http://schemas.openxmlformats.org/drawingml/2006/main" noGrp="1"/>
+          </p:cNvSpPr>
+          <p:nvPr/>
+        </p:nvSpPr>
+        <p:spPr>
+          <a:xfrm xmlns:a="http://schemas.openxmlformats.org/drawingml/2006/main">
+            <a:off x="552450" y="4276725"/>
+            <a:ext cx="11087100" cy="323850"/>
+          </a:xfrm>
+          <a:prstGeom xmlns:a="http://schemas.openxmlformats.org/drawingml/2006/main" prst="rect">
+            <a:avLst/>
+          </a:prstGeom>
+          <a:noFill xmlns:a="http://schemas.openxmlformats.org/drawingml/2006/main"/>
+          <a:ln xmlns:a="http://schemas.openxmlformats.org/drawingml/2006/main" w="0">
+            <a:noFill/>
+          </a:ln>
+        </p:spPr>
+        <p:txBody>
+          <a:bodyPr xmlns:a="http://schemas.openxmlformats.org/drawingml/2006/main" lIns="0" tIns="0" rIns="0" bIns="0"/>
+          <a:lstStyle xmlns:a="http://schemas.openxmlformats.org/drawingml/2006/main">
+            <a:defPPr>
+              <a:defRPr sz="2025" b="1">
+                <a:solidFill>
+                  <a:srgbClr val="DCFA6B"/>
+                </a:solidFill>
+                <a:latin typeface="Arial"/>
+                <a:ea typeface="Arial"/>
+                <a:cs typeface="Arial"/>
+              </a:defRPr>
+            </a:defPPr>
+            <a:lvl1pPr>
+              <a:defRPr sz="2025" b="1">
+                <a:solidFill>
+                  <a:srgbClr val="DCFA6B"/>
+                </a:solidFill>
+                <a:latin typeface="Arial"/>
+                <a:ea typeface="Arial"/>
+                <a:cs typeface="Arial"/>
+              </a:defRPr>
+            </a:lvl1pPr>
+            <a:lvl2pPr>
+              <a:defRPr sz="2025" b="1">
+                <a:solidFill>
+                  <a:srgbClr val="DCFA6B"/>
+                </a:solidFill>
+                <a:latin typeface="Arial"/>
+                <a:ea typeface="Arial"/>
+                <a:cs typeface="Arial"/>
+              </a:defRPr>
+            </a:lvl2pPr>
+            <a:lvl3pPr>
+              <a:defRPr sz="2025" b="1">
+                <a:solidFill>
+                  <a:srgbClr val="DCFA6B"/>
+                </a:solidFill>
+                <a:latin typeface="Arial"/>
+                <a:ea typeface="Arial"/>
+                <a:cs typeface="Arial"/>
+              </a:defRPr>
+            </a:lvl3pPr>
+            <a:lvl4pPr>
+              <a:defRPr sz="2025" b="1">
+                <a:solidFill>
+                  <a:srgbClr val="DCFA6B"/>
+                </a:solidFill>
+                <a:latin typeface="Arial"/>
+                <a:ea typeface="Arial"/>
+                <a:cs typeface="Arial"/>
+              </a:defRPr>
+            </a:lvl4pPr>
+            <a:lvl5pPr>
+              <a:defRPr sz="2025" b="1">
+                <a:solidFill>
+                  <a:srgbClr val="DCFA6B"/>
+                </a:solidFill>
+                <a:latin typeface="Arial"/>
+                <a:ea typeface="Arial"/>
+                <a:cs typeface="Arial"/>
+              </a:defRPr>
+            </a:lvl5pPr>
+            <a:lvl6pPr>
+              <a:defRPr sz="2025" b="1">
+                <a:solidFill>
+                  <a:srgbClr val="DCFA6B"/>
+                </a:solidFill>
+                <a:latin typeface="Arial"/>
+                <a:ea typeface="Arial"/>
+                <a:cs typeface="Arial"/>
+              </a:defRPr>
+            </a:lvl6pPr>
+            <a:lvl7pPr>
+              <a:defRPr sz="2025" b="1">
+                <a:solidFill>
+                  <a:srgbClr val="DCFA6B"/>
+                </a:solidFill>
+                <a:latin typeface="Arial"/>
+                <a:ea typeface="Arial"/>
+                <a:cs typeface="Arial"/>
+              </a:defRPr>
+            </a:lvl7pPr>
+            <a:lvl8pPr>
+              <a:defRPr sz="2025" b="1">
+                <a:solidFill>
+                  <a:srgbClr val="DCFA6B"/>
+                </a:solidFill>
+                <a:latin typeface="Arial"/>
+                <a:ea typeface="Arial"/>
+                <a:cs typeface="Arial"/>
+              </a:defRPr>
+            </a:lvl8pPr>
+            <a:lvl9pPr>
+              <a:defRPr sz="2025" b="1">
+                <a:solidFill>
+                  <a:srgbClr val="DCFA6B"/>
+                </a:solidFill>
+                <a:latin typeface="Arial"/>
+                <a:ea typeface="Arial"/>
+                <a:cs typeface="Arial"/>
+              </a:defRPr>
+            </a:lvl9pPr>
+          </a:lstStyle>
+          <a:p xmlns:a="http://schemas.openxmlformats.org/drawingml/2006/main">
+            <a:pPr>
+              <a:defRPr sz="2025" b="1">
+                <a:solidFill>
+                  <a:srgbClr val="DCFA6B"/>
+                </a:solidFill>
+                <a:latin typeface="Arial"/>
+                <a:ea typeface="Arial"/>
+                <a:cs typeface="Arial"/>
+              </a:defRPr>
+            </a:pPr>
+            <a:r>
+              <a:rPr sz="2025" b="1">
+                <a:solidFill>
+                  <a:srgbClr val="DCFA6B"/>
+                </a:solidFill>
+                <a:latin typeface="Arial"/>
+                <a:ea typeface="Arial"/>
+                <a:cs typeface="Arial"/>
+              </a:rPr>
+              <a:t>E4  Country and road adaptation</a:t>
+            </a:r>
+          </a:p>
+        </p:txBody>
+      </p:sp>
+      <p:sp>
+        <p:nvSpPr>
+          <p:cNvPr id="12" name="Near-duplicate leakage limits claims. Saudi field ">
+            <a:extLst xmlns:a="http://schemas.openxmlformats.org/drawingml/2006/main">
+              <a:ext uri="{FF2B5EF4-FFF2-40B4-BE49-F238E27FC236}">
+                <a16:creationId xmlns:a16="http://schemas.microsoft.com/office/drawing/2014/main" id="{9AB09FA5-60ED-4FE0-974A-9F71B5D8628C}"/>
+              </a:ext>
+            </a:extLst>
+          </p:cNvPr>
+          <p:cNvSpPr>
+            <a:spLocks xmlns:a="http://schemas.openxmlformats.org/drawingml/2006/main" noGrp="1"/>
+          </p:cNvSpPr>
+          <p:nvPr/>
+        </p:nvSpPr>
+        <p:spPr>
+          <a:xfrm xmlns:a="http://schemas.openxmlformats.org/drawingml/2006/main">
+            <a:off x="552450" y="4648200"/>
+            <a:ext cx="11087100" cy="323850"/>
+          </a:xfrm>
+          <a:prstGeom xmlns:a="http://schemas.openxmlformats.org/drawingml/2006/main" prst="rect">
+            <a:avLst/>
+          </a:prstGeom>
+          <a:noFill xmlns:a="http://schemas.openxmlformats.org/drawingml/2006/main"/>
+          <a:ln xmlns:a="http://schemas.openxmlformats.org/drawingml/2006/main" w="0">
+            <a:noFill/>
+          </a:ln>
+        </p:spPr>
+        <p:txBody>
+          <a:bodyPr xmlns:a="http://schemas.openxmlformats.org/drawingml/2006/main" lIns="0" tIns="0" rIns="0" bIns="0"/>
+          <a:lstStyle xmlns:a="http://schemas.openxmlformats.org/drawingml/2006/main">
+            <a:defPPr>
+              <a:defRPr sz="1725" b="0">
+                <a:solidFill>
+                  <a:srgbClr val="A5BDC6"/>
+                </a:solidFill>
+                <a:latin typeface="Arial"/>
+                <a:ea typeface="Arial"/>
+                <a:cs typeface="Arial"/>
+              </a:defRPr>
+            </a:defPPr>
+            <a:lvl1pPr>
+              <a:defRPr sz="1725" b="0">
+                <a:solidFill>
+                  <a:srgbClr val="A5BDC6"/>
+                </a:solidFill>
+                <a:latin typeface="Arial"/>
+                <a:ea typeface="Arial"/>
+                <a:cs typeface="Arial"/>
+              </a:defRPr>
+            </a:lvl1pPr>
+            <a:lvl2pPr>
+              <a:defRPr sz="1725" b="0">
+                <a:solidFill>
+                  <a:srgbClr val="A5BDC6"/>
+                </a:solidFill>
+                <a:latin typeface="Arial"/>
+                <a:ea typeface="Arial"/>
+                <a:cs typeface="Arial"/>
+              </a:defRPr>
+            </a:lvl2pPr>
+            <a:lvl3pPr>
+              <a:defRPr sz="1725" b="0">
+                <a:solidFill>
+                  <a:srgbClr val="A5BDC6"/>
+                </a:solidFill>
+                <a:latin typeface="Arial"/>
+                <a:ea typeface="Arial"/>
+                <a:cs typeface="Arial"/>
+              </a:defRPr>
+            </a:lvl3pPr>
+            <a:lvl4pPr>
+              <a:defRPr sz="1725" b="0">
+                <a:solidFill>
+                  <a:srgbClr val="A5BDC6"/>
+                </a:solidFill>
+                <a:latin typeface="Arial"/>
+                <a:ea typeface="Arial"/>
+                <a:cs typeface="Arial"/>
+              </a:defRPr>
+            </a:lvl4pPr>
+            <a:lvl5pPr>
+              <a:defRPr sz="1725" b="0">
+                <a:solidFill>
+                  <a:srgbClr val="A5BDC6"/>
+                </a:solidFill>
+                <a:latin typeface="Arial"/>
+                <a:ea typeface="Arial"/>
+                <a:cs typeface="Arial"/>
+              </a:defRPr>
+            </a:lvl5pPr>
+            <a:lvl6pPr>
+              <a:defRPr sz="1725" b="0">
+                <a:solidFill>
+                  <a:srgbClr val="A5BDC6"/>
+                </a:solidFill>
+                <a:latin typeface="Arial"/>
+                <a:ea typeface="Arial"/>
+                <a:cs typeface="Arial"/>
+              </a:defRPr>
+            </a:lvl6pPr>
+            <a:lvl7pPr>
+              <a:defRPr sz="1725" b="0">
+                <a:solidFill>
+                  <a:srgbClr val="A5BDC6"/>
+                </a:solidFill>
+                <a:latin typeface="Arial"/>
+                <a:ea typeface="Arial"/>
+                <a:cs typeface="Arial"/>
+              </a:defRPr>
+            </a:lvl7pPr>
+            <a:lvl8pPr>
+              <a:defRPr sz="1725" b="0">
+                <a:solidFill>
+                  <a:srgbClr val="A5BDC6"/>
+                </a:solidFill>
+                <a:latin typeface="Arial"/>
+                <a:ea typeface="Arial"/>
+                <a:cs typeface="Arial"/>
+              </a:defRPr>
+            </a:lvl8pPr>
+            <a:lvl9pPr>
+              <a:defRPr sz="1725" b="0">
+                <a:solidFill>
+                  <a:srgbClr val="A5BDC6"/>
+                </a:solidFill>
+                <a:latin typeface="Arial"/>
+                <a:ea typeface="Arial"/>
+                <a:cs typeface="Arial"/>
+              </a:defRPr>
+            </a:lvl9pPr>
+          </a:lstStyle>
+          <a:p xmlns:a="http://schemas.openxmlformats.org/drawingml/2006/main">
+            <a:pPr>
+              <a:defRPr sz="1725" b="0">
+                <a:solidFill>
+                  <a:srgbClr val="A5BDC6"/>
+                </a:solidFill>
+                <a:latin typeface="Arial"/>
+                <a:ea typeface="Arial"/>
+                <a:cs typeface="Arial"/>
+              </a:defRPr>
+            </a:pPr>
+            <a:r>
+              <a:rPr sz="1725" b="0">
+                <a:solidFill>
+                  <a:srgbClr val="A5BDC6"/>
+                </a:solidFill>
+                <a:latin typeface="Arial"/>
+                <a:ea typeface="Arial"/>
+                <a:cs typeface="Arial"/>
+              </a:rPr>
+              <a:t>Near-duplicate leakage limits claims. Saudi field testing is still needed.</a:t>
+            </a:r>
+          </a:p>
+        </p:txBody>
+      </p:sp>
+      <p:sp>
+        <p:nvSpPr>
+          <p:cNvPr id="13" name="E5  Repeated damage">
+            <a:extLst xmlns:a="http://schemas.openxmlformats.org/drawingml/2006/main">
+              <a:ext uri="{FF2B5EF4-FFF2-40B4-BE49-F238E27FC236}">
+                <a16:creationId xmlns:a16="http://schemas.microsoft.com/office/drawing/2014/main" id="{3C901791-55E7-411C-BC92-03768CA03BDD}"/>
+              </a:ext>
+            </a:extLst>
+          </p:cNvPr>
+          <p:cNvSpPr>
+            <a:spLocks xmlns:a="http://schemas.openxmlformats.org/drawingml/2006/main" noGrp="1"/>
+          </p:cNvSpPr>
+          <p:nvPr/>
+        </p:nvSpPr>
+        <p:spPr>
+          <a:xfrm xmlns:a="http://schemas.openxmlformats.org/drawingml/2006/main">
+            <a:off x="552450" y="5057775"/>
+            <a:ext cx="11087100" cy="323850"/>
+          </a:xfrm>
+          <a:prstGeom xmlns:a="http://schemas.openxmlformats.org/drawingml/2006/main" prst="rect">
+            <a:avLst/>
+          </a:prstGeom>
+          <a:noFill xmlns:a="http://schemas.openxmlformats.org/drawingml/2006/main"/>
+          <a:ln xmlns:a="http://schemas.openxmlformats.org/drawingml/2006/main" w="0">
+            <a:noFill/>
+          </a:ln>
+        </p:spPr>
+        <p:txBody>
+          <a:bodyPr xmlns:a="http://schemas.openxmlformats.org/drawingml/2006/main" lIns="0" tIns="0" rIns="0" bIns="0"/>
+          <a:lstStyle xmlns:a="http://schemas.openxmlformats.org/drawingml/2006/main">
+            <a:defPPr>
+              <a:defRPr sz="2025" b="1">
+                <a:solidFill>
+                  <a:srgbClr val="DCFA6B"/>
+                </a:solidFill>
+                <a:latin typeface="Arial"/>
+                <a:ea typeface="Arial"/>
+                <a:cs typeface="Arial"/>
+              </a:defRPr>
+            </a:defPPr>
+            <a:lvl1pPr>
+              <a:defRPr sz="2025" b="1">
+                <a:solidFill>
+                  <a:srgbClr val="DCFA6B"/>
+                </a:solidFill>
+                <a:latin typeface="Arial"/>
+                <a:ea typeface="Arial"/>
+                <a:cs typeface="Arial"/>
+              </a:defRPr>
+            </a:lvl1pPr>
+            <a:lvl2pPr>
+              <a:defRPr sz="2025" b="1">
+                <a:solidFill>
+                  <a:srgbClr val="DCFA6B"/>
+                </a:solidFill>
+                <a:latin typeface="Arial"/>
+                <a:ea typeface="Arial"/>
+                <a:cs typeface="Arial"/>
+              </a:defRPr>
+            </a:lvl2pPr>
+            <a:lvl3pPr>
+              <a:defRPr sz="2025" b="1">
+                <a:solidFill>
+                  <a:srgbClr val="DCFA6B"/>
+                </a:solidFill>
+                <a:latin typeface="Arial"/>
+                <a:ea typeface="Arial"/>
+                <a:cs typeface="Arial"/>
+              </a:defRPr>
+            </a:lvl3pPr>
+            <a:lvl4pPr>
+              <a:defRPr sz="2025" b="1">
+                <a:solidFill>
+                  <a:srgbClr val="DCFA6B"/>
+                </a:solidFill>
+                <a:latin typeface="Arial"/>
+                <a:ea typeface="Arial"/>
+                <a:cs typeface="Arial"/>
+              </a:defRPr>
+            </a:lvl4pPr>
+            <a:lvl5pPr>
+              <a:defRPr sz="2025" b="1">
+                <a:solidFill>
+                  <a:srgbClr val="DCFA6B"/>
+                </a:solidFill>
+                <a:latin typeface="Arial"/>
+                <a:ea typeface="Arial"/>
+                <a:cs typeface="Arial"/>
+              </a:defRPr>
+            </a:lvl5pPr>
+            <a:lvl6pPr>
+              <a:defRPr sz="2025" b="1">
+                <a:solidFill>
+                  <a:srgbClr val="DCFA6B"/>
+                </a:solidFill>
+                <a:latin typeface="Arial"/>
+                <a:ea typeface="Arial"/>
+                <a:cs typeface="Arial"/>
+              </a:defRPr>
+            </a:lvl6pPr>
+            <a:lvl7pPr>
+              <a:defRPr sz="2025" b="1">
+                <a:solidFill>
+                  <a:srgbClr val="DCFA6B"/>
+                </a:solidFill>
+                <a:latin typeface="Arial"/>
+                <a:ea typeface="Arial"/>
+                <a:cs typeface="Arial"/>
+              </a:defRPr>
+            </a:lvl7pPr>
+            <a:lvl8pPr>
+              <a:defRPr sz="2025" b="1">
+                <a:solidFill>
+                  <a:srgbClr val="DCFA6B"/>
+                </a:solidFill>
+                <a:latin typeface="Arial"/>
+                <a:ea typeface="Arial"/>
+                <a:cs typeface="Arial"/>
+              </a:defRPr>
+            </a:lvl8pPr>
+            <a:lvl9pPr>
+              <a:defRPr sz="2025" b="1">
+                <a:solidFill>
+                  <a:srgbClr val="DCFA6B"/>
+                </a:solidFill>
+                <a:latin typeface="Arial"/>
+                <a:ea typeface="Arial"/>
+                <a:cs typeface="Arial"/>
+              </a:defRPr>
+            </a:lvl9pPr>
+          </a:lstStyle>
+          <a:p xmlns:a="http://schemas.openxmlformats.org/drawingml/2006/main">
+            <a:pPr>
+              <a:defRPr sz="2025" b="1">
+                <a:solidFill>
+                  <a:srgbClr val="DCFA6B"/>
+                </a:solidFill>
+                <a:latin typeface="Arial"/>
+                <a:ea typeface="Arial"/>
+                <a:cs typeface="Arial"/>
+              </a:defRPr>
+            </a:pPr>
+            <a:r>
+              <a:rPr sz="2025" b="1">
+                <a:solidFill>
+                  <a:srgbClr val="DCFA6B"/>
+                </a:solidFill>
+                <a:latin typeface="Arial"/>
+                <a:ea typeface="Arial"/>
+                <a:cs typeface="Arial"/>
+              </a:rPr>
+              <a:t>E5  Repeated damage</a:t>
+            </a:r>
+          </a:p>
+        </p:txBody>
+      </p:sp>
+      <p:sp>
+        <p:nvSpPr>
+          <p:cNvPr id="14" name="Embedding simulations exist. Real repeat-damage pa">
+            <a:extLst xmlns:a="http://schemas.openxmlformats.org/drawingml/2006/main">
+              <a:ext uri="{FF2B5EF4-FFF2-40B4-BE49-F238E27FC236}">
+                <a16:creationId xmlns:a16="http://schemas.microsoft.com/office/drawing/2014/main" id="{41581E14-C390-4F9A-97CE-001D7F12BC24}"/>
+              </a:ext>
+            </a:extLst>
+          </p:cNvPr>
+          <p:cNvSpPr>
+            <a:spLocks xmlns:a="http://schemas.openxmlformats.org/drawingml/2006/main" noGrp="1"/>
+          </p:cNvSpPr>
+          <p:nvPr/>
+        </p:nvSpPr>
+        <p:spPr>
+          <a:xfrm xmlns:a="http://schemas.openxmlformats.org/drawingml/2006/main">
+            <a:off x="552450" y="5429250"/>
+            <a:ext cx="11087100" cy="323850"/>
+          </a:xfrm>
+          <a:prstGeom xmlns:a="http://schemas.openxmlformats.org/drawingml/2006/main" prst="rect">
+            <a:avLst/>
+          </a:prstGeom>
+          <a:noFill xmlns:a="http://schemas.openxmlformats.org/drawingml/2006/main"/>
+          <a:ln xmlns:a="http://schemas.openxmlformats.org/drawingml/2006/main" w="0">
+            <a:noFill/>
+          </a:ln>
+        </p:spPr>
+        <p:txBody>
+          <a:bodyPr xmlns:a="http://schemas.openxmlformats.org/drawingml/2006/main" lIns="0" tIns="0" rIns="0" bIns="0"/>
+          <a:lstStyle xmlns:a="http://schemas.openxmlformats.org/drawingml/2006/main">
+            <a:defPPr>
+              <a:defRPr sz="1725" b="0">
+                <a:solidFill>
+                  <a:srgbClr val="A5BDC6"/>
+                </a:solidFill>
+                <a:latin typeface="Arial"/>
+                <a:ea typeface="Arial"/>
+                <a:cs typeface="Arial"/>
+              </a:defRPr>
+            </a:defPPr>
+            <a:lvl1pPr>
+              <a:defRPr sz="1725" b="0">
+                <a:solidFill>
+                  <a:srgbClr val="A5BDC6"/>
+                </a:solidFill>
+                <a:latin typeface="Arial"/>
+                <a:ea typeface="Arial"/>
+                <a:cs typeface="Arial"/>
+              </a:defRPr>
+            </a:lvl1pPr>
+            <a:lvl2pPr>
+              <a:defRPr sz="1725" b="0">
+                <a:solidFill>
+                  <a:srgbClr val="A5BDC6"/>
+                </a:solidFill>
+                <a:latin typeface="Arial"/>
+                <a:ea typeface="Arial"/>
+                <a:cs typeface="Arial"/>
+              </a:defRPr>
+            </a:lvl2pPr>
+            <a:lvl3pPr>
+              <a:defRPr sz="1725" b="0">
+                <a:solidFill>
+                  <a:srgbClr val="A5BDC6"/>
+                </a:solidFill>
+                <a:latin typeface="Arial"/>
+                <a:ea typeface="Arial"/>
+                <a:cs typeface="Arial"/>
+              </a:defRPr>
+            </a:lvl3pPr>
+            <a:lvl4pPr>
+              <a:defRPr sz="1725" b="0">
+                <a:solidFill>
+                  <a:srgbClr val="A5BDC6"/>
+                </a:solidFill>
+                <a:latin typeface="Arial"/>
+                <a:ea typeface="Arial"/>
+                <a:cs typeface="Arial"/>
+              </a:defRPr>
+            </a:lvl4pPr>
+            <a:lvl5pPr>
+              <a:defRPr sz="1725" b="0">
+                <a:solidFill>
+                  <a:srgbClr val="A5BDC6"/>
+                </a:solidFill>
+                <a:latin typeface="Arial"/>
+                <a:ea typeface="Arial"/>
+                <a:cs typeface="Arial"/>
+              </a:defRPr>
+            </a:lvl5pPr>
+            <a:lvl6pPr>
+              <a:defRPr sz="1725" b="0">
+                <a:solidFill>
+                  <a:srgbClr val="A5BDC6"/>
+                </a:solidFill>
+                <a:latin typeface="Arial"/>
+                <a:ea typeface="Arial"/>
+                <a:cs typeface="Arial"/>
+              </a:defRPr>
+            </a:lvl6pPr>
+            <a:lvl7pPr>
+              <a:defRPr sz="1725" b="0">
+                <a:solidFill>
+                  <a:srgbClr val="A5BDC6"/>
+                </a:solidFill>
+                <a:latin typeface="Arial"/>
+                <a:ea typeface="Arial"/>
+                <a:cs typeface="Arial"/>
+              </a:defRPr>
+            </a:lvl7pPr>
+            <a:lvl8pPr>
+              <a:defRPr sz="1725" b="0">
+                <a:solidFill>
+                  <a:srgbClr val="A5BDC6"/>
+                </a:solidFill>
+                <a:latin typeface="Arial"/>
+                <a:ea typeface="Arial"/>
+                <a:cs typeface="Arial"/>
+              </a:defRPr>
+            </a:lvl8pPr>
+            <a:lvl9pPr>
+              <a:defRPr sz="1725" b="0">
+                <a:solidFill>
+                  <a:srgbClr val="A5BDC6"/>
+                </a:solidFill>
+                <a:latin typeface="Arial"/>
+                <a:ea typeface="Arial"/>
+                <a:cs typeface="Arial"/>
+              </a:defRPr>
+            </a:lvl9pPr>
+          </a:lstStyle>
+          <a:p xmlns:a="http://schemas.openxmlformats.org/drawingml/2006/main">
+            <a:pPr>
+              <a:defRPr sz="1725" b="0">
+                <a:solidFill>
+                  <a:srgbClr val="A5BDC6"/>
+                </a:solidFill>
+                <a:latin typeface="Arial"/>
+                <a:ea typeface="Arial"/>
+                <a:cs typeface="Arial"/>
+              </a:defRPr>
+            </a:pPr>
+            <a:r>
+              <a:rPr sz="1725" b="0">
+                <a:solidFill>
+                  <a:srgbClr val="A5BDC6"/>
+                </a:solidFill>
+                <a:latin typeface="Arial"/>
+                <a:ea typeface="Arial"/>
+                <a:cs typeface="Arial"/>
+              </a:rPr>
+              <a:t>Embedding simulations exist. Real repeat-damage pairs remain untested.</a:t>
+            </a:r>
+          </a:p>
+        </p:txBody>
+      </p:sp>
+    </p:spTree>
+    <p:extLst>
+      <p:ext uri="{BB962C8B-B14F-4D97-AF65-F5344CB8AC3E}">
+        <p14:creationId xmlns:p14="http://schemas.microsoft.com/office/powerpoint/2010/main" val="482253409"/>
       </p:ext>
     </p:extLst>
   </p:cSld>
@@ -10021,7 +12325,7 @@
           <p:cNvPr id="23" name="">
             <a:extLst xmlns:a="http://schemas.openxmlformats.org/drawingml/2006/main">
               <a:ext uri="{FF2B5EF4-FFF2-40B4-BE49-F238E27FC236}">
-                <a16:creationId xmlns:a16="http://schemas.microsoft.com/office/drawing/2014/main" id="{33AD9631-B747-4F7F-9056-1202334B8E93}"/>
+                <a16:creationId xmlns:a16="http://schemas.microsoft.com/office/drawing/2014/main" id="{04B6DDDF-6B22-4C54-8086-25631DB9B98C}"/>
               </a:ext>
             </a:extLst>
           </p:cNvPr>
@@ -10052,7 +12356,7 @@
           <p:cNvPr id="22" name="">
             <a:extLst xmlns:a="http://schemas.openxmlformats.org/drawingml/2006/main">
               <a:ext uri="{FF2B5EF4-FFF2-40B4-BE49-F238E27FC236}">
-                <a16:creationId xmlns:a16="http://schemas.microsoft.com/office/drawing/2014/main" id="{BE54503E-DE86-44B5-947E-7600526130D0}"/>
+                <a16:creationId xmlns:a16="http://schemas.microsoft.com/office/drawing/2014/main" id="{5267E4B0-06A4-4FD1-9433-C1958FC0567A}"/>
               </a:ext>
             </a:extLst>
           </p:cNvPr>
@@ -10083,7 +12387,7 @@
           <p:cNvPr id="15" name="">
             <a:extLst xmlns:a="http://schemas.openxmlformats.org/drawingml/2006/main">
               <a:ext uri="{FF2B5EF4-FFF2-40B4-BE49-F238E27FC236}">
-                <a16:creationId xmlns:a16="http://schemas.microsoft.com/office/drawing/2014/main" id="{8AA8D15D-75C7-4F82-958C-9317DE9368F5}"/>
+                <a16:creationId xmlns:a16="http://schemas.microsoft.com/office/drawing/2014/main" id="{2ABAAC82-39D1-47A5-8D7A-8017588D9A28}"/>
               </a:ext>
             </a:extLst>
           </p:cNvPr>
@@ -10114,7 +12418,7 @@
           <p:cNvPr id="14" name="">
             <a:extLst xmlns:a="http://schemas.openxmlformats.org/drawingml/2006/main">
               <a:ext uri="{FF2B5EF4-FFF2-40B4-BE49-F238E27FC236}">
-                <a16:creationId xmlns:a16="http://schemas.microsoft.com/office/drawing/2014/main" id="{CDA15F27-30BF-42AA-BC3A-6EBE5113B737}"/>
+                <a16:creationId xmlns:a16="http://schemas.microsoft.com/office/drawing/2014/main" id="{63FC2B2D-5B29-4A4D-B928-E134488FD69E}"/>
               </a:ext>
             </a:extLst>
           </p:cNvPr>
@@ -10145,7 +12449,7 @@
           <p:cNvPr id="27" name="ARCHITECTURE AND DATA FLOW">
             <a:extLst xmlns:a="http://schemas.openxmlformats.org/drawingml/2006/main">
               <a:ext uri="{FF2B5EF4-FFF2-40B4-BE49-F238E27FC236}">
-                <a16:creationId xmlns:a16="http://schemas.microsoft.com/office/drawing/2014/main" id="{B3A71E5D-88A7-4AD7-9A2F-3BEBB4EBA58E}"/>
+                <a16:creationId xmlns:a16="http://schemas.microsoft.com/office/drawing/2014/main" id="{C4ABC656-6BBE-458C-BCBB-9F96C1B385C3}"/>
               </a:ext>
             </a:extLst>
           </p:cNvPr>
@@ -10301,7 +12605,7 @@
           <p:cNvPr id="2" name="How the code connects">
             <a:extLst xmlns:a="http://schemas.openxmlformats.org/drawingml/2006/main">
               <a:ext uri="{FF2B5EF4-FFF2-40B4-BE49-F238E27FC236}">
-                <a16:creationId xmlns:a16="http://schemas.microsoft.com/office/drawing/2014/main" id="{6AB6054F-507F-4342-AD49-7D3C02F3AF76}"/>
+                <a16:creationId xmlns:a16="http://schemas.microsoft.com/office/drawing/2014/main" id="{8FD22CAB-DBA9-4A0F-9849-87446ABA76B4}"/>
               </a:ext>
             </a:extLst>
           </p:cNvPr>
@@ -10457,7 +12761,7 @@
           <p:cNvPr id="3" name="RoadScan / AIEP capstone">
             <a:extLst xmlns:a="http://schemas.openxmlformats.org/drawingml/2006/main">
               <a:ext uri="{FF2B5EF4-FFF2-40B4-BE49-F238E27FC236}">
-                <a16:creationId xmlns:a16="http://schemas.microsoft.com/office/drawing/2014/main" id="{A62FF309-5A28-4C21-AB9D-025C1036BC62}"/>
+                <a16:creationId xmlns:a16="http://schemas.microsoft.com/office/drawing/2014/main" id="{58D8D063-F386-4879-8126-2DB7190AA4B2}"/>
               </a:ext>
             </a:extLst>
           </p:cNvPr>
@@ -10613,7 +12917,7 @@
           <p:cNvPr id="4" name="02">
             <a:extLst xmlns:a="http://schemas.openxmlformats.org/drawingml/2006/main">
               <a:ext uri="{FF2B5EF4-FFF2-40B4-BE49-F238E27FC236}">
-                <a16:creationId xmlns:a16="http://schemas.microsoft.com/office/drawing/2014/main" id="{385D8F31-79BA-400C-B85B-DB35E536250C}"/>
+                <a16:creationId xmlns:a16="http://schemas.microsoft.com/office/drawing/2014/main" id="{832ECC0C-51A1-4C3D-A531-AADCD34CC02C}"/>
               </a:ext>
             </a:extLst>
           </p:cNvPr>
@@ -10769,7 +13073,7 @@
           <p:cNvPr id="5" name="">
             <a:extLst xmlns:a="http://schemas.openxmlformats.org/drawingml/2006/main">
               <a:ext uri="{FF2B5EF4-FFF2-40B4-BE49-F238E27FC236}">
-                <a16:creationId xmlns:a16="http://schemas.microsoft.com/office/drawing/2014/main" id="{B7B327EB-F293-4A49-9BC5-C92F2143F4C9}"/>
+                <a16:creationId xmlns:a16="http://schemas.microsoft.com/office/drawing/2014/main" id="{A003C847-81AC-43C1-9C65-686D359A3B0C}"/>
               </a:ext>
             </a:extLst>
           </p:cNvPr>
@@ -10801,7 +13105,7 @@
           <p:cNvPr id="6" name="Browser">
             <a:extLst xmlns:a="http://schemas.openxmlformats.org/drawingml/2006/main">
               <a:ext uri="{FF2B5EF4-FFF2-40B4-BE49-F238E27FC236}">
-                <a16:creationId xmlns:a16="http://schemas.microsoft.com/office/drawing/2014/main" id="{11A18B2B-AF9D-482B-A2B9-C30B44FF78B3}"/>
+                <a16:creationId xmlns:a16="http://schemas.microsoft.com/office/drawing/2014/main" id="{D090FDB5-2CFB-4EDF-8EBF-DC1988913EA6}"/>
               </a:ext>
             </a:extLst>
           </p:cNvPr>
@@ -10957,7 +13261,7 @@
           <p:cNvPr id="7" name="React + TypeScript&#10;App.tsx / LiveRecognition.tsx">
             <a:extLst xmlns:a="http://schemas.openxmlformats.org/drawingml/2006/main">
               <a:ext uri="{FF2B5EF4-FFF2-40B4-BE49-F238E27FC236}">
-                <a16:creationId xmlns:a16="http://schemas.microsoft.com/office/drawing/2014/main" id="{B491C560-053F-4438-A2BC-C75E7689103B}"/>
+                <a16:creationId xmlns:a16="http://schemas.microsoft.com/office/drawing/2014/main" id="{44861BDC-EDDF-49B0-8730-6A3E4A19DEFF}"/>
               </a:ext>
             </a:extLst>
           </p:cNvPr>
@@ -11136,7 +13440,7 @@
           <p:cNvPr id="8" name="">
             <a:extLst xmlns:a="http://schemas.openxmlformats.org/drawingml/2006/main">
               <a:ext uri="{FF2B5EF4-FFF2-40B4-BE49-F238E27FC236}">
-                <a16:creationId xmlns:a16="http://schemas.microsoft.com/office/drawing/2014/main" id="{EA6959A8-DD7F-4471-9492-4E229FD8DCEA}"/>
+                <a16:creationId xmlns:a16="http://schemas.microsoft.com/office/drawing/2014/main" id="{4C376EFC-A059-415F-90E4-97B811B911FD}"/>
               </a:ext>
             </a:extLst>
           </p:cNvPr>
@@ -11168,7 +13472,7 @@
           <p:cNvPr id="9" name="Request boundary">
             <a:extLst xmlns:a="http://schemas.openxmlformats.org/drawingml/2006/main">
               <a:ext uri="{FF2B5EF4-FFF2-40B4-BE49-F238E27FC236}">
-                <a16:creationId xmlns:a16="http://schemas.microsoft.com/office/drawing/2014/main" id="{3C26864F-0075-4867-B26D-6DC6298B4424}"/>
+                <a16:creationId xmlns:a16="http://schemas.microsoft.com/office/drawing/2014/main" id="{641A95E3-430C-4761-8753-DBFAE7F8DEFE}"/>
               </a:ext>
             </a:extLst>
           </p:cNvPr>
@@ -11324,7 +13628,7 @@
           <p:cNvPr id="10" name="FastAPI / api.py&#10;Input validation + access checks">
             <a:extLst xmlns:a="http://schemas.openxmlformats.org/drawingml/2006/main">
               <a:ext uri="{FF2B5EF4-FFF2-40B4-BE49-F238E27FC236}">
-                <a16:creationId xmlns:a16="http://schemas.microsoft.com/office/drawing/2014/main" id="{518BD2DB-5025-4C7E-B857-70A529C8341E}"/>
+                <a16:creationId xmlns:a16="http://schemas.microsoft.com/office/drawing/2014/main" id="{36517471-E609-413B-BCD9-FC2E041CDAD8}"/>
               </a:ext>
             </a:extLst>
           </p:cNvPr>
@@ -11503,7 +13807,7 @@
           <p:cNvPr id="11" name="">
             <a:extLst xmlns:a="http://schemas.openxmlformats.org/drawingml/2006/main">
               <a:ext uri="{FF2B5EF4-FFF2-40B4-BE49-F238E27FC236}">
-                <a16:creationId xmlns:a16="http://schemas.microsoft.com/office/drawing/2014/main" id="{648D5C7A-E280-4158-8114-946EEAAE9AB3}"/>
+                <a16:creationId xmlns:a16="http://schemas.microsoft.com/office/drawing/2014/main" id="{C70F7B09-BFFF-4E66-B8D1-DBCE514D2E70}"/>
               </a:ext>
             </a:extLst>
           </p:cNvPr>
@@ -11535,7 +13839,7 @@
           <p:cNvPr id="12" name="Local inference">
             <a:extLst xmlns:a="http://schemas.openxmlformats.org/drawingml/2006/main">
               <a:ext uri="{FF2B5EF4-FFF2-40B4-BE49-F238E27FC236}">
-                <a16:creationId xmlns:a16="http://schemas.microsoft.com/office/drawing/2014/main" id="{DE95BDC5-C17F-4C05-80D2-8418C0861AFD}"/>
+                <a16:creationId xmlns:a16="http://schemas.microsoft.com/office/drawing/2014/main" id="{63B46537-D371-4C3B-8AD4-EBCE130B5DF7}"/>
               </a:ext>
             </a:extLst>
           </p:cNvPr>
@@ -11691,7 +13995,7 @@
           <p:cNvPr id="13" name="model_library.py / inference.py&#10;Selected checkpoin">
             <a:extLst xmlns:a="http://schemas.openxmlformats.org/drawingml/2006/main">
               <a:ext uri="{FF2B5EF4-FFF2-40B4-BE49-F238E27FC236}">
-                <a16:creationId xmlns:a16="http://schemas.microsoft.com/office/drawing/2014/main" id="{657D3A4A-B860-49B6-81FB-512489DF7948}"/>
+                <a16:creationId xmlns:a16="http://schemas.microsoft.com/office/drawing/2014/main" id="{F3345094-FFFE-402C-AF01-3B7E581DD188}"/>
               </a:ext>
             </a:extLst>
           </p:cNvPr>
@@ -11870,7 +14174,7 @@
           <p:cNvPr id="16" name="">
             <a:extLst xmlns:a="http://schemas.openxmlformats.org/drawingml/2006/main">
               <a:ext uri="{FF2B5EF4-FFF2-40B4-BE49-F238E27FC236}">
-                <a16:creationId xmlns:a16="http://schemas.microsoft.com/office/drawing/2014/main" id="{673B67B0-A321-4003-A667-733F0F07B80D}"/>
+                <a16:creationId xmlns:a16="http://schemas.microsoft.com/office/drawing/2014/main" id="{7E33BA50-D5AF-4248-A44B-2594AB12EDB4}"/>
               </a:ext>
             </a:extLst>
           </p:cNvPr>
@@ -11902,7 +14206,7 @@
           <p:cNvPr id="17" name="Saved report + review">
             <a:extLst xmlns:a="http://schemas.openxmlformats.org/drawingml/2006/main">
               <a:ext uri="{FF2B5EF4-FFF2-40B4-BE49-F238E27FC236}">
-                <a16:creationId xmlns:a16="http://schemas.microsoft.com/office/drawing/2014/main" id="{2766E25C-AB66-4B06-92C3-13E7947D1A16}"/>
+                <a16:creationId xmlns:a16="http://schemas.microsoft.com/office/drawing/2014/main" id="{896837DD-1747-4951-A9A0-E73434A8E220}"/>
               </a:ext>
             </a:extLst>
           </p:cNvPr>
@@ -12058,7 +14362,7 @@
           <p:cNvPr id="18" name="core.py / review.py / workflow.py&#10;SQLite, image fi">
             <a:extLst xmlns:a="http://schemas.openxmlformats.org/drawingml/2006/main">
               <a:ext uri="{FF2B5EF4-FFF2-40B4-BE49-F238E27FC236}">
-                <a16:creationId xmlns:a16="http://schemas.microsoft.com/office/drawing/2014/main" id="{7317B029-AAFE-4F3F-ABB9-60E02EA4FA61}"/>
+                <a16:creationId xmlns:a16="http://schemas.microsoft.com/office/drawing/2014/main" id="{45CC98E7-F409-4168-81A1-3CC14C34599A}"/>
               </a:ext>
             </a:extLst>
           </p:cNvPr>
@@ -12237,7 +14541,7 @@
           <p:cNvPr id="19" name="">
             <a:extLst xmlns:a="http://schemas.openxmlformats.org/drawingml/2006/main">
               <a:ext uri="{FF2B5EF4-FFF2-40B4-BE49-F238E27FC236}">
-                <a16:creationId xmlns:a16="http://schemas.microsoft.com/office/drawing/2014/main" id="{9EA02F20-4B38-4E06-838A-0C83770D2327}"/>
+                <a16:creationId xmlns:a16="http://schemas.microsoft.com/office/drawing/2014/main" id="{0F687E40-0C69-46CC-8770-6B4EDCA433A5}"/>
               </a:ext>
             </a:extLst>
           </p:cNvPr>
@@ -12269,7 +14573,7 @@
           <p:cNvPr id="20" name="Approved export">
             <a:extLst xmlns:a="http://schemas.openxmlformats.org/drawingml/2006/main">
               <a:ext uri="{FF2B5EF4-FFF2-40B4-BE49-F238E27FC236}">
-                <a16:creationId xmlns:a16="http://schemas.microsoft.com/office/drawing/2014/main" id="{389BCDD1-4C6D-4D33-B550-DEF8EC0D64F6}"/>
+                <a16:creationId xmlns:a16="http://schemas.microsoft.com/office/drawing/2014/main" id="{68D9041D-6761-4489-983D-8D6C4415F2AF}"/>
               </a:ext>
             </a:extLst>
           </p:cNvPr>
@@ -12425,7 +14729,7 @@
           <p:cNvPr id="21" name="training_data.py&#10;Images, labels, splits, provenanc">
             <a:extLst xmlns:a="http://schemas.openxmlformats.org/drawingml/2006/main">
               <a:ext uri="{FF2B5EF4-FFF2-40B4-BE49-F238E27FC236}">
-                <a16:creationId xmlns:a16="http://schemas.microsoft.com/office/drawing/2014/main" id="{084B3A72-1C8D-40C3-925B-0BCE2EE8C216}"/>
+                <a16:creationId xmlns:a16="http://schemas.microsoft.com/office/drawing/2014/main" id="{1FC9D0CA-1770-4702-96F7-B71A4296EB35}"/>
               </a:ext>
             </a:extLst>
           </p:cNvPr>
@@ -12604,7 +14908,7 @@
           <p:cNvPr id="24" name="Temporary frames">
             <a:extLst xmlns:a="http://schemas.openxmlformats.org/drawingml/2006/main">
               <a:ext uri="{FF2B5EF4-FFF2-40B4-BE49-F238E27FC236}">
-                <a16:creationId xmlns:a16="http://schemas.microsoft.com/office/drawing/2014/main" id="{F670F970-4137-4478-B598-9E2DF5953C63}"/>
+                <a16:creationId xmlns:a16="http://schemas.microsoft.com/office/drawing/2014/main" id="{7CF9674E-CBBB-48C4-ABA5-C83F5A7F14D7}"/>
               </a:ext>
             </a:extLst>
           </p:cNvPr>
@@ -12760,7 +15064,7 @@
           <p:cNvPr id="25" name="/api/recognize&#10;persisted: false&#10;Save a frame expli">
             <a:extLst xmlns:a="http://schemas.openxmlformats.org/drawingml/2006/main">
               <a:ext uri="{FF2B5EF4-FFF2-40B4-BE49-F238E27FC236}">
-                <a16:creationId xmlns:a16="http://schemas.microsoft.com/office/drawing/2014/main" id="{6681EF0A-02C0-4426-B34A-336DBE6C7DF5}"/>
+                <a16:creationId xmlns:a16="http://schemas.microsoft.com/office/drawing/2014/main" id="{EB3945AC-31C3-42E7-B8E0-7C4E3102CC9A}"/>
               </a:ext>
             </a:extLst>
           </p:cNvPr>
@@ -12962,7 +15266,7 @@
           <p:cNvPr id="26" name="Model prediction stays separate from the reviewer’">
             <a:extLst xmlns:a="http://schemas.openxmlformats.org/drawingml/2006/main">
               <a:ext uri="{FF2B5EF4-FFF2-40B4-BE49-F238E27FC236}">
-                <a16:creationId xmlns:a16="http://schemas.microsoft.com/office/drawing/2014/main" id="{0CCE55FA-85F7-4169-B487-87B75DE4297C}"/>
+                <a16:creationId xmlns:a16="http://schemas.microsoft.com/office/drawing/2014/main" id="{1B04FBDB-4329-4CE3-9CE9-87DB0166190D}"/>
               </a:ext>
             </a:extLst>
           </p:cNvPr>
@@ -13116,7 +15420,7 @@
     </p:spTree>
     <p:extLst>
       <p:ext uri="{BB962C8B-B14F-4D97-AF65-F5344CB8AC3E}">
-        <p14:creationId xmlns:p14="http://schemas.microsoft.com/office/powerpoint/2010/main" val="241103092"/>
+        <p14:creationId xmlns:p14="http://schemas.microsoft.com/office/powerpoint/2010/main" val="2015894761"/>
       </p:ext>
     </p:extLst>
   </p:cSld>
@@ -13147,7 +15451,7 @@
           <p:cNvPr id="12" name="REVIEW AND MODEL COMPARISON">
             <a:extLst xmlns:a="http://schemas.openxmlformats.org/drawingml/2006/main">
               <a:ext uri="{FF2B5EF4-FFF2-40B4-BE49-F238E27FC236}">
-                <a16:creationId xmlns:a16="http://schemas.microsoft.com/office/drawing/2014/main" id="{B99838E7-2464-49DE-8F2C-73F8D79BA9AF}"/>
+                <a16:creationId xmlns:a16="http://schemas.microsoft.com/office/drawing/2014/main" id="{8C013C40-EBA3-4F54-BB89-B5D7D676A7D6}"/>
               </a:ext>
             </a:extLst>
           </p:cNvPr>
@@ -13303,7 +15607,7 @@
           <p:cNvPr id="2" name="A person makes the final call">
             <a:extLst xmlns:a="http://schemas.openxmlformats.org/drawingml/2006/main">
               <a:ext uri="{FF2B5EF4-FFF2-40B4-BE49-F238E27FC236}">
-                <a16:creationId xmlns:a16="http://schemas.microsoft.com/office/drawing/2014/main" id="{ADBB0967-DC3F-4692-B7EC-805D6AB591C0}"/>
+                <a16:creationId xmlns:a16="http://schemas.microsoft.com/office/drawing/2014/main" id="{CE49C609-6F3E-4A3D-A76D-64E272EA7741}"/>
               </a:ext>
             </a:extLst>
           </p:cNvPr>
@@ -13459,7 +15763,7 @@
           <p:cNvPr id="3" name="RoadScan / AIEP capstone">
             <a:extLst xmlns:a="http://schemas.openxmlformats.org/drawingml/2006/main">
               <a:ext uri="{FF2B5EF4-FFF2-40B4-BE49-F238E27FC236}">
-                <a16:creationId xmlns:a16="http://schemas.microsoft.com/office/drawing/2014/main" id="{5A7184B1-011B-438F-A0EB-7E16B175C418}"/>
+                <a16:creationId xmlns:a16="http://schemas.microsoft.com/office/drawing/2014/main" id="{E8B1A0E9-23EE-42FF-B02A-02261069D455}"/>
               </a:ext>
             </a:extLst>
           </p:cNvPr>
@@ -13615,7 +15919,7 @@
           <p:cNvPr id="4" name="03">
             <a:extLst xmlns:a="http://schemas.openxmlformats.org/drawingml/2006/main">
               <a:ext uri="{FF2B5EF4-FFF2-40B4-BE49-F238E27FC236}">
-                <a16:creationId xmlns:a16="http://schemas.microsoft.com/office/drawing/2014/main" id="{F2CDE979-A287-414B-8299-5110296D832D}"/>
+                <a16:creationId xmlns:a16="http://schemas.microsoft.com/office/drawing/2014/main" id="{5A2D78FC-BF35-4CC6-B545-43F1A6C3A990}"/>
               </a:ext>
             </a:extLst>
           </p:cNvPr>
@@ -13771,7 +16075,7 @@
           <p:cNvPr id="5" name="01  Inspect the boxes">
             <a:extLst xmlns:a="http://schemas.openxmlformats.org/drawingml/2006/main">
               <a:ext uri="{FF2B5EF4-FFF2-40B4-BE49-F238E27FC236}">
-                <a16:creationId xmlns:a16="http://schemas.microsoft.com/office/drawing/2014/main" id="{9A04CF05-3E71-4367-A415-3657C53239AB}"/>
+                <a16:creationId xmlns:a16="http://schemas.microsoft.com/office/drawing/2014/main" id="{9E6D8C61-2199-4D3A-BA18-4C8619A22F66}"/>
               </a:ext>
             </a:extLst>
           </p:cNvPr>
@@ -13927,7 +16231,7 @@
           <p:cNvPr id="6" name="Correct the class and location.&#10;Keep the original ">
             <a:extLst xmlns:a="http://schemas.openxmlformats.org/drawingml/2006/main">
               <a:ext uri="{FF2B5EF4-FFF2-40B4-BE49-F238E27FC236}">
-                <a16:creationId xmlns:a16="http://schemas.microsoft.com/office/drawing/2014/main" id="{E01D0388-5417-4777-806E-43AB8A332CD4}"/>
+                <a16:creationId xmlns:a16="http://schemas.microsoft.com/office/drawing/2014/main" id="{BF06852C-B7DF-41BB-9E79-845E2989B7CD}"/>
               </a:ext>
             </a:extLst>
           </p:cNvPr>
@@ -14106,7 +16410,7 @@
           <p:cNvPr id="7" name="02  Compare model opinions">
             <a:extLst xmlns:a="http://schemas.openxmlformats.org/drawingml/2006/main">
               <a:ext uri="{FF2B5EF4-FFF2-40B4-BE49-F238E27FC236}">
-                <a16:creationId xmlns:a16="http://schemas.microsoft.com/office/drawing/2014/main" id="{FA1713FC-9627-43E2-BB60-6D167EAC250E}"/>
+                <a16:creationId xmlns:a16="http://schemas.microsoft.com/office/drawing/2014/main" id="{04E2FC97-47F5-4CA5-8463-049BEB1F32F8}"/>
               </a:ext>
             </a:extLst>
           </p:cNvPr>
@@ -14262,7 +16566,7 @@
           <p:cNvPr id="8" name="Choose any completed model,&#10;including a minority r">
             <a:extLst xmlns:a="http://schemas.openxmlformats.org/drawingml/2006/main">
               <a:ext uri="{FF2B5EF4-FFF2-40B4-BE49-F238E27FC236}">
-                <a16:creationId xmlns:a16="http://schemas.microsoft.com/office/drawing/2014/main" id="{1A85D539-C870-455B-A7D0-B6CF5CB3931D}"/>
+                <a16:creationId xmlns:a16="http://schemas.microsoft.com/office/drawing/2014/main" id="{92BDA689-6262-4CE1-B6B2-190E2D42255C}"/>
               </a:ext>
             </a:extLst>
           </p:cNvPr>
@@ -14464,7 +16768,7 @@
           <p:cNvPr id="9" name="">
             <a:extLst xmlns:a="http://schemas.openxmlformats.org/drawingml/2006/main">
               <a:ext uri="{FF2B5EF4-FFF2-40B4-BE49-F238E27FC236}">
-                <a16:creationId xmlns:a16="http://schemas.microsoft.com/office/drawing/2014/main" id="{33A823B7-2811-44CA-AE19-5A7C4C7C3452}"/>
+                <a16:creationId xmlns:a16="http://schemas.microsoft.com/office/drawing/2014/main" id="{D470F92B-02CF-4897-80D3-242120406256}"/>
               </a:ext>
             </a:extLst>
           </p:cNvPr>
@@ -14474,7 +16778,7 @@
           <p:nvPr/>
         </p:nvPicPr>
         <p:blipFill>
-          <a:blip xmlns:r="http://schemas.openxmlformats.org/officeDocument/2006/relationships" xmlns:a="http://schemas.openxmlformats.org/drawingml/2006/main" r:embed="Re4dc91ebe5fc40d6"/>
+          <a:blip xmlns:r="http://schemas.openxmlformats.org/officeDocument/2006/relationships" xmlns:a="http://schemas.openxmlformats.org/drawingml/2006/main" r:embed="Rf93c821bbf3f4e25"/>
           <a:srcRect xmlns:a="http://schemas.openxmlformats.org/drawingml/2006/main" l="38700" t="3400" r="0" b="40800"/>
           <a:stretch xmlns:a="http://schemas.openxmlformats.org/drawingml/2006/main"/>
         </p:blipFill>
@@ -14493,7 +16797,7 @@
           <p:cNvPr id="10" name="03  Save the review">
             <a:extLst xmlns:a="http://schemas.openxmlformats.org/drawingml/2006/main">
               <a:ext uri="{FF2B5EF4-FFF2-40B4-BE49-F238E27FC236}">
-                <a16:creationId xmlns:a16="http://schemas.microsoft.com/office/drawing/2014/main" id="{54F08FC3-4D85-4A6A-91A2-BD444E9BAB29}"/>
+                <a16:creationId xmlns:a16="http://schemas.microsoft.com/office/drawing/2014/main" id="{BB77C427-CB95-4DF5-8AC2-9D9DFB1409F1}"/>
               </a:ext>
             </a:extLst>
           </p:cNvPr>
@@ -14649,7 +16953,7 @@
           <p:cNvPr id="11" name="Priority supports triage. It does not measure phys">
             <a:extLst xmlns:a="http://schemas.openxmlformats.org/drawingml/2006/main">
               <a:ext uri="{FF2B5EF4-FFF2-40B4-BE49-F238E27FC236}">
-                <a16:creationId xmlns:a16="http://schemas.microsoft.com/office/drawing/2014/main" id="{F1657056-6390-49EC-B857-19035D8C2A9C}"/>
+                <a16:creationId xmlns:a16="http://schemas.microsoft.com/office/drawing/2014/main" id="{8C143578-14AA-49F5-B8EA-C52C5B4133D1}"/>
               </a:ext>
             </a:extLst>
           </p:cNvPr>
@@ -14803,7 +17107,7 @@
     </p:spTree>
     <p:extLst>
       <p:ext uri="{BB962C8B-B14F-4D97-AF65-F5344CB8AC3E}">
-        <p14:creationId xmlns:p14="http://schemas.microsoft.com/office/powerpoint/2010/main" val="1678003342"/>
+        <p14:creationId xmlns:p14="http://schemas.microsoft.com/office/powerpoint/2010/main" val="1064223644"/>
       </p:ext>
     </p:extLst>
   </p:cSld>
@@ -14834,7 +17138,7 @@
           <p:cNvPr id="9" name="DATA AND TRAINING EVIDENCE">
             <a:extLst xmlns:a="http://schemas.openxmlformats.org/drawingml/2006/main">
               <a:ext uri="{FF2B5EF4-FFF2-40B4-BE49-F238E27FC236}">
-                <a16:creationId xmlns:a16="http://schemas.microsoft.com/office/drawing/2014/main" id="{14D2359A-FB85-4D70-8E2C-D029ED1DFC74}"/>
+                <a16:creationId xmlns:a16="http://schemas.microsoft.com/office/drawing/2014/main" id="{9FC2E04B-6026-408D-B435-9867EAB44805}"/>
               </a:ext>
             </a:extLst>
           </p:cNvPr>
@@ -14990,7 +17294,7 @@
           <p:cNvPr id="2" name="Model results depend on the test set">
             <a:extLst xmlns:a="http://schemas.openxmlformats.org/drawingml/2006/main">
               <a:ext uri="{FF2B5EF4-FFF2-40B4-BE49-F238E27FC236}">
-                <a16:creationId xmlns:a16="http://schemas.microsoft.com/office/drawing/2014/main" id="{93D33889-B6A3-4EBF-9B0C-84FCBC80907E}"/>
+                <a16:creationId xmlns:a16="http://schemas.microsoft.com/office/drawing/2014/main" id="{58D8F9EB-EBCD-45EB-BF4A-268AFC4040F2}"/>
               </a:ext>
             </a:extLst>
           </p:cNvPr>
@@ -15146,7 +17450,7 @@
           <p:cNvPr id="3" name="RoadScan / AIEP capstone">
             <a:extLst xmlns:a="http://schemas.openxmlformats.org/drawingml/2006/main">
               <a:ext uri="{FF2B5EF4-FFF2-40B4-BE49-F238E27FC236}">
-                <a16:creationId xmlns:a16="http://schemas.microsoft.com/office/drawing/2014/main" id="{22B34832-E4DC-4B58-AAD8-A73622F896AA}"/>
+                <a16:creationId xmlns:a16="http://schemas.microsoft.com/office/drawing/2014/main" id="{A7301883-C904-4FAE-A602-2DE894A04FD8}"/>
               </a:ext>
             </a:extLst>
           </p:cNvPr>
@@ -15302,7 +17606,7 @@
           <p:cNvPr id="4" name="04">
             <a:extLst xmlns:a="http://schemas.openxmlformats.org/drawingml/2006/main">
               <a:ext uri="{FF2B5EF4-FFF2-40B4-BE49-F238E27FC236}">
-                <a16:creationId xmlns:a16="http://schemas.microsoft.com/office/drawing/2014/main" id="{6C0D7107-F08C-4B02-9719-E64A6D020343}"/>
+                <a16:creationId xmlns:a16="http://schemas.microsoft.com/office/drawing/2014/main" id="{FFF32168-219D-484D-9CF3-62DB2AF1CCBF}"/>
               </a:ext>
             </a:extLst>
           </p:cNvPr>
@@ -15458,7 +17762,7 @@
           <p:cNvPr id="5" name="">
             <a:extLst xmlns:a="http://schemas.openxmlformats.org/drawingml/2006/main">
               <a:ext uri="{FF2B5EF4-FFF2-40B4-BE49-F238E27FC236}">
-                <a16:creationId xmlns:a16="http://schemas.microsoft.com/office/drawing/2014/main" id="{959DB72B-3A8A-47DC-98D3-3DB8DD302B3C}"/>
+                <a16:creationId xmlns:a16="http://schemas.microsoft.com/office/drawing/2014/main" id="{7A1F0C37-3B76-49AF-BB81-52FF792EB933}"/>
               </a:ext>
             </a:extLst>
           </p:cNvPr>
@@ -16336,7 +18640,7 @@
           <p:cNvPr id="6" name="Baseline: 8,000 train + 1,000 Czech validation + 1">
             <a:extLst xmlns:a="http://schemas.openxmlformats.org/drawingml/2006/main">
               <a:ext uri="{FF2B5EF4-FFF2-40B4-BE49-F238E27FC236}">
-                <a16:creationId xmlns:a16="http://schemas.microsoft.com/office/drawing/2014/main" id="{65192F78-ADCB-47BC-B549-4DE250F50AE0}"/>
+                <a16:creationId xmlns:a16="http://schemas.microsoft.com/office/drawing/2014/main" id="{6D3D3498-F469-44CB-A437-DE627D82D878}"/>
               </a:ext>
             </a:extLst>
           </p:cNvPr>
@@ -16492,7 +18796,7 @@
           <p:cNvPr id="7" name="These rows are separate experiments, not a common-">
             <a:extLst xmlns:a="http://schemas.openxmlformats.org/drawingml/2006/main">
               <a:ext uri="{FF2B5EF4-FFF2-40B4-BE49-F238E27FC236}">
-                <a16:creationId xmlns:a16="http://schemas.microsoft.com/office/drawing/2014/main" id="{E9DF56E0-1E81-402F-9000-84DF55820445}"/>
+                <a16:creationId xmlns:a16="http://schemas.microsoft.com/office/drawing/2014/main" id="{6D8F6043-C7A2-4420-ADDC-37CA80F4F5AB}"/>
               </a:ext>
             </a:extLst>
           </p:cNvPr>
@@ -16648,7 +18952,7 @@
           <p:cNvPr id="8" name="Team data includes reported near-duplicate leakage">
             <a:extLst xmlns:a="http://schemas.openxmlformats.org/drawingml/2006/main">
               <a:ext uri="{FF2B5EF4-FFF2-40B4-BE49-F238E27FC236}">
-                <a16:creationId xmlns:a16="http://schemas.microsoft.com/office/drawing/2014/main" id="{963A5BAA-5214-4208-A1F1-EE635430DECC}"/>
+                <a16:creationId xmlns:a16="http://schemas.microsoft.com/office/drawing/2014/main" id="{90F4966D-8F2A-4897-9BC2-B466D612A33C}"/>
               </a:ext>
             </a:extLst>
           </p:cNvPr>
@@ -16802,7 +19106,7 @@
     </p:spTree>
     <p:extLst>
       <p:ext uri="{BB962C8B-B14F-4D97-AF65-F5344CB8AC3E}">
-        <p14:creationId xmlns:p14="http://schemas.microsoft.com/office/powerpoint/2010/main" val="779302791"/>
+        <p14:creationId xmlns:p14="http://schemas.microsoft.com/office/powerpoint/2010/main" val="2113454964"/>
       </p:ext>
     </p:extLst>
   </p:cSld>
@@ -16833,7 +19137,7 @@
           <p:cNvPr id="28" name="">
             <a:extLst xmlns:a="http://schemas.openxmlformats.org/drawingml/2006/main">
               <a:ext uri="{FF2B5EF4-FFF2-40B4-BE49-F238E27FC236}">
-                <a16:creationId xmlns:a16="http://schemas.microsoft.com/office/drawing/2014/main" id="{FCB344A1-52D4-4143-82E0-F62921A50D4C}"/>
+                <a16:creationId xmlns:a16="http://schemas.microsoft.com/office/drawing/2014/main" id="{D1C33239-7C9F-418B-8F21-B10E99047246}"/>
               </a:ext>
             </a:extLst>
           </p:cNvPr>
@@ -16864,7 +19168,7 @@
           <p:cNvPr id="27" name="">
             <a:extLst xmlns:a="http://schemas.openxmlformats.org/drawingml/2006/main">
               <a:ext uri="{FF2B5EF4-FFF2-40B4-BE49-F238E27FC236}">
-                <a16:creationId xmlns:a16="http://schemas.microsoft.com/office/drawing/2014/main" id="{276DC405-1222-4834-A73F-02CDB854006C}"/>
+                <a16:creationId xmlns:a16="http://schemas.microsoft.com/office/drawing/2014/main" id="{BE28635F-1F85-4680-AABF-6A237562D481}"/>
               </a:ext>
             </a:extLst>
           </p:cNvPr>
@@ -16895,7 +19199,7 @@
           <p:cNvPr id="16" name="">
             <a:extLst xmlns:a="http://schemas.openxmlformats.org/drawingml/2006/main">
               <a:ext uri="{FF2B5EF4-FFF2-40B4-BE49-F238E27FC236}">
-                <a16:creationId xmlns:a16="http://schemas.microsoft.com/office/drawing/2014/main" id="{4F45D7E7-7161-4D28-8A79-2AB4D671B5C7}"/>
+                <a16:creationId xmlns:a16="http://schemas.microsoft.com/office/drawing/2014/main" id="{3071F130-DB04-47EA-949B-7F7A9FD628CF}"/>
               </a:ext>
             </a:extLst>
           </p:cNvPr>
@@ -16926,7 +19230,7 @@
           <p:cNvPr id="15" name="">
             <a:extLst xmlns:a="http://schemas.openxmlformats.org/drawingml/2006/main">
               <a:ext uri="{FF2B5EF4-FFF2-40B4-BE49-F238E27FC236}">
-                <a16:creationId xmlns:a16="http://schemas.microsoft.com/office/drawing/2014/main" id="{BDBC1AC9-6FA5-436E-90D1-0143351FBD10}"/>
+                <a16:creationId xmlns:a16="http://schemas.microsoft.com/office/drawing/2014/main" id="{C256AAA0-E913-410A-A922-4F5A2E402977}"/>
               </a:ext>
             </a:extLst>
           </p:cNvPr>
@@ -16957,7 +19261,7 @@
           <p:cNvPr id="30" name="CAMERA AND UPLOADED VIDEO">
             <a:extLst xmlns:a="http://schemas.openxmlformats.org/drawingml/2006/main">
               <a:ext uri="{FF2B5EF4-FFF2-40B4-BE49-F238E27FC236}">
-                <a16:creationId xmlns:a16="http://schemas.microsoft.com/office/drawing/2014/main" id="{3B08F3C1-9225-43E5-B9F8-29D0BD9F3F03}"/>
+                <a16:creationId xmlns:a16="http://schemas.microsoft.com/office/drawing/2014/main" id="{FD12E9EA-2CBF-4926-B762-CD09D2599FE9}"/>
               </a:ext>
             </a:extLst>
           </p:cNvPr>
@@ -17113,7 +19417,7 @@
           <p:cNvPr id="2" name="Live viewing and complete video analysis">
             <a:extLst xmlns:a="http://schemas.openxmlformats.org/drawingml/2006/main">
               <a:ext uri="{FF2B5EF4-FFF2-40B4-BE49-F238E27FC236}">
-                <a16:creationId xmlns:a16="http://schemas.microsoft.com/office/drawing/2014/main" id="{54B4E1E0-CFE0-4170-87A9-C84E34CAF583}"/>
+                <a16:creationId xmlns:a16="http://schemas.microsoft.com/office/drawing/2014/main" id="{22E5CD58-1176-4AD3-BDEB-1759CBB5F973}"/>
               </a:ext>
             </a:extLst>
           </p:cNvPr>
@@ -17269,7 +19573,7 @@
           <p:cNvPr id="3" name="RoadScan / AIEP capstone">
             <a:extLst xmlns:a="http://schemas.openxmlformats.org/drawingml/2006/main">
               <a:ext uri="{FF2B5EF4-FFF2-40B4-BE49-F238E27FC236}">
-                <a16:creationId xmlns:a16="http://schemas.microsoft.com/office/drawing/2014/main" id="{14870B46-8A17-40BD-A145-5C240CAB8404}"/>
+                <a16:creationId xmlns:a16="http://schemas.microsoft.com/office/drawing/2014/main" id="{DC6E6C77-41C0-4E43-AB2F-EAB54D60EB2B}"/>
               </a:ext>
             </a:extLst>
           </p:cNvPr>
@@ -17425,7 +19729,7 @@
           <p:cNvPr id="4" name="05">
             <a:extLst xmlns:a="http://schemas.openxmlformats.org/drawingml/2006/main">
               <a:ext uri="{FF2B5EF4-FFF2-40B4-BE49-F238E27FC236}">
-                <a16:creationId xmlns:a16="http://schemas.microsoft.com/office/drawing/2014/main" id="{AF95188B-6DCC-4FAB-8735-FAA5594B4C24}"/>
+                <a16:creationId xmlns:a16="http://schemas.microsoft.com/office/drawing/2014/main" id="{39D4E658-7016-4EFC-9ED4-7B5849FD81BB}"/>
               </a:ext>
             </a:extLst>
           </p:cNvPr>
@@ -17581,7 +19885,7 @@
           <p:cNvPr id="5" name="Camera / Iriun / USB">
             <a:extLst xmlns:a="http://schemas.openxmlformats.org/drawingml/2006/main">
               <a:ext uri="{FF2B5EF4-FFF2-40B4-BE49-F238E27FC236}">
-                <a16:creationId xmlns:a16="http://schemas.microsoft.com/office/drawing/2014/main" id="{72CBFAF6-7156-488E-9855-91A14F24C442}"/>
+                <a16:creationId xmlns:a16="http://schemas.microsoft.com/office/drawing/2014/main" id="{0F1CF0E6-3724-4474-9A73-B199CCB00F8D}"/>
               </a:ext>
             </a:extLst>
           </p:cNvPr>
@@ -17737,7 +20041,7 @@
           <p:cNvPr id="6" name="">
             <a:extLst xmlns:a="http://schemas.openxmlformats.org/drawingml/2006/main">
               <a:ext uri="{FF2B5EF4-FFF2-40B4-BE49-F238E27FC236}">
-                <a16:creationId xmlns:a16="http://schemas.microsoft.com/office/drawing/2014/main" id="{B10E571A-4493-4FEB-A246-B2D8FA6EB682}"/>
+                <a16:creationId xmlns:a16="http://schemas.microsoft.com/office/drawing/2014/main" id="{9DBF1C8F-357C-40F2-BDE0-49712F96E86E}"/>
               </a:ext>
             </a:extLst>
           </p:cNvPr>
@@ -17769,7 +20073,7 @@
           <p:cNvPr id="7" name="Current camera frame">
             <a:extLst xmlns:a="http://schemas.openxmlformats.org/drawingml/2006/main">
               <a:ext uri="{FF2B5EF4-FFF2-40B4-BE49-F238E27FC236}">
-                <a16:creationId xmlns:a16="http://schemas.microsoft.com/office/drawing/2014/main" id="{1041D3A7-87CA-4779-B9E8-A9A1C277F3E5}"/>
+                <a16:creationId xmlns:a16="http://schemas.microsoft.com/office/drawing/2014/main" id="{09276CF0-112B-4A4C-BAB0-9B9CEC970ABC}"/>
               </a:ext>
             </a:extLst>
           </p:cNvPr>
@@ -17925,7 +20229,7 @@
           <p:cNvPr id="8" name="Browser captures a fresh frame">
             <a:extLst xmlns:a="http://schemas.openxmlformats.org/drawingml/2006/main">
               <a:ext uri="{FF2B5EF4-FFF2-40B4-BE49-F238E27FC236}">
-                <a16:creationId xmlns:a16="http://schemas.microsoft.com/office/drawing/2014/main" id="{3D122ED9-BFCF-441C-9A41-9556FBE5526E}"/>
+                <a16:creationId xmlns:a16="http://schemas.microsoft.com/office/drawing/2014/main" id="{FF51BD00-2BE7-4E40-8762-B630BC4ED765}"/>
               </a:ext>
             </a:extLst>
           </p:cNvPr>
@@ -18081,7 +20385,7 @@
           <p:cNvPr id="9" name="">
             <a:extLst xmlns:a="http://schemas.openxmlformats.org/drawingml/2006/main">
               <a:ext uri="{FF2B5EF4-FFF2-40B4-BE49-F238E27FC236}">
-                <a16:creationId xmlns:a16="http://schemas.microsoft.com/office/drawing/2014/main" id="{4A05C713-C0DC-4818-8263-EB0CAF356E78}"/>
+                <a16:creationId xmlns:a16="http://schemas.microsoft.com/office/drawing/2014/main" id="{5D66A103-3E44-442E-97A6-2CCE8C43501B}"/>
               </a:ext>
             </a:extLst>
           </p:cNvPr>
@@ -18113,7 +20417,7 @@
           <p:cNvPr id="10" name="Local detector">
             <a:extLst xmlns:a="http://schemas.openxmlformats.org/drawingml/2006/main">
               <a:ext uri="{FF2B5EF4-FFF2-40B4-BE49-F238E27FC236}">
-                <a16:creationId xmlns:a16="http://schemas.microsoft.com/office/drawing/2014/main" id="{DBDD0EEE-5A34-4C76-A911-2F57A06E8547}"/>
+                <a16:creationId xmlns:a16="http://schemas.microsoft.com/office/drawing/2014/main" id="{3FCA34ED-478D-4965-B2C2-B0995E352528}"/>
               </a:ext>
             </a:extLst>
           </p:cNvPr>
@@ -18269,7 +20573,7 @@
           <p:cNvPr id="11" name="One request at a time">
             <a:extLst xmlns:a="http://schemas.openxmlformats.org/drawingml/2006/main">
               <a:ext uri="{FF2B5EF4-FFF2-40B4-BE49-F238E27FC236}">
-                <a16:creationId xmlns:a16="http://schemas.microsoft.com/office/drawing/2014/main" id="{E9C4BCDE-4C14-488C-9BA5-8003E423B736}"/>
+                <a16:creationId xmlns:a16="http://schemas.microsoft.com/office/drawing/2014/main" id="{5A6E01CE-8DF4-4889-8559-6479DECA8309}"/>
               </a:ext>
             </a:extLst>
           </p:cNvPr>
@@ -18425,7 +20729,7 @@
           <p:cNvPr id="12" name="">
             <a:extLst xmlns:a="http://schemas.openxmlformats.org/drawingml/2006/main">
               <a:ext uri="{FF2B5EF4-FFF2-40B4-BE49-F238E27FC236}">
-                <a16:creationId xmlns:a16="http://schemas.microsoft.com/office/drawing/2014/main" id="{540E12E4-0898-44E4-9A49-8A53DE23AF45}"/>
+                <a16:creationId xmlns:a16="http://schemas.microsoft.com/office/drawing/2014/main" id="{E1791F00-D413-4C58-AD7E-E2C246D1C63D}"/>
               </a:ext>
             </a:extLst>
           </p:cNvPr>
@@ -18457,7 +20761,7 @@
           <p:cNvPr id="13" name="Result overlay">
             <a:extLst xmlns:a="http://schemas.openxmlformats.org/drawingml/2006/main">
               <a:ext uri="{FF2B5EF4-FFF2-40B4-BE49-F238E27FC236}">
-                <a16:creationId xmlns:a16="http://schemas.microsoft.com/office/drawing/2014/main" id="{52C6DE89-1CE0-4A9B-8FE1-65DB18AA3FBE}"/>
+                <a16:creationId xmlns:a16="http://schemas.microsoft.com/office/drawing/2014/main" id="{D138D4D6-5CEB-4C68-AECE-50B7B3944356}"/>
               </a:ext>
             </a:extLst>
           </p:cNvPr>
@@ -18613,7 +20917,7 @@
           <p:cNvPr id="14" name="Responsive sampled recognition">
             <a:extLst xmlns:a="http://schemas.openxmlformats.org/drawingml/2006/main">
               <a:ext uri="{FF2B5EF4-FFF2-40B4-BE49-F238E27FC236}">
-                <a16:creationId xmlns:a16="http://schemas.microsoft.com/office/drawing/2014/main" id="{2D3C28CA-E7C1-4865-A2AB-BBC866277CDB}"/>
+                <a16:creationId xmlns:a16="http://schemas.microsoft.com/office/drawing/2014/main" id="{0D65CF7F-08BF-4D85-9F7B-FD1B4B2F83CA}"/>
               </a:ext>
             </a:extLst>
           </p:cNvPr>
@@ -18769,7 +21073,7 @@
           <p:cNvPr id="17" name="Uploaded file: “Analyze every frame”">
             <a:extLst xmlns:a="http://schemas.openxmlformats.org/drawingml/2006/main">
               <a:ext uri="{FF2B5EF4-FFF2-40B4-BE49-F238E27FC236}">
-                <a16:creationId xmlns:a16="http://schemas.microsoft.com/office/drawing/2014/main" id="{120AD9AA-259F-47E5-B9D4-87BF646ADAD4}"/>
+                <a16:creationId xmlns:a16="http://schemas.microsoft.com/office/drawing/2014/main" id="{0219FB9B-4878-4AC0-B0D1-656862096231}"/>
               </a:ext>
             </a:extLst>
           </p:cNvPr>
@@ -18925,7 +21229,7 @@
           <p:cNvPr id="18" name="">
             <a:extLst xmlns:a="http://schemas.openxmlformats.org/drawingml/2006/main">
               <a:ext uri="{FF2B5EF4-FFF2-40B4-BE49-F238E27FC236}">
-                <a16:creationId xmlns:a16="http://schemas.microsoft.com/office/drawing/2014/main" id="{0B3BA6A4-92DB-4ABC-9830-1540B053F6D3}"/>
+                <a16:creationId xmlns:a16="http://schemas.microsoft.com/office/drawing/2014/main" id="{96E1B581-FDBF-4FA2-86B9-1CEB31A6957D}"/>
               </a:ext>
             </a:extLst>
           </p:cNvPr>
@@ -18957,7 +21261,7 @@
           <p:cNvPr id="19" name="Decode next frame">
             <a:extLst xmlns:a="http://schemas.openxmlformats.org/drawingml/2006/main">
               <a:ext uri="{FF2B5EF4-FFF2-40B4-BE49-F238E27FC236}">
-                <a16:creationId xmlns:a16="http://schemas.microsoft.com/office/drawing/2014/main" id="{57F3ACF9-25B7-4820-A12D-112C2A6A3284}"/>
+                <a16:creationId xmlns:a16="http://schemas.microsoft.com/office/drawing/2014/main" id="{D8EFD80C-678D-4FC0-9E3A-6014A39F11B1}"/>
               </a:ext>
             </a:extLst>
           </p:cNvPr>
@@ -19113,7 +21417,7 @@
           <p:cNvPr id="20" name="FullVideoAnalysis.tsx">
             <a:extLst xmlns:a="http://schemas.openxmlformats.org/drawingml/2006/main">
               <a:ext uri="{FF2B5EF4-FFF2-40B4-BE49-F238E27FC236}">
-                <a16:creationId xmlns:a16="http://schemas.microsoft.com/office/drawing/2014/main" id="{2D034820-C8CC-42D3-BEC9-988972C566C9}"/>
+                <a16:creationId xmlns:a16="http://schemas.microsoft.com/office/drawing/2014/main" id="{8B9B7E76-9FB9-4675-897B-0068963F32F0}"/>
               </a:ext>
             </a:extLst>
           </p:cNvPr>
@@ -19269,7 +21573,7 @@
           <p:cNvPr id="21" name="">
             <a:extLst xmlns:a="http://schemas.openxmlformats.org/drawingml/2006/main">
               <a:ext uri="{FF2B5EF4-FFF2-40B4-BE49-F238E27FC236}">
-                <a16:creationId xmlns:a16="http://schemas.microsoft.com/office/drawing/2014/main" id="{0B8546AC-045E-43FD-A524-3905C8B9805B}"/>
+                <a16:creationId xmlns:a16="http://schemas.microsoft.com/office/drawing/2014/main" id="{FD7689F8-D81C-4F33-B85C-9786AACE6EDB}"/>
               </a:ext>
             </a:extLst>
           </p:cNvPr>
@@ -19301,7 +21605,7 @@
           <p:cNvPr id="22" name="Wait for inference">
             <a:extLst xmlns:a="http://schemas.openxmlformats.org/drawingml/2006/main">
               <a:ext uri="{FF2B5EF4-FFF2-40B4-BE49-F238E27FC236}">
-                <a16:creationId xmlns:a16="http://schemas.microsoft.com/office/drawing/2014/main" id="{9C62597A-C601-482E-A6B1-7121E53EBD3C}"/>
+                <a16:creationId xmlns:a16="http://schemas.microsoft.com/office/drawing/2014/main" id="{3305218A-CC40-41D5-A935-804248FE7B20}"/>
               </a:ext>
             </a:extLst>
           </p:cNvPr>
@@ -19457,7 +21761,7 @@
           <p:cNvPr id="23" name="video_analysis.py">
             <a:extLst xmlns:a="http://schemas.openxmlformats.org/drawingml/2006/main">
               <a:ext uri="{FF2B5EF4-FFF2-40B4-BE49-F238E27FC236}">
-                <a16:creationId xmlns:a16="http://schemas.microsoft.com/office/drawing/2014/main" id="{DAB82AAD-785E-4ADB-9DC2-B424F3819809}"/>
+                <a16:creationId xmlns:a16="http://schemas.microsoft.com/office/drawing/2014/main" id="{A17F52AA-20EF-45A0-8A42-887621A7D662}"/>
               </a:ext>
             </a:extLst>
           </p:cNvPr>
@@ -19613,7 +21917,7 @@
           <p:cNvPr id="24" name="">
             <a:extLst xmlns:a="http://schemas.openxmlformats.org/drawingml/2006/main">
               <a:ext uri="{FF2B5EF4-FFF2-40B4-BE49-F238E27FC236}">
-                <a16:creationId xmlns:a16="http://schemas.microsoft.com/office/drawing/2014/main" id="{5A713D0D-59D7-40AE-BB27-87D1DF3DD797}"/>
+                <a16:creationId xmlns:a16="http://schemas.microsoft.com/office/drawing/2014/main" id="{9294CB46-1FD8-4D40-B4E5-49BD80F01BA9}"/>
               </a:ext>
             </a:extLst>
           </p:cNvPr>
@@ -19645,7 +21949,7 @@
           <p:cNvPr id="25" name="Continue sequentially">
             <a:extLst xmlns:a="http://schemas.openxmlformats.org/drawingml/2006/main">
               <a:ext uri="{FF2B5EF4-FFF2-40B4-BE49-F238E27FC236}">
-                <a16:creationId xmlns:a16="http://schemas.microsoft.com/office/drawing/2014/main" id="{36641305-9214-4D05-BC93-59B1613F5770}"/>
+                <a16:creationId xmlns:a16="http://schemas.microsoft.com/office/drawing/2014/main" id="{AF4F2734-65B0-4059-976D-7F0ACB83AEB9}"/>
               </a:ext>
             </a:extLst>
           </p:cNvPr>
@@ -19801,7 +22105,7 @@
           <p:cNvPr id="26" name="Busy retry retains the same frame">
             <a:extLst xmlns:a="http://schemas.openxmlformats.org/drawingml/2006/main">
               <a:ext uri="{FF2B5EF4-FFF2-40B4-BE49-F238E27FC236}">
-                <a16:creationId xmlns:a16="http://schemas.microsoft.com/office/drawing/2014/main" id="{63D0FC45-BACA-4400-A177-37799D2E2E42}"/>
+                <a16:creationId xmlns:a16="http://schemas.microsoft.com/office/drawing/2014/main" id="{362E3AA5-D152-49C7-805C-DDEF361E03D6}"/>
               </a:ext>
             </a:extLst>
           </p:cNvPr>
@@ -19957,7 +22261,7 @@
           <p:cNvPr id="29" name="Complete coverage can run slower than playback. A ">
             <a:extLst xmlns:a="http://schemas.openxmlformats.org/drawingml/2006/main">
               <a:ext uri="{FF2B5EF4-FFF2-40B4-BE49-F238E27FC236}">
-                <a16:creationId xmlns:a16="http://schemas.microsoft.com/office/drawing/2014/main" id="{67475F6D-8528-439D-B915-57B4D05D6F26}"/>
+                <a16:creationId xmlns:a16="http://schemas.microsoft.com/office/drawing/2014/main" id="{6A66C075-810D-47CE-91DF-0D3E15B56862}"/>
               </a:ext>
             </a:extLst>
           </p:cNvPr>
@@ -20111,7 +22415,7 @@
     </p:spTree>
     <p:extLst>
       <p:ext uri="{BB962C8B-B14F-4D97-AF65-F5344CB8AC3E}">
-        <p14:creationId xmlns:p14="http://schemas.microsoft.com/office/powerpoint/2010/main" val="989280736"/>
+        <p14:creationId xmlns:p14="http://schemas.microsoft.com/office/powerpoint/2010/main" val="749739739"/>
       </p:ext>
     </p:extLst>
   </p:cSld>
@@ -20142,7 +22446,7 @@
           <p:cNvPr id="8" name="THE LEARNING WORKFLOW">
             <a:extLst xmlns:a="http://schemas.openxmlformats.org/drawingml/2006/main">
               <a:ext uri="{FF2B5EF4-FFF2-40B4-BE49-F238E27FC236}">
-                <a16:creationId xmlns:a16="http://schemas.microsoft.com/office/drawing/2014/main" id="{FD61FE00-CC32-4DAB-9FFD-F6E3CA34B9F1}"/>
+                <a16:creationId xmlns:a16="http://schemas.microsoft.com/office/drawing/2014/main" id="{828178B9-9A7F-426A-9281-9747C6FB58AC}"/>
               </a:ext>
             </a:extLst>
           </p:cNvPr>
@@ -20298,7 +22602,7 @@
           <p:cNvPr id="2" name="How human review improves later models">
             <a:extLst xmlns:a="http://schemas.openxmlformats.org/drawingml/2006/main">
               <a:ext uri="{FF2B5EF4-FFF2-40B4-BE49-F238E27FC236}">
-                <a16:creationId xmlns:a16="http://schemas.microsoft.com/office/drawing/2014/main" id="{5758800C-308B-4B16-AF0C-49AC23E21B35}"/>
+                <a16:creationId xmlns:a16="http://schemas.microsoft.com/office/drawing/2014/main" id="{3F694B54-FB8F-4A49-8197-CD02DEC4C03D}"/>
               </a:ext>
             </a:extLst>
           </p:cNvPr>
@@ -20454,7 +22758,7 @@
           <p:cNvPr id="3" name="RoadScan / AIEP capstone">
             <a:extLst xmlns:a="http://schemas.openxmlformats.org/drawingml/2006/main">
               <a:ext uri="{FF2B5EF4-FFF2-40B4-BE49-F238E27FC236}">
-                <a16:creationId xmlns:a16="http://schemas.microsoft.com/office/drawing/2014/main" id="{3BD965CC-CE65-428E-AB5F-20D43B33F933}"/>
+                <a16:creationId xmlns:a16="http://schemas.microsoft.com/office/drawing/2014/main" id="{F8A927DD-D7C4-4A5B-AF8A-AD523054B552}"/>
               </a:ext>
             </a:extLst>
           </p:cNvPr>
@@ -20610,7 +22914,7 @@
           <p:cNvPr id="4" name="06">
             <a:extLst xmlns:a="http://schemas.openxmlformats.org/drawingml/2006/main">
               <a:ext uri="{FF2B5EF4-FFF2-40B4-BE49-F238E27FC236}">
-                <a16:creationId xmlns:a16="http://schemas.microsoft.com/office/drawing/2014/main" id="{F6329D1E-6EED-4ACD-AC5A-B62FD4CBBBB4}"/>
+                <a16:creationId xmlns:a16="http://schemas.microsoft.com/office/drawing/2014/main" id="{91A1BF52-322E-4070-8F1B-E59142E31B13}"/>
               </a:ext>
             </a:extLst>
           </p:cNvPr>
@@ -20766,7 +23070,7 @@
           <p:cNvPr id="5" name="">
             <a:extLst xmlns:a="http://schemas.openxmlformats.org/drawingml/2006/main">
               <a:ext uri="{FF2B5EF4-FFF2-40B4-BE49-F238E27FC236}">
-                <a16:creationId xmlns:a16="http://schemas.microsoft.com/office/drawing/2014/main" id="{8F744163-4666-462B-9072-9A3B141891BA}"/>
+                <a16:creationId xmlns:a16="http://schemas.microsoft.com/office/drawing/2014/main" id="{62521FAF-3975-4636-848D-4EC5AD577799}"/>
               </a:ext>
             </a:extLst>
           </p:cNvPr>
@@ -20776,7 +23080,7 @@
           <p:nvPr/>
         </p:nvPicPr>
         <p:blipFill>
-          <a:blip xmlns:r="http://schemas.openxmlformats.org/officeDocument/2006/relationships" xmlns:a="http://schemas.openxmlformats.org/drawingml/2006/main" r:embed="Re96565ee5dbb416f"/>
+          <a:blip xmlns:r="http://schemas.openxmlformats.org/officeDocument/2006/relationships" xmlns:a="http://schemas.openxmlformats.org/drawingml/2006/main" r:embed="Rd8ba9a77ab304527"/>
           <a:srcRect xmlns:a="http://schemas.openxmlformats.org/drawingml/2006/main" l="17700" t="29000" r="1700" b="28000"/>
           <a:stretch xmlns:a="http://schemas.openxmlformats.org/drawingml/2006/main"/>
         </p:blipFill>
@@ -20795,7 +23099,7 @@
           <p:cNvPr id="6" name="Saved corrections leave the active model unchanged">
             <a:extLst xmlns:a="http://schemas.openxmlformats.org/drawingml/2006/main">
               <a:ext uri="{FF2B5EF4-FFF2-40B4-BE49-F238E27FC236}">
-                <a16:creationId xmlns:a16="http://schemas.microsoft.com/office/drawing/2014/main" id="{17B2D8FE-1F62-4956-8C2E-29822CD9FFF6}"/>
+                <a16:creationId xmlns:a16="http://schemas.microsoft.com/office/drawing/2014/main" id="{CD5DD9B6-2999-4E1D-8FF2-A75BB16F4766}"/>
               </a:ext>
             </a:extLst>
           </p:cNvPr>
@@ -20951,7 +23255,7 @@
           <p:cNvPr id="7" name="Approved export   /   separate training   /   held">
             <a:extLst xmlns:a="http://schemas.openxmlformats.org/drawingml/2006/main">
               <a:ext uri="{FF2B5EF4-FFF2-40B4-BE49-F238E27FC236}">
-                <a16:creationId xmlns:a16="http://schemas.microsoft.com/office/drawing/2014/main" id="{2BAC8634-1591-469F-8FCD-7CB3ABE1B452}"/>
+                <a16:creationId xmlns:a16="http://schemas.microsoft.com/office/drawing/2014/main" id="{2A537069-2F1E-4738-A7D9-16BC4359CE89}"/>
               </a:ext>
             </a:extLst>
           </p:cNvPr>
@@ -21105,7 +23409,7 @@
     </p:spTree>
     <p:extLst>
       <p:ext uri="{BB962C8B-B14F-4D97-AF65-F5344CB8AC3E}">
-        <p14:creationId xmlns:p14="http://schemas.microsoft.com/office/powerpoint/2010/main" val="760099699"/>
+        <p14:creationId xmlns:p14="http://schemas.microsoft.com/office/powerpoint/2010/main" val="342570890"/>
       </p:ext>
     </p:extLst>
   </p:cSld>
@@ -21136,7 +23440,7 @@
           <p:cNvPr id="15" name="RESULTS AND CONCLUSION">
             <a:extLst xmlns:a="http://schemas.openxmlformats.org/drawingml/2006/main">
               <a:ext uri="{FF2B5EF4-FFF2-40B4-BE49-F238E27FC236}">
-                <a16:creationId xmlns:a16="http://schemas.microsoft.com/office/drawing/2014/main" id="{46BDAA66-8DEE-4C05-8722-7CA6CA727938}"/>
+                <a16:creationId xmlns:a16="http://schemas.microsoft.com/office/drawing/2014/main" id="{0B2ED3EE-62A8-4C2B-8A02-0F34561BAB52}"/>
               </a:ext>
             </a:extLst>
           </p:cNvPr>
@@ -21292,7 +23596,7 @@
           <p:cNvPr id="2" name="A working system with clear next tests">
             <a:extLst xmlns:a="http://schemas.openxmlformats.org/drawingml/2006/main">
               <a:ext uri="{FF2B5EF4-FFF2-40B4-BE49-F238E27FC236}">
-                <a16:creationId xmlns:a16="http://schemas.microsoft.com/office/drawing/2014/main" id="{2C1234E3-3479-4EAA-912B-1FB440382880}"/>
+                <a16:creationId xmlns:a16="http://schemas.microsoft.com/office/drawing/2014/main" id="{B273D7D4-213A-48EA-807A-FA8757734CCF}"/>
               </a:ext>
             </a:extLst>
           </p:cNvPr>
@@ -21448,7 +23752,7 @@
           <p:cNvPr id="3" name="RoadScan / AIEP capstone">
             <a:extLst xmlns:a="http://schemas.openxmlformats.org/drawingml/2006/main">
               <a:ext uri="{FF2B5EF4-FFF2-40B4-BE49-F238E27FC236}">
-                <a16:creationId xmlns:a16="http://schemas.microsoft.com/office/drawing/2014/main" id="{A59251AE-CE1D-4CCE-9B53-D5679DD2B9C5}"/>
+                <a16:creationId xmlns:a16="http://schemas.microsoft.com/office/drawing/2014/main" id="{24E54020-DE36-4387-86DB-96D44FE52122}"/>
               </a:ext>
             </a:extLst>
           </p:cNvPr>
@@ -21604,7 +23908,7 @@
           <p:cNvPr id="4" name="07">
             <a:extLst xmlns:a="http://schemas.openxmlformats.org/drawingml/2006/main">
               <a:ext uri="{FF2B5EF4-FFF2-40B4-BE49-F238E27FC236}">
-                <a16:creationId xmlns:a16="http://schemas.microsoft.com/office/drawing/2014/main" id="{AA4CB130-791B-4E96-9FCA-E61A602770CE}"/>
+                <a16:creationId xmlns:a16="http://schemas.microsoft.com/office/drawing/2014/main" id="{72D6D1F8-690E-41DE-A699-ED01996F4277}"/>
               </a:ext>
             </a:extLst>
           </p:cNvPr>
@@ -21760,7 +24064,7 @@
           <p:cNvPr id="5" name="221">
             <a:extLst xmlns:a="http://schemas.openxmlformats.org/drawingml/2006/main">
               <a:ext uri="{FF2B5EF4-FFF2-40B4-BE49-F238E27FC236}">
-                <a16:creationId xmlns:a16="http://schemas.microsoft.com/office/drawing/2014/main" id="{42E47B7F-21DB-4337-B5A7-60F24F7F88D1}"/>
+                <a16:creationId xmlns:a16="http://schemas.microsoft.com/office/drawing/2014/main" id="{B360466D-61B0-48D2-96B0-E4A1814B2535}"/>
               </a:ext>
             </a:extLst>
           </p:cNvPr>
@@ -21916,7 +24220,7 @@
           <p:cNvPr id="6" name="backend tests">
             <a:extLst xmlns:a="http://schemas.openxmlformats.org/drawingml/2006/main">
               <a:ext uri="{FF2B5EF4-FFF2-40B4-BE49-F238E27FC236}">
-                <a16:creationId xmlns:a16="http://schemas.microsoft.com/office/drawing/2014/main" id="{6949E41B-2096-48B8-A4C6-4A5E0DA56518}"/>
+                <a16:creationId xmlns:a16="http://schemas.microsoft.com/office/drawing/2014/main" id="{C97810CA-184D-4F73-8BDA-80DCA1D88FB8}"/>
               </a:ext>
             </a:extLst>
           </p:cNvPr>
@@ -22072,7 +24376,7 @@
           <p:cNvPr id="7" name="24">
             <a:extLst xmlns:a="http://schemas.openxmlformats.org/drawingml/2006/main">
               <a:ext uri="{FF2B5EF4-FFF2-40B4-BE49-F238E27FC236}">
-                <a16:creationId xmlns:a16="http://schemas.microsoft.com/office/drawing/2014/main" id="{2C92CDC2-0A18-4BF0-AFE4-E68E6AA86A12}"/>
+                <a16:creationId xmlns:a16="http://schemas.microsoft.com/office/drawing/2014/main" id="{54D1B746-FADE-467E-A834-C98574402521}"/>
               </a:ext>
             </a:extLst>
           </p:cNvPr>
@@ -22228,7 +24532,7 @@
           <p:cNvPr id="8" name="frontend tests">
             <a:extLst xmlns:a="http://schemas.openxmlformats.org/drawingml/2006/main">
               <a:ext uri="{FF2B5EF4-FFF2-40B4-BE49-F238E27FC236}">
-                <a16:creationId xmlns:a16="http://schemas.microsoft.com/office/drawing/2014/main" id="{20498B3B-4676-4B67-9270-F1A0E840CE31}"/>
+                <a16:creationId xmlns:a16="http://schemas.microsoft.com/office/drawing/2014/main" id="{306DEFA8-F7FD-4AD7-A0DB-29469303F6B2}"/>
               </a:ext>
             </a:extLst>
           </p:cNvPr>
@@ -22384,7 +24688,7 @@
           <p:cNvPr id="9" name="67">
             <a:extLst xmlns:a="http://schemas.openxmlformats.org/drawingml/2006/main">
               <a:ext uri="{FF2B5EF4-FFF2-40B4-BE49-F238E27FC236}">
-                <a16:creationId xmlns:a16="http://schemas.microsoft.com/office/drawing/2014/main" id="{EA49CBD4-FBDC-462E-9521-1612608DA981}"/>
+                <a16:creationId xmlns:a16="http://schemas.microsoft.com/office/drawing/2014/main" id="{ECE6BA10-87CF-4CB7-97E0-13DC2962B7AB}"/>
               </a:ext>
             </a:extLst>
           </p:cNvPr>
@@ -22540,7 +24844,7 @@
           <p:cNvPr id="10" name="browser checks">
             <a:extLst xmlns:a="http://schemas.openxmlformats.org/drawingml/2006/main">
               <a:ext uri="{FF2B5EF4-FFF2-40B4-BE49-F238E27FC236}">
-                <a16:creationId xmlns:a16="http://schemas.microsoft.com/office/drawing/2014/main" id="{B2A1C478-AFC1-47AB-BC44-C3B357B538F7}"/>
+                <a16:creationId xmlns:a16="http://schemas.microsoft.com/office/drawing/2014/main" id="{CD1A8CFF-DEB7-4B7B-B16D-E81280778DDF}"/>
               </a:ext>
             </a:extLst>
           </p:cNvPr>
@@ -22696,7 +25000,7 @@
           <p:cNvPr id="11" name="Recorded release checks. One optional backend test">
             <a:extLst xmlns:a="http://schemas.openxmlformats.org/drawingml/2006/main">
               <a:ext uri="{FF2B5EF4-FFF2-40B4-BE49-F238E27FC236}">
-                <a16:creationId xmlns:a16="http://schemas.microsoft.com/office/drawing/2014/main" id="{F234B881-3F94-403E-AB89-15C0AC4E1741}"/>
+                <a16:creationId xmlns:a16="http://schemas.microsoft.com/office/drawing/2014/main" id="{65375E8C-DE58-45A8-9118-8B76E7CC82E7}"/>
               </a:ext>
             </a:extLst>
           </p:cNvPr>
@@ -22852,7 +25156,7 @@
           <p:cNvPr id="12" name="Next evidence">
             <a:extLst xmlns:a="http://schemas.openxmlformats.org/drawingml/2006/main">
               <a:ext uri="{FF2B5EF4-FFF2-40B4-BE49-F238E27FC236}">
-                <a16:creationId xmlns:a16="http://schemas.microsoft.com/office/drawing/2014/main" id="{27584D7C-E790-453D-9599-BEE12365CF7E}"/>
+                <a16:creationId xmlns:a16="http://schemas.microsoft.com/office/drawing/2014/main" id="{7C4155EF-E7F8-44CC-8B7E-7032B165A946}"/>
               </a:ext>
             </a:extLst>
           </p:cNvPr>
@@ -23008,7 +25312,7 @@
           <p:cNvPr id="13" name="Labeled Saudi road images and real repeat-damage p">
             <a:extLst xmlns:a="http://schemas.openxmlformats.org/drawingml/2006/main">
               <a:ext uri="{FF2B5EF4-FFF2-40B4-BE49-F238E27FC236}">
-                <a16:creationId xmlns:a16="http://schemas.microsoft.com/office/drawing/2014/main" id="{A67A789D-332A-4223-8D79-836EDB99BB88}"/>
+                <a16:creationId xmlns:a16="http://schemas.microsoft.com/office/drawing/2014/main" id="{DE80EE18-429E-4FF9-AD13-69CED62C6AE3}"/>
               </a:ext>
             </a:extLst>
           </p:cNvPr>
@@ -23184,10 +25488,10 @@
       </p:sp>
       <p:sp>
         <p:nvSpPr>
-          <p:cNvPr id="14" name="Code, reports and baseline resources: github.com/F">
+          <p:cNvPr id="14" name="Code, reports and model downloads: github.com/Fera">
             <a:extLst xmlns:a="http://schemas.openxmlformats.org/drawingml/2006/main">
               <a:ext uri="{FF2B5EF4-FFF2-40B4-BE49-F238E27FC236}">
-                <a16:creationId xmlns:a16="http://schemas.microsoft.com/office/drawing/2014/main" id="{D17F491D-0040-4E88-989E-F17A4A07579F}"/>
+                <a16:creationId xmlns:a16="http://schemas.microsoft.com/office/drawing/2014/main" id="{6C2007D7-0A98-40B6-8EBA-2713C97B7FBC}"/>
               </a:ext>
             </a:extLst>
           </p:cNvPr>
@@ -23333,7 +25637,7 @@
                 <a:ea typeface="Arial"/>
                 <a:cs typeface="Arial"/>
               </a:rPr>
-              <a:t>Code, reports and baseline resources: github.com/Feras-MQ/RoadScan</a:t>
+              <a:t>Code, reports and model downloads: github.com/Feras-MQ/RoadScan</a:t>
             </a:r>
           </a:p>
         </p:txBody>
@@ -23341,7 +25645,7 @@
     </p:spTree>
     <p:extLst>
       <p:ext uri="{BB962C8B-B14F-4D97-AF65-F5344CB8AC3E}">
-        <p14:creationId xmlns:p14="http://schemas.microsoft.com/office/powerpoint/2010/main" val="1787315961"/>
+        <p14:creationId xmlns:p14="http://schemas.microsoft.com/office/powerpoint/2010/main" val="2023629183"/>
       </p:ext>
     </p:extLst>
   </p:cSld>
@@ -23372,7 +25676,7 @@
           <p:cNvPr id="7" name="APPENDIX A / MODEL INVENTORY">
             <a:extLst xmlns:a="http://schemas.openxmlformats.org/drawingml/2006/main">
               <a:ext uri="{FF2B5EF4-FFF2-40B4-BE49-F238E27FC236}">
-                <a16:creationId xmlns:a16="http://schemas.microsoft.com/office/drawing/2014/main" id="{26AFAE1A-0C4F-4842-B25A-B3F9DEC57AA0}"/>
+                <a16:creationId xmlns:a16="http://schemas.microsoft.com/office/drawing/2014/main" id="{D662D8D6-086A-434B-BCB6-80EFB99446BA}"/>
               </a:ext>
             </a:extLst>
           </p:cNvPr>
@@ -23525,10 +25829,10 @@
       </p:sp>
       <p:sp>
         <p:nvSpPr>
-          <p:cNvPr id="2" name="What the 19 retained weights contain">
+          <p:cNvPr id="2" name="The current 22-file model inventory">
             <a:extLst xmlns:a="http://schemas.openxmlformats.org/drawingml/2006/main">
               <a:ext uri="{FF2B5EF4-FFF2-40B4-BE49-F238E27FC236}">
-                <a16:creationId xmlns:a16="http://schemas.microsoft.com/office/drawing/2014/main" id="{C4E5D901-3508-4921-97A0-0C2403654649}"/>
+                <a16:creationId xmlns:a16="http://schemas.microsoft.com/office/drawing/2014/main" id="{ADCD8FDF-AF5E-4484-8631-86576958F731}"/>
               </a:ext>
             </a:extLst>
           </p:cNvPr>
@@ -23674,7 +25978,7 @@
                 <a:ea typeface="Arial"/>
                 <a:cs typeface="Arial"/>
               </a:rPr>
-              <a:t>What the 19 retained weights contain</a:t>
+              <a:t>The current 22-file model inventory</a:t>
             </a:r>
           </a:p>
         </p:txBody>
@@ -23684,7 +25988,7 @@
           <p:cNvPr id="3" name="RoadScan / AIEP capstone">
             <a:extLst xmlns:a="http://schemas.openxmlformats.org/drawingml/2006/main">
               <a:ext uri="{FF2B5EF4-FFF2-40B4-BE49-F238E27FC236}">
-                <a16:creationId xmlns:a16="http://schemas.microsoft.com/office/drawing/2014/main" id="{9B6CC860-2E9D-42E8-BB94-8668DCFD22E4}"/>
+                <a16:creationId xmlns:a16="http://schemas.microsoft.com/office/drawing/2014/main" id="{CA586D5C-33CF-4A28-BA34-E0E598272510}"/>
               </a:ext>
             </a:extLst>
           </p:cNvPr>
@@ -23840,7 +26144,7 @@
           <p:cNvPr id="4" name="08">
             <a:extLst xmlns:a="http://schemas.openxmlformats.org/drawingml/2006/main">
               <a:ext uri="{FF2B5EF4-FFF2-40B4-BE49-F238E27FC236}">
-                <a16:creationId xmlns:a16="http://schemas.microsoft.com/office/drawing/2014/main" id="{B36FAE4F-A05B-463E-B71A-7923938B21FE}"/>
+                <a16:creationId xmlns:a16="http://schemas.microsoft.com/office/drawing/2014/main" id="{D10171D1-64AE-4503-80B4-90846A8FF9F5}"/>
               </a:ext>
             </a:extLst>
           </p:cNvPr>
@@ -23996,7 +26300,7 @@
           <p:cNvPr id="5" name="">
             <a:extLst xmlns:a="http://schemas.openxmlformats.org/drawingml/2006/main">
               <a:ext uri="{FF2B5EF4-FFF2-40B4-BE49-F238E27FC236}">
-                <a16:creationId xmlns:a16="http://schemas.microsoft.com/office/drawing/2014/main" id="{30521578-1F10-41B3-9C4F-EFDF8080D35E}"/>
+                <a16:creationId xmlns:a16="http://schemas.microsoft.com/office/drawing/2014/main" id="{A7191742-EC7C-452E-853D-A4DBBEE919A1}"/>
               </a:ext>
             </a:extLst>
           </p:cNvPr>
@@ -24207,7 +26511,7 @@
                           <a:ea typeface="Arial"/>
                           <a:cs typeface="Arial"/>
                         </a:rPr>
-                        <a:t>16</a:t>
+                        <a:t>19</a:t>
                       </a:r>
                     </a:p>
                   </a:txBody>
@@ -24620,10 +26924,10 @@
       </p:graphicFrame>
       <p:sp>
         <p:nvSpPr>
-          <p:cNvPr id="6" name="Training records differ by checkpoint. “19 models”">
+          <p:cNvPr id="6" name="Downloads: 11 road detectors + DINOv2. Nine files ">
             <a:extLst xmlns:a="http://schemas.openxmlformats.org/drawingml/2006/main">
               <a:ext uri="{FF2B5EF4-FFF2-40B4-BE49-F238E27FC236}">
-                <a16:creationId xmlns:a16="http://schemas.microsoft.com/office/drawing/2014/main" id="{6E0E5FA7-691E-4D71-AD35-033C478083B5}"/>
+                <a16:creationId xmlns:a16="http://schemas.microsoft.com/office/drawing/2014/main" id="{5060CE38-81A1-40AD-B59D-20D7C81F2124}"/>
               </a:ext>
             </a:extLst>
           </p:cNvPr>
@@ -24634,8 +26938,8 @@
         </p:nvSpPr>
         <p:spPr>
           <a:xfrm xmlns:a="http://schemas.openxmlformats.org/drawingml/2006/main">
-            <a:off x="552450" y="5514975"/>
-            <a:ext cx="11001375" cy="600075"/>
+            <a:off x="552450" y="5400675"/>
+            <a:ext cx="11001375" cy="809625"/>
           </a:xfrm>
           <a:prstGeom xmlns:a="http://schemas.openxmlformats.org/drawingml/2006/main" prst="rect">
             <a:avLst/>
@@ -24649,7 +26953,7 @@
           <a:bodyPr xmlns:a="http://schemas.openxmlformats.org/drawingml/2006/main" lIns="0" tIns="0" rIns="0" bIns="0"/>
           <a:lstStyle xmlns:a="http://schemas.openxmlformats.org/drawingml/2006/main">
             <a:defPPr>
-              <a:defRPr sz="1875" b="0">
+              <a:defRPr sz="1800" b="0">
                 <a:solidFill>
                   <a:srgbClr val="A5BDC6"/>
                 </a:solidFill>
@@ -24659,7 +26963,7 @@
               </a:defRPr>
             </a:defPPr>
             <a:lvl1pPr>
-              <a:defRPr sz="1875" b="0">
+              <a:defRPr sz="1800" b="0">
                 <a:solidFill>
                   <a:srgbClr val="A5BDC6"/>
                 </a:solidFill>
@@ -24669,7 +26973,7 @@
               </a:defRPr>
             </a:lvl1pPr>
             <a:lvl2pPr>
-              <a:defRPr sz="1875" b="0">
+              <a:defRPr sz="1800" b="0">
                 <a:solidFill>
                   <a:srgbClr val="A5BDC6"/>
                 </a:solidFill>
@@ -24679,7 +26983,7 @@
               </a:defRPr>
             </a:lvl2pPr>
             <a:lvl3pPr>
-              <a:defRPr sz="1875" b="0">
+              <a:defRPr sz="1800" b="0">
                 <a:solidFill>
                   <a:srgbClr val="A5BDC6"/>
                 </a:solidFill>
@@ -24689,7 +26993,7 @@
               </a:defRPr>
             </a:lvl3pPr>
             <a:lvl4pPr>
-              <a:defRPr sz="1875" b="0">
+              <a:defRPr sz="1800" b="0">
                 <a:solidFill>
                   <a:srgbClr val="A5BDC6"/>
                 </a:solidFill>
@@ -24699,7 +27003,7 @@
               </a:defRPr>
             </a:lvl4pPr>
             <a:lvl5pPr>
-              <a:defRPr sz="1875" b="0">
+              <a:defRPr sz="1800" b="0">
                 <a:solidFill>
                   <a:srgbClr val="A5BDC6"/>
                 </a:solidFill>
@@ -24709,7 +27013,7 @@
               </a:defRPr>
             </a:lvl5pPr>
             <a:lvl6pPr>
-              <a:defRPr sz="1875" b="0">
+              <a:defRPr sz="1800" b="0">
                 <a:solidFill>
                   <a:srgbClr val="A5BDC6"/>
                 </a:solidFill>
@@ -24719,7 +27023,7 @@
               </a:defRPr>
             </a:lvl6pPr>
             <a:lvl7pPr>
-              <a:defRPr sz="1875" b="0">
+              <a:defRPr sz="1800" b="0">
                 <a:solidFill>
                   <a:srgbClr val="A5BDC6"/>
                 </a:solidFill>
@@ -24729,7 +27033,7 @@
               </a:defRPr>
             </a:lvl7pPr>
             <a:lvl8pPr>
-              <a:defRPr sz="1875" b="0">
+              <a:defRPr sz="1800" b="0">
                 <a:solidFill>
                   <a:srgbClr val="A5BDC6"/>
                 </a:solidFill>
@@ -24739,7 +27043,7 @@
               </a:defRPr>
             </a:lvl8pPr>
             <a:lvl9pPr>
-              <a:defRPr sz="1875" b="0">
+              <a:defRPr sz="1800" b="0">
                 <a:solidFill>
                   <a:srgbClr val="A5BDC6"/>
                 </a:solidFill>
@@ -24751,7 +27055,7 @@
           </a:lstStyle>
           <a:p xmlns:a="http://schemas.openxmlformats.org/drawingml/2006/main">
             <a:pPr>
-              <a:defRPr sz="1875" b="0">
+              <a:defRPr sz="1800" b="0">
                 <a:solidFill>
                   <a:srgbClr val="A5BDC6"/>
                 </a:solidFill>
@@ -24761,7 +27065,7 @@
               </a:defRPr>
             </a:pPr>
             <a:r>
-              <a:rPr sz="1875" b="0">
+              <a:rPr sz="1800" b="0">
                 <a:solidFill>
                   <a:srgbClr val="A5BDC6"/>
                 </a:solidFill>
@@ -24769,7 +27073,30 @@
                 <a:ea typeface="Arial"/>
                 <a:cs typeface="Arial"/>
               </a:rPr>
-              <a:t>Training records differ by checkpoint. “19 models” does not mean 19 equivalent detectors.</a:t>
+              <a:t>Downloads: 11 road detectors + DINOv2. Nine files remain on hold.</a:t>
+            </a:r>
+          </a:p>
+          <a:p xmlns:a="http://schemas.openxmlformats.org/drawingml/2006/main">
+            <a:pPr>
+              <a:defRPr sz="1800" b="0">
+                <a:solidFill>
+                  <a:srgbClr val="A5BDC6"/>
+                </a:solidFill>
+                <a:latin typeface="Arial"/>
+                <a:ea typeface="Arial"/>
+                <a:cs typeface="Arial"/>
+              </a:defRPr>
+            </a:pPr>
+            <a:r>
+              <a:rPr sz="1800" b="0">
+                <a:solidFill>
+                  <a:srgbClr val="A5BDC6"/>
+                </a:solidFill>
+                <a:latin typeface="Arial"/>
+                <a:ea typeface="Arial"/>
+                <a:cs typeface="Arial"/>
+              </a:rPr>
+              <a:t>The stock initializer links to its official upstream release.</a:t>
             </a:r>
           </a:p>
         </p:txBody>
@@ -24777,7 +27104,7 @@
     </p:spTree>
     <p:extLst>
       <p:ext uri="{BB962C8B-B14F-4D97-AF65-F5344CB8AC3E}">
-        <p14:creationId xmlns:p14="http://schemas.microsoft.com/office/powerpoint/2010/main" val="1795691096"/>
+        <p14:creationId xmlns:p14="http://schemas.microsoft.com/office/powerpoint/2010/main" val="361933298"/>
       </p:ext>
     </p:extLst>
   </p:cSld>
@@ -24808,7 +27135,7 @@
           <p:cNvPr id="13" name="APPENDIX B / IMPLEMENTATION EVIDENCE">
             <a:extLst xmlns:a="http://schemas.openxmlformats.org/drawingml/2006/main">
               <a:ext uri="{FF2B5EF4-FFF2-40B4-BE49-F238E27FC236}">
-                <a16:creationId xmlns:a16="http://schemas.microsoft.com/office/drawing/2014/main" id="{09DE3CF6-58EE-433B-9F13-378D2210C5E1}"/>
+                <a16:creationId xmlns:a16="http://schemas.microsoft.com/office/drawing/2014/main" id="{CF7C0A5B-F062-47D4-BB60-974641CC48EB}"/>
               </a:ext>
             </a:extLst>
           </p:cNvPr>
@@ -24964,7 +27291,7 @@
           <p:cNvPr id="2" name="Two safeguards in the actual code">
             <a:extLst xmlns:a="http://schemas.openxmlformats.org/drawingml/2006/main">
               <a:ext uri="{FF2B5EF4-FFF2-40B4-BE49-F238E27FC236}">
-                <a16:creationId xmlns:a16="http://schemas.microsoft.com/office/drawing/2014/main" id="{5EDF698D-305E-4D5F-BE39-A895DBEFC2DE}"/>
+                <a16:creationId xmlns:a16="http://schemas.microsoft.com/office/drawing/2014/main" id="{25B52534-CAF9-41AC-B8BF-46EABD006A94}"/>
               </a:ext>
             </a:extLst>
           </p:cNvPr>
@@ -25120,7 +27447,7 @@
           <p:cNvPr id="3" name="RoadScan / AIEP capstone">
             <a:extLst xmlns:a="http://schemas.openxmlformats.org/drawingml/2006/main">
               <a:ext uri="{FF2B5EF4-FFF2-40B4-BE49-F238E27FC236}">
-                <a16:creationId xmlns:a16="http://schemas.microsoft.com/office/drawing/2014/main" id="{06F8431B-C027-4EB5-A582-D75671DD7D5F}"/>
+                <a16:creationId xmlns:a16="http://schemas.microsoft.com/office/drawing/2014/main" id="{79667AA3-A268-4618-9D1A-EC119F2919F8}"/>
               </a:ext>
             </a:extLst>
           </p:cNvPr>
@@ -25276,7 +27603,7 @@
           <p:cNvPr id="4" name="09">
             <a:extLst xmlns:a="http://schemas.openxmlformats.org/drawingml/2006/main">
               <a:ext uri="{FF2B5EF4-FFF2-40B4-BE49-F238E27FC236}">
-                <a16:creationId xmlns:a16="http://schemas.microsoft.com/office/drawing/2014/main" id="{284B3CE9-F62B-4796-81F8-A16E68410127}"/>
+                <a16:creationId xmlns:a16="http://schemas.microsoft.com/office/drawing/2014/main" id="{C1E0FA4E-F259-455E-8297-8E84DF41C787}"/>
               </a:ext>
             </a:extLst>
           </p:cNvPr>
@@ -25432,7 +27759,7 @@
           <p:cNvPr id="5" name="Temporary recognition">
             <a:extLst xmlns:a="http://schemas.openxmlformats.org/drawingml/2006/main">
               <a:ext uri="{FF2B5EF4-FFF2-40B4-BE49-F238E27FC236}">
-                <a16:creationId xmlns:a16="http://schemas.microsoft.com/office/drawing/2014/main" id="{E22573FF-6584-479E-89EF-C07C63B839B8}"/>
+                <a16:creationId xmlns:a16="http://schemas.microsoft.com/office/drawing/2014/main" id="{F97BBE04-75FF-4C14-8D4E-384DF95EDB38}"/>
               </a:ext>
             </a:extLst>
           </p:cNvPr>
@@ -25588,7 +27915,7 @@
           <p:cNvPr id="6" name="roadscan/api.py:139–148">
             <a:extLst xmlns:a="http://schemas.openxmlformats.org/drawingml/2006/main">
               <a:ext uri="{FF2B5EF4-FFF2-40B4-BE49-F238E27FC236}">
-                <a16:creationId xmlns:a16="http://schemas.microsoft.com/office/drawing/2014/main" id="{E2B2D81C-5138-438F-B6B1-860785E69B0D}"/>
+                <a16:creationId xmlns:a16="http://schemas.microsoft.com/office/drawing/2014/main" id="{CB789421-F91E-4924-9356-600984B7A83A}"/>
               </a:ext>
             </a:extLst>
           </p:cNvPr>
@@ -25744,7 +28071,7 @@
           <p:cNvPr id="7" name="raw=await read_bounded(request,2*1024*1024)&#10;image=">
             <a:extLst xmlns:a="http://schemas.openxmlformats.org/drawingml/2006/main">
               <a:ext uri="{FF2B5EF4-FFF2-40B4-BE49-F238E27FC236}">
-                <a16:creationId xmlns:a16="http://schemas.microsoft.com/office/drawing/2014/main" id="{5D9D1290-86F0-4A02-BA89-1688DC48985E}"/>
+                <a16:creationId xmlns:a16="http://schemas.microsoft.com/office/drawing/2014/main" id="{D93AEE4B-3791-4D2E-B1C5-4D27AF62ED4C}"/>
               </a:ext>
             </a:extLst>
           </p:cNvPr>
@@ -26025,7 +28352,7 @@
           <p:cNvPr id="8" name="A model vote stays a draft">
             <a:extLst xmlns:a="http://schemas.openxmlformats.org/drawingml/2006/main">
               <a:ext uri="{FF2B5EF4-FFF2-40B4-BE49-F238E27FC236}">
-                <a16:creationId xmlns:a16="http://schemas.microsoft.com/office/drawing/2014/main" id="{39CF1B74-E941-4A5C-8425-8401F07B670F}"/>
+                <a16:creationId xmlns:a16="http://schemas.microsoft.com/office/drawing/2014/main" id="{48F04728-3078-4CF6-BC64-03DA565BF9D3}"/>
               </a:ext>
             </a:extLst>
           </p:cNvPr>
@@ -26181,7 +28508,7 @@
           <p:cNvPr id="9" name="frontend/src/App.tsx:337">
             <a:extLst xmlns:a="http://schemas.openxmlformats.org/drawingml/2006/main">
               <a:ext uri="{FF2B5EF4-FFF2-40B4-BE49-F238E27FC236}">
-                <a16:creationId xmlns:a16="http://schemas.microsoft.com/office/drawing/2014/main" id="{E00EC902-8AF5-44D0-8CF8-AB064DB8E4C5}"/>
+                <a16:creationId xmlns:a16="http://schemas.microsoft.com/office/drawing/2014/main" id="{9CC80230-ACCF-4239-9FA3-1BCBCAC26F5D}"/>
               </a:ext>
             </a:extLst>
           </p:cNvPr>
@@ -26337,7 +28664,7 @@
           <p:cNvPr id="10" name="setBoxes(value);&#10;setEdited(true);">
             <a:extLst xmlns:a="http://schemas.openxmlformats.org/drawingml/2006/main">
               <a:ext uri="{FF2B5EF4-FFF2-40B4-BE49-F238E27FC236}">
-                <a16:creationId xmlns:a16="http://schemas.microsoft.com/office/drawing/2014/main" id="{26ED1164-536D-439C-A56E-1178B7729C6E}"/>
+                <a16:creationId xmlns:a16="http://schemas.microsoft.com/office/drawing/2014/main" id="{F75CE9E4-4A96-423E-BAA3-F3C310C6662B}"/>
               </a:ext>
             </a:extLst>
           </p:cNvPr>
@@ -26516,7 +28843,7 @@
           <p:cNvPr id="11" name="The interface asks the reviewer&#10;to check every box">
             <a:extLst xmlns:a="http://schemas.openxmlformats.org/drawingml/2006/main">
               <a:ext uri="{FF2B5EF4-FFF2-40B4-BE49-F238E27FC236}">
-                <a16:creationId xmlns:a16="http://schemas.microsoft.com/office/drawing/2014/main" id="{DA47836F-1C9D-4BB4-A8DE-A2F1D66C9D9E}"/>
+                <a16:creationId xmlns:a16="http://schemas.microsoft.com/office/drawing/2014/main" id="{8F196828-76F2-4170-B927-87774827D38C}"/>
               </a:ext>
             </a:extLst>
           </p:cNvPr>
@@ -26695,7 +29022,7 @@
           <p:cNvPr id="12" name="Abbreviated source excerpts. Validation and review">
             <a:extLst xmlns:a="http://schemas.openxmlformats.org/drawingml/2006/main">
               <a:ext uri="{FF2B5EF4-FFF2-40B4-BE49-F238E27FC236}">
-                <a16:creationId xmlns:a16="http://schemas.microsoft.com/office/drawing/2014/main" id="{BAD0A5DF-C090-4A5E-8494-8D9F399143BA}"/>
+                <a16:creationId xmlns:a16="http://schemas.microsoft.com/office/drawing/2014/main" id="{275DFC2B-0047-47D8-B7DF-3A00B57F023F}"/>
               </a:ext>
             </a:extLst>
           </p:cNvPr>
@@ -26849,7 +29176,7 @@
     </p:spTree>
     <p:extLst>
       <p:ext uri="{BB962C8B-B14F-4D97-AF65-F5344CB8AC3E}">
-        <p14:creationId xmlns:p14="http://schemas.microsoft.com/office/powerpoint/2010/main" val="1899383776"/>
+        <p14:creationId xmlns:p14="http://schemas.microsoft.com/office/powerpoint/2010/main" val="874015409"/>
       </p:ext>
     </p:extLst>
   </p:cSld>

</xml_diff>